<commit_message>
Apply design changes to the Japanese version
</commit_message>
<xml_diff>
--- a/Documents/Original/FlexChroma_Tour_Guide_JP.pptx
+++ b/Documents/Original/FlexChroma_Tour_Guide_JP.pptx
@@ -9,8 +9,8 @@
     <p:sldId id="257" r:id="rId3"/>
     <p:sldId id="258" r:id="rId4"/>
     <p:sldId id="259" r:id="rId5"/>
-    <p:sldId id="263" r:id="rId6"/>
-    <p:sldId id="264" r:id="rId7"/>
+    <p:sldId id="260" r:id="rId6"/>
+    <p:sldId id="261" r:id="rId7"/>
     <p:sldId id="262" r:id="rId8"/>
   </p:sldIdLst>
   <p:sldSz cx="6858000" cy="9144000" type="screen4x3"/>
@@ -4438,7 +4438,7 @@
         </p:nvSpPr>
         <p:spPr>
           <a:xfrm>
-            <a:off x="566175" y="3069491"/>
+            <a:off x="566175" y="2883225"/>
             <a:ext cx="204669" cy="204669"/>
           </a:xfrm>
           <a:prstGeom prst="ellipse">
@@ -4484,8 +4484,8 @@
         </p:nvSpPr>
         <p:spPr>
           <a:xfrm>
-            <a:off x="770844" y="3001606"/>
-            <a:ext cx="2055371" cy="400110"/>
+            <a:off x="770844" y="2815340"/>
+            <a:ext cx="1516762" cy="400110"/>
           </a:xfrm>
           <a:prstGeom prst="rect">
             <a:avLst/>
@@ -4503,7 +4503,14 @@
                 <a:latin typeface="IBM Plex Sans JP SemiBold" panose="020B0703050203000203" pitchFamily="50" charset="-128"/>
                 <a:ea typeface="IBM Plex Sans JP SemiBold" panose="020B0703050203000203" pitchFamily="50" charset="-128"/>
               </a:rPr>
-              <a:t>1. Introduction</a:t>
+              <a:t>1. </a:t>
+            </a:r>
+            <a:r>
+              <a:rPr lang="ja-JP" altLang="en-US" sz="2000" dirty="0">
+                <a:latin typeface="IBM Plex Sans JP SemiBold" panose="020B0703050203000203" pitchFamily="50" charset="-128"/>
+                <a:ea typeface="IBM Plex Sans JP SemiBold" panose="020B0703050203000203" pitchFamily="50" charset="-128"/>
+              </a:rPr>
+              <a:t>はじめに</a:t>
             </a:r>
             <a:endParaRPr kumimoji="1" lang="ja-JP" altLang="en-US" sz="2000" b="1" dirty="0">
               <a:latin typeface="IBM Plex Sans JP SemiBold" panose="020B0703050203000203" pitchFamily="50" charset="-128"/>
@@ -4526,8 +4533,8 @@
         </p:nvSpPr>
         <p:spPr>
           <a:xfrm>
-            <a:off x="668508" y="3424546"/>
-            <a:ext cx="5649491" cy="738664"/>
+            <a:off x="668508" y="3238280"/>
+            <a:ext cx="5649491" cy="861774"/>
           </a:xfrm>
           <a:prstGeom prst="rect">
             <a:avLst/>
@@ -4541,21 +4548,32 @@
           <a:lstStyle/>
           <a:p>
             <a:r>
-              <a:rPr lang="en-US" altLang="ja-JP" sz="1050" dirty="0">
-                <a:latin typeface="Segoe UI Semibold" panose="020B0702040204020203" pitchFamily="34" charset="0"/>
+              <a:rPr lang="en-US" altLang="ja-JP" sz="1000" dirty="0">
+                <a:latin typeface="IBM Plex Sans JP" panose="020B0503050203000203" pitchFamily="50" charset="-128"/>
                 <a:ea typeface="IBM Plex Sans JP" panose="020B0503050203000203" pitchFamily="50" charset="-128"/>
                 <a:cs typeface="Segoe UI Semibold" panose="020B0702040204020203" pitchFamily="34" charset="0"/>
               </a:rPr>
               <a:t>FlexChroma™</a:t>
             </a:r>
             <a:r>
-              <a:rPr lang="en-US" altLang="ja-JP" sz="1050" dirty="0">
-                <a:latin typeface="IBM Plex Sans JP" panose="020B0503050203000203" pitchFamily="50" charset="-128"/>
-                <a:ea typeface="IBM Plex Sans JP" panose="020B0503050203000203" pitchFamily="50" charset="-128"/>
-              </a:rPr>
-              <a:t> is a set of models designed to create filament itself by combining commercially available filaments. It consists of multiple Series, each designed for a different purpose. Within each Series, multiple Models are provided, along with different Profiles and Plates depending on size and usage.</a:t>
-            </a:r>
-            <a:endParaRPr kumimoji="1" lang="ja-JP" altLang="en-US" sz="1050" b="1" dirty="0">
+              <a:rPr lang="ja-JP" altLang="ja-JP" sz="1000" dirty="0">
+                <a:latin typeface="IBM Plex Sans JP" panose="020B0503050203000203" pitchFamily="50" charset="-128"/>
+                <a:ea typeface="IBM Plex Sans JP" panose="020B0503050203000203" pitchFamily="50" charset="-128"/>
+              </a:rPr>
+              <a:t>は、市販のフィラメントを組み合わせて「フィラメントそのもの」を生み出すためのモデルです。</a:t>
+            </a:r>
+          </a:p>
+          <a:p>
+            <a:r>
+              <a:rPr lang="ja-JP" altLang="ja-JP" sz="1000" dirty="0">
+                <a:latin typeface="IBM Plex Sans JP" panose="020B0503050203000203" pitchFamily="50" charset="-128"/>
+                <a:ea typeface="IBM Plex Sans JP" panose="020B0503050203000203" pitchFamily="50" charset="-128"/>
+              </a:rPr>
+              <a:t>様々な目的のシリーズから構成されており、各シリーズにはサイズなどの違いによってモデル、プロファイル、プレートごとに異なるフィラメントモデルを提供します。</a:t>
+            </a:r>
+          </a:p>
+          <a:p>
+            <a:endParaRPr kumimoji="1" lang="ja-JP" altLang="en-US" sz="1000" b="1" dirty="0">
               <a:latin typeface="IBM Plex Sans JP" panose="020B0503050203000203" pitchFamily="50" charset="-128"/>
               <a:ea typeface="IBM Plex Sans JP" panose="020B0503050203000203" pitchFamily="50" charset="-128"/>
             </a:endParaRPr>
@@ -4576,7 +4594,7 @@
         </p:nvSpPr>
         <p:spPr>
           <a:xfrm>
-            <a:off x="566175" y="4562351"/>
+            <a:off x="566175" y="4203603"/>
             <a:ext cx="204669" cy="204669"/>
           </a:xfrm>
           <a:prstGeom prst="ellipse">
@@ -4622,8 +4640,8 @@
         </p:nvSpPr>
         <p:spPr>
           <a:xfrm>
-            <a:off x="770844" y="4494466"/>
-            <a:ext cx="3389069" cy="400110"/>
+            <a:off x="770844" y="4135718"/>
+            <a:ext cx="2286203" cy="400110"/>
           </a:xfrm>
           <a:prstGeom prst="rect">
             <a:avLst/>
@@ -4641,7 +4659,14 @@
                 <a:latin typeface="IBM Plex Sans JP SemiBold" panose="020B0703050203000203" pitchFamily="50" charset="-128"/>
                 <a:ea typeface="IBM Plex Sans JP SemiBold" panose="020B0703050203000203" pitchFamily="50" charset="-128"/>
               </a:rPr>
-              <a:t>2. How to Choose a Model</a:t>
+              <a:t>2. </a:t>
+            </a:r>
+            <a:r>
+              <a:rPr lang="ja-JP" altLang="en-US" sz="2000" dirty="0">
+                <a:latin typeface="IBM Plex Sans JP SemiBold" panose="020B0703050203000203" pitchFamily="50" charset="-128"/>
+                <a:ea typeface="IBM Plex Sans JP SemiBold" panose="020B0703050203000203" pitchFamily="50" charset="-128"/>
+              </a:rPr>
+              <a:t>モデル選定方法</a:t>
             </a:r>
             <a:endParaRPr kumimoji="1" lang="ja-JP" altLang="en-US" sz="2400" b="1" dirty="0">
               <a:latin typeface="IBM Plex Sans JP SemiBold" panose="020B0703050203000203" pitchFamily="50" charset="-128"/>
@@ -4664,8 +4689,8 @@
         </p:nvSpPr>
         <p:spPr>
           <a:xfrm>
-            <a:off x="661239" y="4917406"/>
-            <a:ext cx="5649492" cy="253916"/>
+            <a:off x="661239" y="4511386"/>
+            <a:ext cx="5649492" cy="553998"/>
           </a:xfrm>
           <a:prstGeom prst="rect">
             <a:avLst/>
@@ -4679,13 +4704,43 @@
           <a:lstStyle/>
           <a:p>
             <a:r>
-              <a:rPr lang="en-US" altLang="ja-JP" sz="1050" dirty="0">
-                <a:latin typeface="IBM Plex Sans JP" panose="020B0503050203000203" pitchFamily="50" charset="-128"/>
-                <a:ea typeface="IBM Plex Sans JP" panose="020B0503050203000203" pitchFamily="50" charset="-128"/>
-              </a:rPr>
-              <a:t>First, follow this quick selection flow to download and print the correct data.</a:t>
-            </a:r>
-            <a:endParaRPr kumimoji="1" lang="ja-JP" altLang="en-US" sz="1050" b="1" dirty="0">
+              <a:rPr lang="ja-JP" altLang="ja-JP" sz="1000" dirty="0">
+                <a:latin typeface="IBM Plex Sans JP" panose="020B0503050203000203" pitchFamily="50" charset="-128"/>
+                <a:ea typeface="IBM Plex Sans JP" panose="020B0503050203000203" pitchFamily="50" charset="-128"/>
+              </a:rPr>
+              <a:t>簡易的なモデル選定手順をお見せします。まずは</a:t>
+            </a:r>
+            <a:r>
+              <a:rPr lang="en-US" altLang="ja-JP" sz="1000" dirty="0">
+                <a:latin typeface="IBM Plex Sans JP" panose="020B0503050203000203" pitchFamily="50" charset="-128"/>
+                <a:ea typeface="IBM Plex Sans JP" panose="020B0503050203000203" pitchFamily="50" charset="-128"/>
+              </a:rPr>
+              <a:t>Makerworld</a:t>
+            </a:r>
+            <a:r>
+              <a:rPr lang="ja-JP" altLang="ja-JP" sz="1000" dirty="0">
+                <a:latin typeface="IBM Plex Sans JP" panose="020B0503050203000203" pitchFamily="50" charset="-128"/>
+                <a:ea typeface="IBM Plex Sans JP" panose="020B0503050203000203" pitchFamily="50" charset="-128"/>
+              </a:rPr>
+              <a:t>で</a:t>
+            </a:r>
+            <a:r>
+              <a:rPr lang="en-US" altLang="ja-JP" sz="1000" dirty="0">
+                <a:latin typeface="IBM Plex Sans JP" panose="020B0503050203000203" pitchFamily="50" charset="-128"/>
+                <a:ea typeface="IBM Plex Sans JP" panose="020B0503050203000203" pitchFamily="50" charset="-128"/>
+              </a:rPr>
+              <a:t>FlexChroma HUB</a:t>
+            </a:r>
+            <a:r>
+              <a:rPr lang="ja-JP" altLang="ja-JP" sz="1000" dirty="0">
+                <a:latin typeface="IBM Plex Sans JP" panose="020B0503050203000203" pitchFamily="50" charset="-128"/>
+                <a:ea typeface="IBM Plex Sans JP" panose="020B0503050203000203" pitchFamily="50" charset="-128"/>
+              </a:rPr>
+              <a:t>を開いてください。その後に下記フローに従って適切なデータをダウンロードし、印刷してください。</a:t>
+            </a:r>
+          </a:p>
+          <a:p>
+            <a:endParaRPr kumimoji="1" lang="ja-JP" altLang="en-US" sz="1000" b="1" dirty="0">
               <a:latin typeface="IBM Plex Sans JP" panose="020B0503050203000203" pitchFamily="50" charset="-128"/>
               <a:ea typeface="IBM Plex Sans JP" panose="020B0503050203000203" pitchFamily="50" charset="-128"/>
             </a:endParaRPr>
@@ -4706,8 +4761,8 @@
         </p:nvSpPr>
         <p:spPr>
           <a:xfrm>
-            <a:off x="661238" y="6573178"/>
-            <a:ext cx="5656761" cy="258083"/>
+            <a:off x="661238" y="6206196"/>
+            <a:ext cx="5656761" cy="400110"/>
           </a:xfrm>
           <a:prstGeom prst="rect">
             <a:avLst/>
@@ -4721,11 +4776,39 @@
           <a:lstStyle/>
           <a:p>
             <a:r>
-              <a:rPr lang="en-US" altLang="ja-JP" sz="1050" dirty="0">
-                <a:latin typeface="IBM Plex Sans JP" panose="020B0503050203000203" pitchFamily="50" charset="-128"/>
-                <a:ea typeface="IBM Plex Sans JP" panose="020B0503050203000203" pitchFamily="50" charset="-128"/>
-              </a:rPr>
-              <a:t>When choosing a model, start by deciding what kind of filament you want to create.</a:t>
+              <a:rPr lang="ja-JP" altLang="ja-JP" sz="1000" dirty="0">
+                <a:latin typeface="IBM Plex Sans JP" panose="020B0503050203000203" pitchFamily="50" charset="-128"/>
+                <a:ea typeface="IBM Plex Sans JP" panose="020B0503050203000203" pitchFamily="50" charset="-128"/>
+              </a:rPr>
+              <a:t>モデル選定においてはどの様なフィラメントが欲しいか？を考えま</a:t>
+            </a:r>
+            <a:r>
+              <a:rPr lang="ja-JP" altLang="en-US" sz="1000" dirty="0">
+                <a:latin typeface="IBM Plex Sans JP" panose="020B0503050203000203" pitchFamily="50" charset="-128"/>
+                <a:ea typeface="IBM Plex Sans JP" panose="020B0503050203000203" pitchFamily="50" charset="-128"/>
+              </a:rPr>
+              <a:t>しょう</a:t>
+            </a:r>
+            <a:r>
+              <a:rPr lang="ja-JP" altLang="ja-JP" sz="1000" dirty="0">
+                <a:latin typeface="IBM Plex Sans JP" panose="020B0503050203000203" pitchFamily="50" charset="-128"/>
+                <a:ea typeface="IBM Plex Sans JP" panose="020B0503050203000203" pitchFamily="50" charset="-128"/>
+              </a:rPr>
+              <a:t>。下記１～５の手順によって最適なデータを探</a:t>
+            </a:r>
+            <a:r>
+              <a:rPr lang="ja-JP" altLang="en-US" sz="1000" dirty="0">
+                <a:latin typeface="IBM Plex Sans JP" panose="020B0503050203000203" pitchFamily="50" charset="-128"/>
+                <a:ea typeface="IBM Plex Sans JP" panose="020B0503050203000203" pitchFamily="50" charset="-128"/>
+              </a:rPr>
+              <a:t>すことができます</a:t>
+            </a:r>
+            <a:r>
+              <a:rPr lang="ja-JP" altLang="ja-JP" sz="1000" dirty="0">
+                <a:latin typeface="IBM Plex Sans JP" panose="020B0503050203000203" pitchFamily="50" charset="-128"/>
+                <a:ea typeface="IBM Plex Sans JP" panose="020B0503050203000203" pitchFamily="50" charset="-128"/>
+              </a:rPr>
+              <a:t>。</a:t>
             </a:r>
           </a:p>
         </p:txBody>
@@ -4744,8 +4827,8 @@
         </p:nvSpPr>
         <p:spPr>
           <a:xfrm>
-            <a:off x="770843" y="6836315"/>
-            <a:ext cx="5554425" cy="1169551"/>
+            <a:off x="756306" y="6650049"/>
+            <a:ext cx="5554425" cy="1615827"/>
           </a:xfrm>
           <a:prstGeom prst="rect">
             <a:avLst/>
@@ -4758,71 +4841,336 @@
           </a:bodyPr>
           <a:lstStyle/>
           <a:p>
-            <a:r>
-              <a:rPr lang="en-US" altLang="ja-JP" sz="1000" dirty="0">
-                <a:latin typeface="IBM Plex Sans JP" panose="020B0503050203000203" pitchFamily="50" charset="-128"/>
-                <a:ea typeface="IBM Plex Sans JP" panose="020B0503050203000203" pitchFamily="50" charset="-128"/>
-              </a:rPr>
-              <a:t>1. Select a Series: Blend Filament for mixed colors, Gradient Filament for color changes.</a:t>
-            </a:r>
-          </a:p>
-          <a:p>
-            <a:r>
-              <a:rPr lang="en-US" altLang="ja-JP" sz="1000" dirty="0">
-                <a:latin typeface="IBM Plex Sans JP" panose="020B0503050203000203" pitchFamily="50" charset="-128"/>
-                <a:ea typeface="IBM Plex Sans JP" panose="020B0503050203000203" pitchFamily="50" charset="-128"/>
-              </a:rPr>
-              <a:t>2. Select a Model size: Use an S4 Model for small objects, or an M1 Model for larger prints </a:t>
-            </a:r>
-          </a:p>
-          <a:p>
-            <a:r>
-              <a:rPr lang="en-US" altLang="ja-JP" sz="1000" dirty="0">
-                <a:latin typeface="IBM Plex Sans JP" panose="020B0503050203000203" pitchFamily="50" charset="-128"/>
-                <a:ea typeface="IBM Plex Sans JP" panose="020B0503050203000203" pitchFamily="50" charset="-128"/>
-              </a:rPr>
-              <a:t>     requiring around 70g of filament.</a:t>
-            </a:r>
-          </a:p>
-          <a:p>
-            <a:r>
-              <a:rPr lang="en-US" altLang="ja-JP" sz="1000" dirty="0">
-                <a:latin typeface="IBM Plex Sans JP" panose="020B0503050203000203" pitchFamily="50" charset="-128"/>
-                <a:ea typeface="IBM Plex Sans JP" panose="020B0503050203000203" pitchFamily="50" charset="-128"/>
-              </a:rPr>
-              <a:t>3. Select a Profile and Plate: Choose the Plate that matches your desired mixing ratio or </a:t>
-            </a:r>
-          </a:p>
-          <a:p>
-            <a:r>
-              <a:rPr lang="en-US" altLang="ja-JP" sz="1000" dirty="0">
-                <a:latin typeface="IBM Plex Sans JP" panose="020B0503050203000203" pitchFamily="50" charset="-128"/>
-                <a:ea typeface="IBM Plex Sans JP" panose="020B0503050203000203" pitchFamily="50" charset="-128"/>
-              </a:rPr>
-              <a:t>     pattern.</a:t>
-            </a:r>
-          </a:p>
-          <a:p>
-            <a:r>
-              <a:rPr lang="en-US" altLang="ja-JP" sz="1000" dirty="0">
-                <a:latin typeface="IBM Plex Sans JP" panose="020B0503050203000203" pitchFamily="50" charset="-128"/>
-                <a:ea typeface="IBM Plex Sans JP" panose="020B0503050203000203" pitchFamily="50" charset="-128"/>
-              </a:rPr>
-              <a:t>4. Assign filaments and slice: Use filaments with the same or similar material, assign </a:t>
-            </a:r>
-          </a:p>
-          <a:p>
-            <a:r>
-              <a:rPr lang="en-US" altLang="ja-JP" sz="1000" dirty="0">
-                <a:latin typeface="IBM Plex Sans JP" panose="020B0503050203000203" pitchFamily="50" charset="-128"/>
-                <a:ea typeface="IBM Plex Sans JP" panose="020B0503050203000203" pitchFamily="50" charset="-128"/>
-              </a:rPr>
-              <a:t>     them, slice the model, and read the print notes before printing.</a:t>
-            </a:r>
-            <a:endParaRPr kumimoji="1" lang="ja-JP" altLang="en-US" sz="900" b="1" dirty="0">
-              <a:latin typeface="IBM Plex Sans JP Light" panose="020B0403050203000203" pitchFamily="50" charset="-128"/>
-              <a:ea typeface="IBM Plex Sans JP Light" panose="020B0403050203000203" pitchFamily="50" charset="-128"/>
-            </a:endParaRPr>
+            <a:pPr marL="228600" lvl="0" indent="-228600">
+              <a:buFont typeface="+mj-lt"/>
+              <a:buAutoNum type="arabicPeriod"/>
+            </a:pPr>
+            <a:r>
+              <a:rPr lang="ja-JP" altLang="ja-JP" sz="900" dirty="0">
+                <a:latin typeface="IBM Plex Sans JP" panose="020B0503050203000203" pitchFamily="50" charset="-128"/>
+                <a:ea typeface="IBM Plex Sans JP" panose="020B0503050203000203" pitchFamily="50" charset="-128"/>
+              </a:rPr>
+              <a:t>最初に</a:t>
+            </a:r>
+            <a:r>
+              <a:rPr lang="en-US" altLang="ja-JP" sz="900" dirty="0">
+                <a:latin typeface="IBM Plex Sans JP" panose="020B0503050203000203" pitchFamily="50" charset="-128"/>
+                <a:ea typeface="IBM Plex Sans JP" panose="020B0503050203000203" pitchFamily="50" charset="-128"/>
+              </a:rPr>
+              <a:t>Series</a:t>
+            </a:r>
+            <a:r>
+              <a:rPr lang="ja-JP" altLang="ja-JP" sz="900" dirty="0">
+                <a:latin typeface="IBM Plex Sans JP" panose="020B0503050203000203" pitchFamily="50" charset="-128"/>
+                <a:ea typeface="IBM Plex Sans JP" panose="020B0503050203000203" pitchFamily="50" charset="-128"/>
+              </a:rPr>
+              <a:t>を選択します。中間色が欲しいのであれば</a:t>
+            </a:r>
+            <a:r>
+              <a:rPr lang="en-US" altLang="ja-JP" sz="900" dirty="0">
+                <a:latin typeface="IBM Plex Sans JP" panose="020B0503050203000203" pitchFamily="50" charset="-128"/>
+                <a:ea typeface="IBM Plex Sans JP" panose="020B0503050203000203" pitchFamily="50" charset="-128"/>
+              </a:rPr>
+              <a:t>Blend Filament</a:t>
+            </a:r>
+            <a:r>
+              <a:rPr lang="ja-JP" altLang="ja-JP" sz="900" dirty="0">
+                <a:latin typeface="IBM Plex Sans JP" panose="020B0503050203000203" pitchFamily="50" charset="-128"/>
+                <a:ea typeface="IBM Plex Sans JP" panose="020B0503050203000203" pitchFamily="50" charset="-128"/>
+              </a:rPr>
+              <a:t>、グラデーションフィラメントが欲しければ</a:t>
+            </a:r>
+            <a:r>
+              <a:rPr lang="en-US" altLang="ja-JP" sz="900" dirty="0">
+                <a:latin typeface="IBM Plex Sans JP" panose="020B0503050203000203" pitchFamily="50" charset="-128"/>
+                <a:ea typeface="IBM Plex Sans JP" panose="020B0503050203000203" pitchFamily="50" charset="-128"/>
+              </a:rPr>
+              <a:t>Gradient Filament</a:t>
+            </a:r>
+            <a:r>
+              <a:rPr lang="ja-JP" altLang="ja-JP" sz="900" dirty="0">
+                <a:latin typeface="IBM Plex Sans JP" panose="020B0503050203000203" pitchFamily="50" charset="-128"/>
+                <a:ea typeface="IBM Plex Sans JP" panose="020B0503050203000203" pitchFamily="50" charset="-128"/>
+              </a:rPr>
+              <a:t>と言った様に。</a:t>
+            </a:r>
+          </a:p>
+          <a:p>
+            <a:pPr marL="228600" lvl="0" indent="-228600">
+              <a:buFont typeface="+mj-lt"/>
+              <a:buAutoNum type="arabicPeriod"/>
+            </a:pPr>
+            <a:r>
+              <a:rPr lang="ja-JP" altLang="ja-JP" sz="900" dirty="0">
+                <a:latin typeface="IBM Plex Sans JP" panose="020B0503050203000203" pitchFamily="50" charset="-128"/>
+                <a:ea typeface="IBM Plex Sans JP" panose="020B0503050203000203" pitchFamily="50" charset="-128"/>
+              </a:rPr>
+              <a:t>次に</a:t>
+            </a:r>
+            <a:r>
+              <a:rPr lang="en-US" altLang="ja-JP" sz="900" dirty="0">
+                <a:latin typeface="IBM Plex Sans JP" panose="020B0503050203000203" pitchFamily="50" charset="-128"/>
+                <a:ea typeface="IBM Plex Sans JP" panose="020B0503050203000203" pitchFamily="50" charset="-128"/>
+              </a:rPr>
+              <a:t>Model</a:t>
+            </a:r>
+            <a:r>
+              <a:rPr lang="ja-JP" altLang="ja-JP" sz="900" dirty="0">
+                <a:latin typeface="IBM Plex Sans JP" panose="020B0503050203000203" pitchFamily="50" charset="-128"/>
+                <a:ea typeface="IBM Plex Sans JP" panose="020B0503050203000203" pitchFamily="50" charset="-128"/>
+              </a:rPr>
+              <a:t>を選択します。フィラメントの量がどれくらい必要かを考えて、それに合った</a:t>
+            </a:r>
+            <a:r>
+              <a:rPr lang="en-US" altLang="ja-JP" sz="900" dirty="0">
+                <a:latin typeface="IBM Plex Sans JP" panose="020B0503050203000203" pitchFamily="50" charset="-128"/>
+                <a:ea typeface="IBM Plex Sans JP" panose="020B0503050203000203" pitchFamily="50" charset="-128"/>
+              </a:rPr>
+              <a:t>Model</a:t>
+            </a:r>
+            <a:r>
+              <a:rPr lang="ja-JP" altLang="ja-JP" sz="900" dirty="0">
+                <a:latin typeface="IBM Plex Sans JP" panose="020B0503050203000203" pitchFamily="50" charset="-128"/>
+                <a:ea typeface="IBM Plex Sans JP" panose="020B0503050203000203" pitchFamily="50" charset="-128"/>
+              </a:rPr>
+              <a:t>を選択します。例えば</a:t>
+            </a:r>
+            <a:r>
+              <a:rPr lang="en-US" altLang="ja-JP" sz="900" dirty="0">
+                <a:latin typeface="IBM Plex Sans JP" panose="020B0503050203000203" pitchFamily="50" charset="-128"/>
+                <a:ea typeface="IBM Plex Sans JP" panose="020B0503050203000203" pitchFamily="50" charset="-128"/>
+              </a:rPr>
+              <a:t>3Dbenchy</a:t>
+            </a:r>
+            <a:r>
+              <a:rPr lang="ja-JP" altLang="ja-JP" sz="900" dirty="0">
+                <a:latin typeface="IBM Plex Sans JP" panose="020B0503050203000203" pitchFamily="50" charset="-128"/>
+                <a:ea typeface="IBM Plex Sans JP" panose="020B0503050203000203" pitchFamily="50" charset="-128"/>
+              </a:rPr>
+              <a:t>を作る程度であれば</a:t>
+            </a:r>
+            <a:r>
+              <a:rPr lang="en-US" altLang="ja-JP" sz="900" dirty="0">
+                <a:latin typeface="IBM Plex Sans JP" panose="020B0503050203000203" pitchFamily="50" charset="-128"/>
+                <a:ea typeface="IBM Plex Sans JP" panose="020B0503050203000203" pitchFamily="50" charset="-128"/>
+              </a:rPr>
+              <a:t>S4 Model</a:t>
+            </a:r>
+            <a:r>
+              <a:rPr lang="ja-JP" altLang="ja-JP" sz="900" dirty="0">
+                <a:latin typeface="IBM Plex Sans JP" panose="020B0503050203000203" pitchFamily="50" charset="-128"/>
+                <a:ea typeface="IBM Plex Sans JP" panose="020B0503050203000203" pitchFamily="50" charset="-128"/>
+              </a:rPr>
+              <a:t>、</a:t>
+            </a:r>
+            <a:r>
+              <a:rPr lang="en-US" altLang="ja-JP" sz="900" dirty="0">
+                <a:latin typeface="IBM Plex Sans JP" panose="020B0503050203000203" pitchFamily="50" charset="-128"/>
+                <a:ea typeface="IBM Plex Sans JP" panose="020B0503050203000203" pitchFamily="50" charset="-128"/>
+              </a:rPr>
+              <a:t>70g</a:t>
+            </a:r>
+            <a:r>
+              <a:rPr lang="ja-JP" altLang="ja-JP" sz="900" dirty="0">
+                <a:latin typeface="IBM Plex Sans JP" panose="020B0503050203000203" pitchFamily="50" charset="-128"/>
+                <a:ea typeface="IBM Plex Sans JP" panose="020B0503050203000203" pitchFamily="50" charset="-128"/>
+              </a:rPr>
+              <a:t>近い大きなモデルを作るのであれば</a:t>
+            </a:r>
+            <a:r>
+              <a:rPr lang="en-US" altLang="ja-JP" sz="900" dirty="0">
+                <a:latin typeface="IBM Plex Sans JP" panose="020B0503050203000203" pitchFamily="50" charset="-128"/>
+                <a:ea typeface="IBM Plex Sans JP" panose="020B0503050203000203" pitchFamily="50" charset="-128"/>
+              </a:rPr>
+              <a:t>M1 Model</a:t>
+            </a:r>
+            <a:r>
+              <a:rPr lang="ja-JP" altLang="ja-JP" sz="900" dirty="0">
+                <a:latin typeface="IBM Plex Sans JP" panose="020B0503050203000203" pitchFamily="50" charset="-128"/>
+                <a:ea typeface="IBM Plex Sans JP" panose="020B0503050203000203" pitchFamily="50" charset="-128"/>
+              </a:rPr>
+              <a:t>と言う具合です。</a:t>
+            </a:r>
+          </a:p>
+          <a:p>
+            <a:pPr marL="228600" lvl="0" indent="-228600">
+              <a:buFont typeface="+mj-lt"/>
+              <a:buAutoNum type="arabicPeriod"/>
+            </a:pPr>
+            <a:r>
+              <a:rPr lang="ja-JP" altLang="ja-JP" sz="900" dirty="0">
+                <a:latin typeface="IBM Plex Sans JP" panose="020B0503050203000203" pitchFamily="50" charset="-128"/>
+                <a:ea typeface="IBM Plex Sans JP" panose="020B0503050203000203" pitchFamily="50" charset="-128"/>
+              </a:rPr>
+              <a:t>次に</a:t>
+            </a:r>
+            <a:r>
+              <a:rPr lang="en-US" altLang="ja-JP" sz="900" dirty="0">
+                <a:latin typeface="IBM Plex Sans JP" panose="020B0503050203000203" pitchFamily="50" charset="-128"/>
+                <a:ea typeface="IBM Plex Sans JP" panose="020B0503050203000203" pitchFamily="50" charset="-128"/>
+              </a:rPr>
+              <a:t>Profile</a:t>
+            </a:r>
+            <a:r>
+              <a:rPr lang="ja-JP" altLang="ja-JP" sz="900" dirty="0">
+                <a:latin typeface="IBM Plex Sans JP" panose="020B0503050203000203" pitchFamily="50" charset="-128"/>
+                <a:ea typeface="IBM Plex Sans JP" panose="020B0503050203000203" pitchFamily="50" charset="-128"/>
+              </a:rPr>
+              <a:t>と</a:t>
+            </a:r>
+            <a:r>
+              <a:rPr lang="en-US" altLang="ja-JP" sz="900" dirty="0">
+                <a:latin typeface="IBM Plex Sans JP" panose="020B0503050203000203" pitchFamily="50" charset="-128"/>
+                <a:ea typeface="IBM Plex Sans JP" panose="020B0503050203000203" pitchFamily="50" charset="-128"/>
+              </a:rPr>
+              <a:t>Plate</a:t>
+            </a:r>
+            <a:r>
+              <a:rPr lang="ja-JP" altLang="ja-JP" sz="900" dirty="0">
+                <a:latin typeface="IBM Plex Sans JP" panose="020B0503050203000203" pitchFamily="50" charset="-128"/>
+                <a:ea typeface="IBM Plex Sans JP" panose="020B0503050203000203" pitchFamily="50" charset="-128"/>
+              </a:rPr>
+              <a:t>を選びます。</a:t>
+            </a:r>
+            <a:r>
+              <a:rPr lang="en-US" altLang="ja-JP" sz="900" dirty="0">
+                <a:latin typeface="IBM Plex Sans JP" panose="020B0503050203000203" pitchFamily="50" charset="-128"/>
+                <a:ea typeface="IBM Plex Sans JP" panose="020B0503050203000203" pitchFamily="50" charset="-128"/>
+              </a:rPr>
+              <a:t>Series</a:t>
+            </a:r>
+            <a:r>
+              <a:rPr lang="ja-JP" altLang="ja-JP" sz="900" dirty="0">
+                <a:latin typeface="IBM Plex Sans JP" panose="020B0503050203000203" pitchFamily="50" charset="-128"/>
+                <a:ea typeface="IBM Plex Sans JP" panose="020B0503050203000203" pitchFamily="50" charset="-128"/>
+              </a:rPr>
+              <a:t>によって異なる分け方で</a:t>
+            </a:r>
+            <a:r>
+              <a:rPr lang="en-US" altLang="ja-JP" sz="900" dirty="0">
+                <a:latin typeface="IBM Plex Sans JP" panose="020B0503050203000203" pitchFamily="50" charset="-128"/>
+                <a:ea typeface="IBM Plex Sans JP" panose="020B0503050203000203" pitchFamily="50" charset="-128"/>
+              </a:rPr>
+              <a:t>Profile</a:t>
+            </a:r>
+            <a:r>
+              <a:rPr lang="ja-JP" altLang="ja-JP" sz="900" dirty="0">
+                <a:latin typeface="IBM Plex Sans JP" panose="020B0503050203000203" pitchFamily="50" charset="-128"/>
+                <a:ea typeface="IBM Plex Sans JP" panose="020B0503050203000203" pitchFamily="50" charset="-128"/>
+              </a:rPr>
+              <a:t>と</a:t>
+            </a:r>
+            <a:r>
+              <a:rPr lang="en-US" altLang="ja-JP" sz="900" dirty="0">
+                <a:latin typeface="IBM Plex Sans JP" panose="020B0503050203000203" pitchFamily="50" charset="-128"/>
+                <a:ea typeface="IBM Plex Sans JP" panose="020B0503050203000203" pitchFamily="50" charset="-128"/>
+              </a:rPr>
+              <a:t>Plate</a:t>
+            </a:r>
+            <a:r>
+              <a:rPr lang="ja-JP" altLang="ja-JP" sz="900" dirty="0">
+                <a:latin typeface="IBM Plex Sans JP" panose="020B0503050203000203" pitchFamily="50" charset="-128"/>
+                <a:ea typeface="IBM Plex Sans JP" panose="020B0503050203000203" pitchFamily="50" charset="-128"/>
+              </a:rPr>
+              <a:t>ごとにフィラメントのデータがあります。例えば</a:t>
+            </a:r>
+            <a:r>
+              <a:rPr lang="en-US" altLang="ja-JP" sz="900" dirty="0">
+                <a:latin typeface="IBM Plex Sans JP" panose="020B0503050203000203" pitchFamily="50" charset="-128"/>
+                <a:ea typeface="IBM Plex Sans JP" panose="020B0503050203000203" pitchFamily="50" charset="-128"/>
+              </a:rPr>
+              <a:t>Blend Filament</a:t>
+            </a:r>
+            <a:r>
+              <a:rPr lang="ja-JP" altLang="ja-JP" sz="900" dirty="0">
+                <a:latin typeface="IBM Plex Sans JP" panose="020B0503050203000203" pitchFamily="50" charset="-128"/>
+                <a:ea typeface="IBM Plex Sans JP" panose="020B0503050203000203" pitchFamily="50" charset="-128"/>
+              </a:rPr>
+              <a:t>で９８％混色比のモデルであれば、</a:t>
+            </a:r>
+            <a:r>
+              <a:rPr lang="en-US" altLang="ja-JP" sz="900" dirty="0">
+                <a:latin typeface="IBM Plex Sans JP" panose="020B0503050203000203" pitchFamily="50" charset="-128"/>
+                <a:ea typeface="IBM Plex Sans JP" panose="020B0503050203000203" pitchFamily="50" charset="-128"/>
+              </a:rPr>
+              <a:t>Detail Profile</a:t>
+            </a:r>
+            <a:r>
+              <a:rPr lang="ja-JP" altLang="ja-JP" sz="900" dirty="0">
+                <a:latin typeface="IBM Plex Sans JP" panose="020B0503050203000203" pitchFamily="50" charset="-128"/>
+                <a:ea typeface="IBM Plex Sans JP" panose="020B0503050203000203" pitchFamily="50" charset="-128"/>
+              </a:rPr>
+              <a:t>の中の</a:t>
+            </a:r>
+            <a:r>
+              <a:rPr lang="en-US" altLang="ja-JP" sz="900" dirty="0">
+                <a:latin typeface="IBM Plex Sans JP" panose="020B0503050203000203" pitchFamily="50" charset="-128"/>
+                <a:ea typeface="IBM Plex Sans JP" panose="020B0503050203000203" pitchFamily="50" charset="-128"/>
+              </a:rPr>
+              <a:t>98pct</a:t>
+            </a:r>
+            <a:r>
+              <a:rPr lang="ja-JP" altLang="ja-JP" sz="900" dirty="0">
+                <a:latin typeface="IBM Plex Sans JP" panose="020B0503050203000203" pitchFamily="50" charset="-128"/>
+                <a:ea typeface="IBM Plex Sans JP" panose="020B0503050203000203" pitchFamily="50" charset="-128"/>
+              </a:rPr>
+              <a:t>プレートを選びます。</a:t>
+            </a:r>
+          </a:p>
+          <a:p>
+            <a:pPr marL="228600" lvl="0" indent="-228600">
+              <a:buFont typeface="+mj-lt"/>
+              <a:buAutoNum type="arabicPeriod"/>
+            </a:pPr>
+            <a:r>
+              <a:rPr lang="ja-JP" altLang="ja-JP" sz="900" dirty="0">
+                <a:latin typeface="IBM Plex Sans JP" panose="020B0503050203000203" pitchFamily="50" charset="-128"/>
+                <a:ea typeface="IBM Plex Sans JP" panose="020B0503050203000203" pitchFamily="50" charset="-128"/>
+              </a:rPr>
+              <a:t>使うフィラメントを選びます。素材が同じもしくは近い</a:t>
+            </a:r>
+            <a:r>
+              <a:rPr lang="en-US" altLang="ja-JP" sz="900" dirty="0">
+                <a:latin typeface="IBM Plex Sans JP" panose="020B0503050203000203" pitchFamily="50" charset="-128"/>
+                <a:ea typeface="IBM Plex Sans JP" panose="020B0503050203000203" pitchFamily="50" charset="-128"/>
+              </a:rPr>
+              <a:t>(PLA Basic</a:t>
+            </a:r>
+            <a:r>
+              <a:rPr lang="ja-JP" altLang="ja-JP" sz="900" dirty="0">
+                <a:latin typeface="IBM Plex Sans JP" panose="020B0503050203000203" pitchFamily="50" charset="-128"/>
+                <a:ea typeface="IBM Plex Sans JP" panose="020B0503050203000203" pitchFamily="50" charset="-128"/>
+              </a:rPr>
+              <a:t>と</a:t>
+            </a:r>
+            <a:r>
+              <a:rPr lang="en-US" altLang="ja-JP" sz="900" dirty="0">
+                <a:latin typeface="IBM Plex Sans JP" panose="020B0503050203000203" pitchFamily="50" charset="-128"/>
+                <a:ea typeface="IBM Plex Sans JP" panose="020B0503050203000203" pitchFamily="50" charset="-128"/>
+              </a:rPr>
+              <a:t>PLA Matte</a:t>
+            </a:r>
+            <a:r>
+              <a:rPr lang="ja-JP" altLang="ja-JP" sz="900" dirty="0">
+                <a:latin typeface="IBM Plex Sans JP" panose="020B0503050203000203" pitchFamily="50" charset="-128"/>
+                <a:ea typeface="IBM Plex Sans JP" panose="020B0503050203000203" pitchFamily="50" charset="-128"/>
+              </a:rPr>
+              <a:t>の様な</a:t>
+            </a:r>
+            <a:r>
+              <a:rPr lang="en-US" altLang="ja-JP" sz="900" dirty="0">
+                <a:latin typeface="IBM Plex Sans JP" panose="020B0503050203000203" pitchFamily="50" charset="-128"/>
+                <a:ea typeface="IBM Plex Sans JP" panose="020B0503050203000203" pitchFamily="50" charset="-128"/>
+              </a:rPr>
+              <a:t>)</a:t>
+            </a:r>
+            <a:r>
+              <a:rPr lang="ja-JP" altLang="ja-JP" sz="900" dirty="0">
+                <a:latin typeface="IBM Plex Sans JP" panose="020B0503050203000203" pitchFamily="50" charset="-128"/>
+                <a:ea typeface="IBM Plex Sans JP" panose="020B0503050203000203" pitchFamily="50" charset="-128"/>
+              </a:rPr>
+              <a:t>フィラメントを用意しましょう。選んだフィラメントを割り当てて、スライスしましょう。説明文に書かれている印刷時の注意点をよく読んでから印刷して下さい。</a:t>
+            </a:r>
           </a:p>
         </p:txBody>
       </p:sp>
@@ -4840,8 +5188,8 @@
         </p:nvSpPr>
         <p:spPr>
           <a:xfrm>
-            <a:off x="770842" y="8115753"/>
-            <a:ext cx="5464000" cy="230832"/>
+            <a:off x="656136" y="8285815"/>
+            <a:ext cx="5680304" cy="223138"/>
           </a:xfrm>
           <a:prstGeom prst="rect">
             <a:avLst/>
@@ -4855,31 +5203,54 @@
           <a:lstStyle/>
           <a:p>
             <a:r>
-              <a:rPr lang="en-US" altLang="ja-JP" sz="900" dirty="0">
+              <a:rPr lang="ja-JP" altLang="ja-JP" sz="800" dirty="0">
                 <a:latin typeface="IBM Plex Sans JP Light" panose="020B0403050203000203" pitchFamily="50" charset="-128"/>
                 <a:ea typeface="IBM Plex Sans JP Light" panose="020B0403050203000203" pitchFamily="50" charset="-128"/>
               </a:rPr>
-              <a:t>*Note: In </a:t>
-            </a:r>
-            <a:r>
-              <a:rPr lang="en-US" altLang="ja-JP" sz="900" dirty="0">
-                <a:latin typeface="Segoe UI" panose="020B0502040204020203" pitchFamily="34" charset="0"/>
-                <a:ea typeface="IBM Plex Sans JP Light" panose="020B0403050203000203" pitchFamily="50" charset="-128"/>
-                <a:cs typeface="Segoe UI" panose="020B0502040204020203" pitchFamily="34" charset="0"/>
-              </a:rPr>
-              <a:t>FlexChroma</a:t>
-            </a:r>
-            <a:r>
-              <a:rPr lang="en-US" altLang="ja-JP" sz="900" dirty="0">
+              <a:t>※</a:t>
+            </a:r>
+            <a:r>
+              <a:rPr lang="en-US" altLang="ja-JP" sz="800" dirty="0">
                 <a:latin typeface="IBM Plex Sans JP Light" panose="020B0403050203000203" pitchFamily="50" charset="-128"/>
                 <a:ea typeface="IBM Plex Sans JP Light" panose="020B0403050203000203" pitchFamily="50" charset="-128"/>
               </a:rPr>
-              <a:t>, “Profile” means a purpose-based classification, not different print settings.</a:t>
-            </a:r>
-            <a:endParaRPr kumimoji="1" lang="ja-JP" altLang="en-US" sz="900" b="1" dirty="0">
-              <a:latin typeface="IBM Plex Sans JP Light" panose="020B0403050203000203" pitchFamily="50" charset="-128"/>
-              <a:ea typeface="IBM Plex Sans JP Light" panose="020B0403050203000203" pitchFamily="50" charset="-128"/>
-            </a:endParaRPr>
+              <a:t>FlexChroma</a:t>
+            </a:r>
+            <a:r>
+              <a:rPr lang="ja-JP" altLang="ja-JP" sz="800" dirty="0">
+                <a:latin typeface="IBM Plex Sans JP Light" panose="020B0403050203000203" pitchFamily="50" charset="-128"/>
+                <a:ea typeface="IBM Plex Sans JP Light" panose="020B0403050203000203" pitchFamily="50" charset="-128"/>
+              </a:rPr>
+              <a:t>における</a:t>
+            </a:r>
+            <a:r>
+              <a:rPr lang="en-US" altLang="ja-JP" sz="800" dirty="0">
+                <a:latin typeface="IBM Plex Sans JP Light" panose="020B0403050203000203" pitchFamily="50" charset="-128"/>
+                <a:ea typeface="IBM Plex Sans JP Light" panose="020B0403050203000203" pitchFamily="50" charset="-128"/>
+              </a:rPr>
+              <a:t>Profile</a:t>
+            </a:r>
+            <a:r>
+              <a:rPr lang="ja-JP" altLang="ja-JP" sz="800" dirty="0">
+                <a:latin typeface="IBM Plex Sans JP Light" panose="020B0403050203000203" pitchFamily="50" charset="-128"/>
+                <a:ea typeface="IBM Plex Sans JP Light" panose="020B0403050203000203" pitchFamily="50" charset="-128"/>
+              </a:rPr>
+              <a:t>は印刷設定の違いではありません。各</a:t>
+            </a:r>
+            <a:r>
+              <a:rPr lang="en-US" altLang="ja-JP" sz="800" dirty="0">
+                <a:latin typeface="IBM Plex Sans JP Light" panose="020B0403050203000203" pitchFamily="50" charset="-128"/>
+                <a:ea typeface="IBM Plex Sans JP Light" panose="020B0403050203000203" pitchFamily="50" charset="-128"/>
+              </a:rPr>
+              <a:t>Series</a:t>
+            </a:r>
+            <a:r>
+              <a:rPr lang="ja-JP" altLang="ja-JP" sz="800" dirty="0">
+                <a:latin typeface="IBM Plex Sans JP Light" panose="020B0403050203000203" pitchFamily="50" charset="-128"/>
+                <a:ea typeface="IBM Plex Sans JP Light" panose="020B0403050203000203" pitchFamily="50" charset="-128"/>
+              </a:rPr>
+              <a:t>内で「目的別の分類」を表しています。</a:t>
+            </a:r>
           </a:p>
         </p:txBody>
       </p:sp>
@@ -4905,7 +5276,7 @@
         </p:blipFill>
         <p:spPr>
           <a:xfrm>
-            <a:off x="551490" y="5293717"/>
+            <a:off x="551490" y="4987005"/>
             <a:ext cx="5759241" cy="1144558"/>
           </a:xfrm>
           <a:prstGeom prst="rect">
@@ -5908,7 +6279,7 @@
         </p:nvSpPr>
         <p:spPr>
           <a:xfrm>
-            <a:off x="566175" y="2644750"/>
+            <a:off x="566175" y="2510638"/>
             <a:ext cx="204669" cy="204669"/>
           </a:xfrm>
           <a:prstGeom prst="ellipse">
@@ -5997,7 +6368,7 @@
         <p:spPr>
           <a:xfrm>
             <a:off x="668508" y="950188"/>
-            <a:ext cx="5649491" cy="400110"/>
+            <a:ext cx="5649491" cy="553998"/>
           </a:xfrm>
           <a:prstGeom prst="rect">
             <a:avLst/>
@@ -6012,27 +6383,48 @@
           <a:p>
             <a:r>
               <a:rPr lang="en-US" altLang="ja-JP" sz="1000" dirty="0">
-                <a:latin typeface="IBM Plex Sans JP" panose="020B0503050203000203" pitchFamily="50" charset="-128"/>
-                <a:ea typeface="IBM Plex Sans JP" panose="020B0503050203000203" pitchFamily="50" charset="-128"/>
-              </a:rPr>
-              <a:t>The </a:t>
+                <a:latin typeface="Segoe UI Semibold" panose="020B0702040204020203" pitchFamily="34" charset="0"/>
+                <a:ea typeface="IBM Plex Sans JP" panose="020B0503050203000203" pitchFamily="50" charset="-128"/>
+                <a:cs typeface="Segoe UI Semibold" panose="020B0702040204020203" pitchFamily="34" charset="0"/>
+              </a:rPr>
+              <a:t>FlexChroma HUB </a:t>
+            </a:r>
+            <a:r>
+              <a:rPr lang="ja-JP" altLang="en-US" sz="1000" dirty="0">
+                <a:latin typeface="IBM Plex Sans JP" panose="020B0503050203000203" pitchFamily="50" charset="-128"/>
+                <a:ea typeface="IBM Plex Sans JP" panose="020B0503050203000203" pitchFamily="50" charset="-128"/>
+                <a:cs typeface="Segoe UI Semibold" panose="020B0702040204020203" pitchFamily="34" charset="0"/>
+              </a:rPr>
+              <a:t>は</a:t>
             </a:r>
             <a:r>
               <a:rPr lang="en-US" altLang="ja-JP" sz="1000" dirty="0">
-                <a:latin typeface="Segoe UI Semibold" panose="020B0702040204020203" pitchFamily="34" charset="0"/>
-                <a:ea typeface="IBM Plex Sans JP" panose="020B0503050203000203" pitchFamily="50" charset="-128"/>
-                <a:cs typeface="Segoe UI Semibold" panose="020B0702040204020203" pitchFamily="34" charset="0"/>
-              </a:rPr>
-              <a:t>FlexChroma HUB </a:t>
-            </a:r>
-            <a:r>
-              <a:rPr lang="en-US" altLang="ja-JP" sz="1000" dirty="0">
-                <a:latin typeface="IBM Plex Sans JP" panose="020B0503050203000203" pitchFamily="50" charset="-128"/>
-                <a:ea typeface="IBM Plex Sans JP" panose="020B0503050203000203" pitchFamily="50" charset="-128"/>
-              </a:rPr>
-              <a:t>is the main entry point on MakerWorld, providing access to all Series and external portals. If you are unsure where to start, open this model first.</a:t>
-            </a:r>
-            <a:endParaRPr kumimoji="1" lang="ja-JP" altLang="en-US" sz="500" b="1" dirty="0">
+                <a:latin typeface="IBM Plex Sans JP" panose="020B0503050203000203" pitchFamily="50" charset="-128"/>
+                <a:ea typeface="IBM Plex Sans JP" panose="020B0503050203000203" pitchFamily="50" charset="-128"/>
+              </a:rPr>
+              <a:t>Makerworld</a:t>
+            </a:r>
+            <a:r>
+              <a:rPr lang="ja-JP" altLang="ja-JP" sz="1000" dirty="0">
+                <a:latin typeface="IBM Plex Sans JP" panose="020B0503050203000203" pitchFamily="50" charset="-128"/>
+                <a:ea typeface="IBM Plex Sans JP" panose="020B0503050203000203" pitchFamily="50" charset="-128"/>
+              </a:rPr>
+              <a:t>における全てのシリーズや外部ポータルへの入口です。</a:t>
+            </a:r>
+            <a:r>
+              <a:rPr lang="ja-JP" altLang="ja-JP" sz="1000" b="1" dirty="0">
+                <a:latin typeface="IBM Plex Sans JP" panose="020B0503050203000203" pitchFamily="50" charset="-128"/>
+                <a:ea typeface="IBM Plex Sans JP" panose="020B0503050203000203" pitchFamily="50" charset="-128"/>
+              </a:rPr>
+              <a:t>迷ったらまずここを開いてください。</a:t>
+            </a:r>
+            <a:endParaRPr lang="ja-JP" altLang="ja-JP" sz="1000" dirty="0">
+              <a:latin typeface="IBM Plex Sans JP" panose="020B0503050203000203" pitchFamily="50" charset="-128"/>
+              <a:ea typeface="IBM Plex Sans JP" panose="020B0503050203000203" pitchFamily="50" charset="-128"/>
+            </a:endParaRPr>
+          </a:p>
+          <a:p>
+            <a:endParaRPr kumimoji="1" lang="ja-JP" altLang="en-US" sz="1000" b="1" dirty="0">
               <a:latin typeface="IBM Plex Sans JP" panose="020B0503050203000203" pitchFamily="50" charset="-128"/>
               <a:ea typeface="IBM Plex Sans JP" panose="020B0503050203000203" pitchFamily="50" charset="-128"/>
             </a:endParaRPr>
@@ -6053,7 +6445,7 @@
         </p:nvSpPr>
         <p:spPr>
           <a:xfrm>
-            <a:off x="770844" y="2574192"/>
+            <a:off x="770844" y="2440080"/>
             <a:ext cx="2379177" cy="400110"/>
           </a:xfrm>
           <a:prstGeom prst="rect">
@@ -6095,8 +6487,8 @@
         </p:nvSpPr>
         <p:spPr>
           <a:xfrm>
-            <a:off x="668509" y="2953843"/>
-            <a:ext cx="5642222" cy="1169551"/>
+            <a:off x="668509" y="2819731"/>
+            <a:ext cx="5642222" cy="1323439"/>
           </a:xfrm>
           <a:prstGeom prst="rect">
             <a:avLst/>
@@ -6114,27 +6506,114 @@
                 <a:latin typeface="IBM Plex Sans JP" panose="020B0503050203000203" pitchFamily="50" charset="-128"/>
                 <a:ea typeface="IBM Plex Sans JP" panose="020B0503050203000203" pitchFamily="50" charset="-128"/>
               </a:rPr>
-              <a:t>The Blend Filament Series is the most basic FlexChroma lineup. It allows you to mix two filaments at various ratios to create your own custom color.</a:t>
-            </a:r>
-          </a:p>
-          <a:p>
+              <a:t>Blend Filament</a:t>
+            </a:r>
+            <a:r>
+              <a:rPr lang="ja-JP" altLang="ja-JP" sz="1000" dirty="0">
+                <a:latin typeface="IBM Plex Sans JP" panose="020B0503050203000203" pitchFamily="50" charset="-128"/>
+                <a:ea typeface="IBM Plex Sans JP" panose="020B0503050203000203" pitchFamily="50" charset="-128"/>
+              </a:rPr>
+              <a:t>シリーズは</a:t>
+            </a:r>
             <a:r>
               <a:rPr lang="en-US" altLang="ja-JP" sz="1000" dirty="0">
                 <a:latin typeface="IBM Plex Sans JP" panose="020B0503050203000203" pitchFamily="50" charset="-128"/>
                 <a:ea typeface="IBM Plex Sans JP" panose="020B0503050203000203" pitchFamily="50" charset="-128"/>
               </a:rPr>
-              <a:t>Each model supports blend ratios from 50% to 99.5</a:t>
+              <a:t>FlexChroma</a:t>
+            </a:r>
+            <a:r>
+              <a:rPr lang="ja-JP" altLang="ja-JP" sz="1000" dirty="0">
+                <a:latin typeface="IBM Plex Sans JP" panose="020B0503050203000203" pitchFamily="50" charset="-128"/>
+                <a:ea typeface="IBM Plex Sans JP" panose="020B0503050203000203" pitchFamily="50" charset="-128"/>
+              </a:rPr>
+              <a:t>の最も基礎的なシリーズです。</a:t>
+            </a:r>
+            <a:r>
+              <a:rPr lang="en-US" altLang="ja-JP" sz="1000" dirty="0">
+                <a:latin typeface="IBM Plex Sans JP" panose="020B0503050203000203" pitchFamily="50" charset="-128"/>
+                <a:ea typeface="IBM Plex Sans JP" panose="020B0503050203000203" pitchFamily="50" charset="-128"/>
+              </a:rPr>
+              <a:t>2</a:t>
+            </a:r>
+            <a:r>
+              <a:rPr lang="ja-JP" altLang="ja-JP" sz="1000" dirty="0">
+                <a:latin typeface="IBM Plex Sans JP" panose="020B0503050203000203" pitchFamily="50" charset="-128"/>
+                <a:ea typeface="IBM Plex Sans JP" panose="020B0503050203000203" pitchFamily="50" charset="-128"/>
+              </a:rPr>
+              <a:t>つのフィラメントを様々な混合比で混ぜ合わせ、あなただけの新しい色を作ることが出来ます。各モデルは</a:t>
+            </a:r>
+            <a:r>
+              <a:rPr lang="en-US" altLang="ja-JP" sz="1000" dirty="0">
+                <a:latin typeface="IBM Plex Sans JP" panose="020B0503050203000203" pitchFamily="50" charset="-128"/>
+                <a:ea typeface="IBM Plex Sans JP" panose="020B0503050203000203" pitchFamily="50" charset="-128"/>
+              </a:rPr>
+              <a:t>50</a:t>
+            </a:r>
+            <a:r>
+              <a:rPr lang="ja-JP" altLang="ja-JP" sz="1000" dirty="0">
+                <a:latin typeface="IBM Plex Sans JP" panose="020B0503050203000203" pitchFamily="50" charset="-128"/>
+                <a:ea typeface="IBM Plex Sans JP" panose="020B0503050203000203" pitchFamily="50" charset="-128"/>
+              </a:rPr>
+              <a:t>％～</a:t>
+            </a:r>
+            <a:r>
+              <a:rPr lang="en-US" altLang="ja-JP" sz="1000" dirty="0">
+                <a:latin typeface="IBM Plex Sans JP" panose="020B0503050203000203" pitchFamily="50" charset="-128"/>
+                <a:ea typeface="IBM Plex Sans JP" panose="020B0503050203000203" pitchFamily="50" charset="-128"/>
+              </a:rPr>
+              <a:t>99.5%</a:t>
+            </a:r>
+            <a:r>
+              <a:rPr lang="ja-JP" altLang="ja-JP" sz="1000" dirty="0">
+                <a:latin typeface="IBM Plex Sans JP" panose="020B0503050203000203" pitchFamily="50" charset="-128"/>
+                <a:ea typeface="IBM Plex Sans JP" panose="020B0503050203000203" pitchFamily="50" charset="-128"/>
+              </a:rPr>
+              <a:t>までの混色比</a:t>
+            </a:r>
+            <a:r>
+              <a:rPr lang="en-US" altLang="ja-JP" sz="1000" dirty="0">
+                <a:latin typeface="IBM Plex Sans JP" panose="020B0503050203000203" pitchFamily="50" charset="-128"/>
+                <a:ea typeface="IBM Plex Sans JP" panose="020B0503050203000203" pitchFamily="50" charset="-128"/>
+              </a:rPr>
+              <a:t>Profile</a:t>
+            </a:r>
+            <a:r>
+              <a:rPr lang="ja-JP" altLang="ja-JP" sz="1000" dirty="0">
+                <a:latin typeface="IBM Plex Sans JP" panose="020B0503050203000203" pitchFamily="50" charset="-128"/>
+                <a:ea typeface="IBM Plex Sans JP" panose="020B0503050203000203" pitchFamily="50" charset="-128"/>
+              </a:rPr>
+              <a:t>をもっていますが、</a:t>
             </a:r>
             <a:r>
               <a:rPr lang="en-US" altLang="ja-JP" sz="1000" b="1" dirty="0">
                 <a:latin typeface="IBM Plex Sans JP" panose="020B0503050203000203" pitchFamily="50" charset="-128"/>
                 <a:ea typeface="IBM Plex Sans JP" panose="020B0503050203000203" pitchFamily="50" charset="-128"/>
               </a:rPr>
-              <a:t>%. For ratios below 50%, simply swap Filament A and Filament B.</a:t>
-            </a:r>
-          </a:p>
-          <a:p>
-            <a:endParaRPr lang="en-US" altLang="ja-JP" sz="1000" dirty="0">
+              <a:t>50</a:t>
+            </a:r>
+            <a:r>
+              <a:rPr lang="ja-JP" altLang="ja-JP" sz="1000" b="1" dirty="0">
+                <a:latin typeface="IBM Plex Sans JP" panose="020B0503050203000203" pitchFamily="50" charset="-128"/>
+                <a:ea typeface="IBM Plex Sans JP" panose="020B0503050203000203" pitchFamily="50" charset="-128"/>
+              </a:rPr>
+              <a:t>％未満の混色比についてはフィラメント</a:t>
+            </a:r>
+            <a:r>
+              <a:rPr lang="en-US" altLang="ja-JP" sz="1000" b="1" dirty="0">
+                <a:latin typeface="IBM Plex Sans JP" panose="020B0503050203000203" pitchFamily="50" charset="-128"/>
+                <a:ea typeface="IBM Plex Sans JP" panose="020B0503050203000203" pitchFamily="50" charset="-128"/>
+              </a:rPr>
+              <a:t>A/B</a:t>
+            </a:r>
+            <a:r>
+              <a:rPr lang="ja-JP" altLang="ja-JP" sz="1000" b="1" dirty="0">
+                <a:latin typeface="IBM Plex Sans JP" panose="020B0503050203000203" pitchFamily="50" charset="-128"/>
+                <a:ea typeface="IBM Plex Sans JP" panose="020B0503050203000203" pitchFamily="50" charset="-128"/>
+              </a:rPr>
+              <a:t>を入れ替えることで得ることが出来ます。</a:t>
+            </a:r>
+            <a:endParaRPr lang="ja-JP" altLang="ja-JP" sz="1000" dirty="0">
               <a:latin typeface="IBM Plex Sans JP" panose="020B0503050203000203" pitchFamily="50" charset="-128"/>
               <a:ea typeface="IBM Plex Sans JP" panose="020B0503050203000203" pitchFamily="50" charset="-128"/>
             </a:endParaRPr>
@@ -6145,12 +6624,93 @@
                 <a:latin typeface="IBM Plex Sans JP" panose="020B0503050203000203" pitchFamily="50" charset="-128"/>
                 <a:ea typeface="IBM Plex Sans JP" panose="020B0503050203000203" pitchFamily="50" charset="-128"/>
               </a:rPr>
-              <a:t>Example: To create a filament with 25% cyan mixed into yellow, read the Plate value as the ratio of Filament A, interpret it as 75% yellow, and slice the model accordingly.</a:t>
-            </a:r>
-            <a:endParaRPr kumimoji="1" lang="ja-JP" altLang="en-US" sz="1000" b="1" dirty="0">
+              <a:t> </a:t>
+            </a:r>
+            <a:endParaRPr lang="ja-JP" altLang="ja-JP" sz="1000" dirty="0">
               <a:latin typeface="IBM Plex Sans JP" panose="020B0503050203000203" pitchFamily="50" charset="-128"/>
               <a:ea typeface="IBM Plex Sans JP" panose="020B0503050203000203" pitchFamily="50" charset="-128"/>
             </a:endParaRPr>
+          </a:p>
+          <a:p>
+            <a:r>
+              <a:rPr lang="ja-JP" altLang="ja-JP" sz="1000" dirty="0">
+                <a:latin typeface="IBM Plex Sans JP" panose="020B0503050203000203" pitchFamily="50" charset="-128"/>
+                <a:ea typeface="IBM Plex Sans JP" panose="020B0503050203000203" pitchFamily="50" charset="-128"/>
+              </a:rPr>
+              <a:t>以下はイエローにシアンを</a:t>
+            </a:r>
+            <a:r>
+              <a:rPr lang="en-US" altLang="ja-JP" sz="1000" dirty="0">
+                <a:latin typeface="IBM Plex Sans JP" panose="020B0503050203000203" pitchFamily="50" charset="-128"/>
+                <a:ea typeface="IBM Plex Sans JP" panose="020B0503050203000203" pitchFamily="50" charset="-128"/>
+              </a:rPr>
+              <a:t>25%</a:t>
+            </a:r>
+            <a:r>
+              <a:rPr lang="ja-JP" altLang="ja-JP" sz="1000" dirty="0">
+                <a:latin typeface="IBM Plex Sans JP" panose="020B0503050203000203" pitchFamily="50" charset="-128"/>
+                <a:ea typeface="IBM Plex Sans JP" panose="020B0503050203000203" pitchFamily="50" charset="-128"/>
+              </a:rPr>
+              <a:t>混ぜた</a:t>
+            </a:r>
+            <a:r>
+              <a:rPr lang="en-US" altLang="ja-JP" sz="1000" dirty="0">
+                <a:latin typeface="IBM Plex Sans JP" panose="020B0503050203000203" pitchFamily="50" charset="-128"/>
+                <a:ea typeface="IBM Plex Sans JP" panose="020B0503050203000203" pitchFamily="50" charset="-128"/>
+              </a:rPr>
+              <a:t>Blend Filament</a:t>
+            </a:r>
+            <a:r>
+              <a:rPr lang="ja-JP" altLang="ja-JP" sz="1000" dirty="0">
+                <a:latin typeface="IBM Plex Sans JP" panose="020B0503050203000203" pitchFamily="50" charset="-128"/>
+                <a:ea typeface="IBM Plex Sans JP" panose="020B0503050203000203" pitchFamily="50" charset="-128"/>
+              </a:rPr>
+              <a:t>を作る場合の例です。</a:t>
+            </a:r>
+          </a:p>
+          <a:p>
+            <a:r>
+              <a:rPr lang="en-US" altLang="ja-JP" sz="1000" dirty="0">
+                <a:latin typeface="IBM Plex Sans JP" panose="020B0503050203000203" pitchFamily="50" charset="-128"/>
+                <a:ea typeface="IBM Plex Sans JP" panose="020B0503050203000203" pitchFamily="50" charset="-128"/>
+              </a:rPr>
+              <a:t>Plate</a:t>
+            </a:r>
+            <a:r>
+              <a:rPr lang="ja-JP" altLang="ja-JP" sz="1000" dirty="0">
+                <a:latin typeface="IBM Plex Sans JP" panose="020B0503050203000203" pitchFamily="50" charset="-128"/>
+                <a:ea typeface="IBM Plex Sans JP" panose="020B0503050203000203" pitchFamily="50" charset="-128"/>
+              </a:rPr>
+              <a:t>に記載されている数値はフィラメント</a:t>
+            </a:r>
+            <a:r>
+              <a:rPr lang="en-US" altLang="ja-JP" sz="1000" dirty="0">
+                <a:latin typeface="IBM Plex Sans JP" panose="020B0503050203000203" pitchFamily="50" charset="-128"/>
+                <a:ea typeface="IBM Plex Sans JP" panose="020B0503050203000203" pitchFamily="50" charset="-128"/>
+              </a:rPr>
+              <a:t>A</a:t>
+            </a:r>
+            <a:r>
+              <a:rPr lang="ja-JP" altLang="ja-JP" sz="1000" dirty="0">
+                <a:latin typeface="IBM Plex Sans JP" panose="020B0503050203000203" pitchFamily="50" charset="-128"/>
+                <a:ea typeface="IBM Plex Sans JP" panose="020B0503050203000203" pitchFamily="50" charset="-128"/>
+              </a:rPr>
+              <a:t>の割合です。そのためこの例ではイエローを</a:t>
+            </a:r>
+            <a:r>
+              <a:rPr lang="en-US" altLang="ja-JP" sz="1000" dirty="0">
+                <a:latin typeface="IBM Plex Sans JP" panose="020B0503050203000203" pitchFamily="50" charset="-128"/>
+                <a:ea typeface="IBM Plex Sans JP" panose="020B0503050203000203" pitchFamily="50" charset="-128"/>
+              </a:rPr>
+              <a:t>75%</a:t>
+            </a:r>
+            <a:r>
+              <a:rPr lang="ja-JP" altLang="ja-JP" sz="1000" dirty="0">
+                <a:latin typeface="IBM Plex Sans JP" panose="020B0503050203000203" pitchFamily="50" charset="-128"/>
+                <a:ea typeface="IBM Plex Sans JP" panose="020B0503050203000203" pitchFamily="50" charset="-128"/>
+              </a:rPr>
+              <a:t>にすると読み替えて、スライスまでのの設定を選びます。</a:t>
+            </a:r>
           </a:p>
         </p:txBody>
       </p:sp>
@@ -6168,7 +6728,7 @@
         </p:nvSpPr>
         <p:spPr>
           <a:xfrm>
-            <a:off x="668508" y="5046262"/>
+            <a:off x="668508" y="5070646"/>
             <a:ext cx="5642222" cy="246221"/>
           </a:xfrm>
           <a:prstGeom prst="rect">
@@ -6183,11 +6743,25 @@
           <a:lstStyle/>
           <a:p>
             <a:r>
+              <a:rPr lang="ja-JP" altLang="ja-JP" sz="1000" dirty="0">
+                <a:latin typeface="IBM Plex Sans JP" panose="020B0503050203000203" pitchFamily="50" charset="-128"/>
+                <a:ea typeface="IBM Plex Sans JP" panose="020B0503050203000203" pitchFamily="50" charset="-128"/>
+              </a:rPr>
+              <a:t>以下は</a:t>
+            </a:r>
+            <a:r>
               <a:rPr lang="en-US" altLang="ja-JP" sz="1000" dirty="0">
                 <a:latin typeface="IBM Plex Sans JP" panose="020B0503050203000203" pitchFamily="50" charset="-128"/>
                 <a:ea typeface="IBM Plex Sans JP" panose="020B0503050203000203" pitchFamily="50" charset="-128"/>
               </a:rPr>
-              <a:t>The following is the model configuration for Blend Filament.</a:t>
+              <a:t>Blend Filament</a:t>
+            </a:r>
+            <a:r>
+              <a:rPr lang="ja-JP" altLang="ja-JP" sz="1000" dirty="0">
+                <a:latin typeface="IBM Plex Sans JP" panose="020B0503050203000203" pitchFamily="50" charset="-128"/>
+                <a:ea typeface="IBM Plex Sans JP" panose="020B0503050203000203" pitchFamily="50" charset="-128"/>
+              </a:rPr>
+              <a:t>のモデル構成です。</a:t>
             </a:r>
           </a:p>
         </p:txBody>
@@ -6221,7 +6795,7 @@
         </p:blipFill>
         <p:spPr bwMode="auto">
           <a:xfrm>
-            <a:off x="770844" y="5325050"/>
+            <a:off x="770844" y="5337242"/>
             <a:ext cx="5264196" cy="3270393"/>
           </a:xfrm>
           <a:prstGeom prst="rect">
@@ -6261,7 +6835,7 @@
         </p:blipFill>
         <p:spPr>
           <a:xfrm>
-            <a:off x="709884" y="4100534"/>
+            <a:off x="709884" y="4161494"/>
             <a:ext cx="5325156" cy="831813"/>
           </a:xfrm>
           <a:prstGeom prst="rect">
@@ -6298,7 +6872,7 @@
         </p:blipFill>
         <p:spPr bwMode="auto">
           <a:xfrm>
-            <a:off x="1091915" y="1374795"/>
+            <a:off x="1091915" y="1338219"/>
             <a:ext cx="4561094" cy="1014727"/>
           </a:xfrm>
           <a:prstGeom prst="rect">
@@ -6901,7 +7475,7 @@
             <a:pPr algn="ctr"/>
             <a:r>
               <a:rPr kumimoji="1" lang="en-US" altLang="ja-JP" dirty="0"/>
-              <a:t>2</a:t>
+              <a:t>3</a:t>
             </a:r>
             <a:endParaRPr kumimoji="1" lang="ja-JP" altLang="en-US" dirty="0"/>
           </a:p>
@@ -6967,7 +7541,7 @@
         </p:nvSpPr>
         <p:spPr>
           <a:xfrm>
-            <a:off x="546348" y="7301051"/>
+            <a:off x="546348" y="7885537"/>
             <a:ext cx="204669" cy="204669"/>
           </a:xfrm>
           <a:prstGeom prst="ellipse">
@@ -7056,7 +7630,7 @@
         <p:spPr>
           <a:xfrm>
             <a:off x="668508" y="1032957"/>
-            <a:ext cx="5649491" cy="861774"/>
+            <a:ext cx="5649491" cy="1661993"/>
           </a:xfrm>
           <a:prstGeom prst="rect">
             <a:avLst/>
@@ -7074,22 +7648,227 @@
                 <a:latin typeface="IBM Plex Sans JP" panose="020B0503050203000203" pitchFamily="50" charset="-128"/>
                 <a:ea typeface="IBM Plex Sans JP" panose="020B0503050203000203" pitchFamily="50" charset="-128"/>
               </a:rPr>
-              <a:t>The Gradient Filament Series provides multiple color-changing Profiles and Plates with different cycle counts. Details vary by model, so please refer to each model’s description.</a:t>
-            </a:r>
-          </a:p>
-          <a:p>
-            <a:endParaRPr lang="en-US" altLang="ja-JP" sz="1000" dirty="0">
+              <a:t>Gradient Filament</a:t>
+            </a:r>
+            <a:r>
+              <a:rPr lang="ja-JP" altLang="ja-JP" sz="1000" dirty="0">
+                <a:latin typeface="IBM Plex Sans JP" panose="020B0503050203000203" pitchFamily="50" charset="-128"/>
+                <a:ea typeface="IBM Plex Sans JP" panose="020B0503050203000203" pitchFamily="50" charset="-128"/>
+              </a:rPr>
+              <a:t>シリーズは色の組み合わせに合わせた複数のカーブ</a:t>
+            </a:r>
+            <a:r>
+              <a:rPr lang="en-US" altLang="ja-JP" sz="1000" dirty="0">
+                <a:latin typeface="IBM Plex Sans JP" panose="020B0503050203000203" pitchFamily="50" charset="-128"/>
+                <a:ea typeface="IBM Plex Sans JP" panose="020B0503050203000203" pitchFamily="50" charset="-128"/>
+              </a:rPr>
+              <a:t>Profile</a:t>
+            </a:r>
+            <a:r>
+              <a:rPr lang="ja-JP" altLang="ja-JP" sz="1000" dirty="0">
+                <a:latin typeface="IBM Plex Sans JP" panose="020B0503050203000203" pitchFamily="50" charset="-128"/>
+                <a:ea typeface="IBM Plex Sans JP" panose="020B0503050203000203" pitchFamily="50" charset="-128"/>
+              </a:rPr>
+              <a:t>とプレートごとにサイクル数が違うモデルを持っています。詳細は各モデルの説明文をご確認ください。</a:t>
+            </a:r>
+          </a:p>
+          <a:p>
+            <a:r>
+              <a:rPr lang="en-US" altLang="ja-JP" sz="600" dirty="0">
+                <a:latin typeface="IBM Plex Sans JP" panose="020B0503050203000203" pitchFamily="50" charset="-128"/>
+                <a:ea typeface="IBM Plex Sans JP" panose="020B0503050203000203" pitchFamily="50" charset="-128"/>
+              </a:rPr>
+              <a:t> </a:t>
+            </a:r>
+          </a:p>
+          <a:p>
+            <a:pPr marL="171450" indent="-171450">
+              <a:buFont typeface="Arial" panose="020B0604020202020204" pitchFamily="34" charset="0"/>
+              <a:buChar char="•"/>
+            </a:pPr>
+            <a:r>
+              <a:rPr lang="ja-JP" altLang="ja-JP" sz="900" dirty="0">
+                <a:latin typeface="IBM Plex Sans JP" panose="020B0503050203000203" pitchFamily="50" charset="-128"/>
+                <a:ea typeface="IBM Plex Sans JP" panose="020B0503050203000203" pitchFamily="50" charset="-128"/>
+              </a:rPr>
+              <a:t>カラーカーブ：色の組み合わせに応じた設定。シアンとイエローならば</a:t>
+            </a:r>
+            <a:r>
+              <a:rPr lang="en-US" altLang="ja-JP" sz="900" dirty="0">
+                <a:latin typeface="IBM Plex Sans JP" panose="020B0503050203000203" pitchFamily="50" charset="-128"/>
+                <a:ea typeface="IBM Plex Sans JP" panose="020B0503050203000203" pitchFamily="50" charset="-128"/>
+              </a:rPr>
+              <a:t>Vivid</a:t>
+            </a:r>
+            <a:r>
+              <a:rPr lang="ja-JP" altLang="ja-JP" sz="900" dirty="0">
+                <a:latin typeface="IBM Plex Sans JP" panose="020B0503050203000203" pitchFamily="50" charset="-128"/>
+                <a:ea typeface="IBM Plex Sans JP" panose="020B0503050203000203" pitchFamily="50" charset="-128"/>
+              </a:rPr>
+              <a:t>、白とマゼンタならば</a:t>
+            </a:r>
+            <a:r>
+              <a:rPr lang="en-US" altLang="ja-JP" sz="900" dirty="0">
+                <a:latin typeface="IBM Plex Sans JP" panose="020B0503050203000203" pitchFamily="50" charset="-128"/>
+                <a:ea typeface="IBM Plex Sans JP" panose="020B0503050203000203" pitchFamily="50" charset="-128"/>
+              </a:rPr>
+              <a:t>Contrast</a:t>
+            </a:r>
+            <a:r>
+              <a:rPr lang="ja-JP" altLang="ja-JP" sz="900" dirty="0">
+                <a:latin typeface="IBM Plex Sans JP" panose="020B0503050203000203" pitchFamily="50" charset="-128"/>
+                <a:ea typeface="IBM Plex Sans JP" panose="020B0503050203000203" pitchFamily="50" charset="-128"/>
+              </a:rPr>
+              <a:t>と言う風に色に応じた最適なグラデーションを選ぶための項目。</a:t>
+            </a:r>
+          </a:p>
+          <a:p>
+            <a:pPr marL="171450" indent="-171450">
+              <a:buFont typeface="Arial" panose="020B0604020202020204" pitchFamily="34" charset="0"/>
+              <a:buChar char="•"/>
+            </a:pPr>
+            <a:r>
+              <a:rPr lang="ja-JP" altLang="ja-JP" sz="900" dirty="0">
+                <a:latin typeface="IBM Plex Sans JP" panose="020B0503050203000203" pitchFamily="50" charset="-128"/>
+                <a:ea typeface="IBM Plex Sans JP" panose="020B0503050203000203" pitchFamily="50" charset="-128"/>
+              </a:rPr>
+              <a:t>サイクル数：グラデーションの頻度を変える数。サイクル数はフィラメントが</a:t>
+            </a:r>
+            <a:r>
+              <a:rPr lang="en-US" altLang="ja-JP" sz="900" dirty="0">
+                <a:latin typeface="IBM Plex Sans JP" panose="020B0503050203000203" pitchFamily="50" charset="-128"/>
+                <a:ea typeface="IBM Plex Sans JP" panose="020B0503050203000203" pitchFamily="50" charset="-128"/>
+              </a:rPr>
+              <a:t>A</a:t>
+            </a:r>
+            <a:r>
+              <a:rPr lang="ja-JP" altLang="ja-JP" sz="900" dirty="0">
+                <a:latin typeface="IBM Plex Sans JP" panose="020B0503050203000203" pitchFamily="50" charset="-128"/>
+                <a:ea typeface="IBM Plex Sans JP" panose="020B0503050203000203" pitchFamily="50" charset="-128"/>
+              </a:rPr>
+              <a:t>→</a:t>
+            </a:r>
+            <a:r>
+              <a:rPr lang="en-US" altLang="ja-JP" sz="900" dirty="0">
+                <a:latin typeface="IBM Plex Sans JP" panose="020B0503050203000203" pitchFamily="50" charset="-128"/>
+                <a:ea typeface="IBM Plex Sans JP" panose="020B0503050203000203" pitchFamily="50" charset="-128"/>
+              </a:rPr>
+              <a:t>B</a:t>
+            </a:r>
+            <a:r>
+              <a:rPr lang="ja-JP" altLang="ja-JP" sz="900" dirty="0">
+                <a:latin typeface="IBM Plex Sans JP" panose="020B0503050203000203" pitchFamily="50" charset="-128"/>
+                <a:ea typeface="IBM Plex Sans JP" panose="020B0503050203000203" pitchFamily="50" charset="-128"/>
+              </a:rPr>
+              <a:t>→</a:t>
+            </a:r>
+            <a:r>
+              <a:rPr lang="en-US" altLang="ja-JP" sz="900" dirty="0">
+                <a:latin typeface="IBM Plex Sans JP" panose="020B0503050203000203" pitchFamily="50" charset="-128"/>
+                <a:ea typeface="IBM Plex Sans JP" panose="020B0503050203000203" pitchFamily="50" charset="-128"/>
+              </a:rPr>
+              <a:t>A</a:t>
+            </a:r>
+            <a:r>
+              <a:rPr lang="ja-JP" altLang="ja-JP" sz="900" dirty="0">
+                <a:latin typeface="IBM Plex Sans JP" panose="020B0503050203000203" pitchFamily="50" charset="-128"/>
+                <a:ea typeface="IBM Plex Sans JP" panose="020B0503050203000203" pitchFamily="50" charset="-128"/>
+              </a:rPr>
+              <a:t>と変化して戻ることを</a:t>
+            </a:r>
+            <a:r>
+              <a:rPr lang="en-US" altLang="ja-JP" sz="900" dirty="0">
+                <a:latin typeface="IBM Plex Sans JP" panose="020B0503050203000203" pitchFamily="50" charset="-128"/>
+                <a:ea typeface="IBM Plex Sans JP" panose="020B0503050203000203" pitchFamily="50" charset="-128"/>
+              </a:rPr>
+              <a:t>1</a:t>
+            </a:r>
+            <a:r>
+              <a:rPr lang="ja-JP" altLang="ja-JP" sz="900" dirty="0">
+                <a:latin typeface="IBM Plex Sans JP" panose="020B0503050203000203" pitchFamily="50" charset="-128"/>
+                <a:ea typeface="IBM Plex Sans JP" panose="020B0503050203000203" pitchFamily="50" charset="-128"/>
+              </a:rPr>
+              <a:t>回と数える。</a:t>
+            </a:r>
+          </a:p>
+          <a:p>
+            <a:endParaRPr lang="ja-JP" altLang="ja-JP" sz="600" dirty="0">
               <a:latin typeface="IBM Plex Sans JP" panose="020B0503050203000203" pitchFamily="50" charset="-128"/>
               <a:ea typeface="IBM Plex Sans JP" panose="020B0503050203000203" pitchFamily="50" charset="-128"/>
             </a:endParaRPr>
           </a:p>
           <a:p>
             <a:r>
+              <a:rPr lang="ja-JP" altLang="ja-JP" sz="1000" dirty="0">
+                <a:latin typeface="IBM Plex Sans JP" panose="020B0503050203000203" pitchFamily="50" charset="-128"/>
+                <a:ea typeface="IBM Plex Sans JP" panose="020B0503050203000203" pitchFamily="50" charset="-128"/>
+              </a:rPr>
+              <a:t>以下はシアンとマゼンタの速い周期の</a:t>
+            </a:r>
+            <a:r>
               <a:rPr lang="en-US" altLang="ja-JP" sz="1000" dirty="0">
                 <a:latin typeface="IBM Plex Sans JP" panose="020B0503050203000203" pitchFamily="50" charset="-128"/>
                 <a:ea typeface="IBM Plex Sans JP" panose="020B0503050203000203" pitchFamily="50" charset="-128"/>
               </a:rPr>
-              <a:t>Example: To create a fast-cycle gradient filament using cyan and magenta, select an S4 Model, choose a 4-cycle Plate, and use the Vivid curve Profile due to the high color contrast.</a:t>
+              <a:t>Gradient Filament</a:t>
+            </a:r>
+            <a:r>
+              <a:rPr lang="ja-JP" altLang="ja-JP" sz="1000" dirty="0">
+                <a:latin typeface="IBM Plex Sans JP" panose="020B0503050203000203" pitchFamily="50" charset="-128"/>
+                <a:ea typeface="IBM Plex Sans JP" panose="020B0503050203000203" pitchFamily="50" charset="-128"/>
+              </a:rPr>
+              <a:t>を作る場合の例です。</a:t>
+            </a:r>
+          </a:p>
+          <a:p>
+            <a:r>
+              <a:rPr lang="ja-JP" altLang="ja-JP" sz="1000" dirty="0">
+                <a:latin typeface="IBM Plex Sans JP" panose="020B0503050203000203" pitchFamily="50" charset="-128"/>
+                <a:ea typeface="IBM Plex Sans JP" panose="020B0503050203000203" pitchFamily="50" charset="-128"/>
+              </a:rPr>
+              <a:t>周期はモデルサイズとサイクル数に影響されます。そのため、</a:t>
+            </a:r>
+            <a:r>
+              <a:rPr lang="en-US" altLang="ja-JP" sz="1000" dirty="0">
+                <a:latin typeface="IBM Plex Sans JP" panose="020B0503050203000203" pitchFamily="50" charset="-128"/>
+                <a:ea typeface="IBM Plex Sans JP" panose="020B0503050203000203" pitchFamily="50" charset="-128"/>
+              </a:rPr>
+              <a:t>S4</a:t>
+            </a:r>
+            <a:r>
+              <a:rPr lang="ja-JP" altLang="ja-JP" sz="1000" dirty="0">
+                <a:latin typeface="IBM Plex Sans JP" panose="020B0503050203000203" pitchFamily="50" charset="-128"/>
+                <a:ea typeface="IBM Plex Sans JP" panose="020B0503050203000203" pitchFamily="50" charset="-128"/>
+              </a:rPr>
+              <a:t>のモデルを選び、サイクル数は</a:t>
+            </a:r>
+            <a:r>
+              <a:rPr lang="en-US" altLang="ja-JP" sz="1000" dirty="0">
+                <a:latin typeface="IBM Plex Sans JP" panose="020B0503050203000203" pitchFamily="50" charset="-128"/>
+                <a:ea typeface="IBM Plex Sans JP" panose="020B0503050203000203" pitchFamily="50" charset="-128"/>
+              </a:rPr>
+              <a:t>4</a:t>
+            </a:r>
+            <a:r>
+              <a:rPr lang="ja-JP" altLang="ja-JP" sz="1000" dirty="0">
+                <a:latin typeface="IBM Plex Sans JP" panose="020B0503050203000203" pitchFamily="50" charset="-128"/>
+                <a:ea typeface="IBM Plex Sans JP" panose="020B0503050203000203" pitchFamily="50" charset="-128"/>
+              </a:rPr>
+              <a:t>サイクルを選ぶこととします。また、色相の離れた組合せなので</a:t>
+            </a:r>
+            <a:r>
+              <a:rPr lang="en-US" altLang="ja-JP" sz="1000" dirty="0">
+                <a:latin typeface="IBM Plex Sans JP" panose="020B0503050203000203" pitchFamily="50" charset="-128"/>
+                <a:ea typeface="IBM Plex Sans JP" panose="020B0503050203000203" pitchFamily="50" charset="-128"/>
+              </a:rPr>
+              <a:t>Vivid</a:t>
+            </a:r>
+            <a:r>
+              <a:rPr lang="ja-JP" altLang="ja-JP" sz="1000" dirty="0">
+                <a:latin typeface="IBM Plex Sans JP" panose="020B0503050203000203" pitchFamily="50" charset="-128"/>
+                <a:ea typeface="IBM Plex Sans JP" panose="020B0503050203000203" pitchFamily="50" charset="-128"/>
+              </a:rPr>
+              <a:t>カーブを選びます。</a:t>
             </a:r>
             <a:endParaRPr kumimoji="1" lang="ja-JP" altLang="en-US" sz="1000" b="1" dirty="0">
               <a:latin typeface="IBM Plex Sans JP" panose="020B0503050203000203" pitchFamily="50" charset="-128"/>
@@ -7112,7 +7891,7 @@
         </p:nvSpPr>
         <p:spPr>
           <a:xfrm>
-            <a:off x="675778" y="3011477"/>
+            <a:off x="675778" y="3595963"/>
             <a:ext cx="5642222" cy="246221"/>
           </a:xfrm>
           <a:prstGeom prst="rect">
@@ -7127,12 +7906,30 @@
           <a:lstStyle/>
           <a:p>
             <a:r>
+              <a:rPr lang="ja-JP" altLang="ja-JP" sz="1000" dirty="0">
+                <a:latin typeface="IBM Plex Sans JP" panose="020B0503050203000203" pitchFamily="50" charset="-128"/>
+                <a:ea typeface="IBM Plex Sans JP" panose="020B0503050203000203" pitchFamily="50" charset="-128"/>
+              </a:rPr>
+              <a:t>以下は</a:t>
+            </a:r>
+            <a:r>
               <a:rPr lang="en-US" altLang="ja-JP" sz="1000" dirty="0">
                 <a:latin typeface="IBM Plex Sans JP" panose="020B0503050203000203" pitchFamily="50" charset="-128"/>
                 <a:ea typeface="IBM Plex Sans JP" panose="020B0503050203000203" pitchFamily="50" charset="-128"/>
               </a:rPr>
-              <a:t>The following is the model configuration for Gradient Filament.</a:t>
-            </a:r>
+              <a:t>Gradient Filament</a:t>
+            </a:r>
+            <a:r>
+              <a:rPr lang="ja-JP" altLang="ja-JP" sz="1000" dirty="0">
+                <a:latin typeface="IBM Plex Sans JP" panose="020B0503050203000203" pitchFamily="50" charset="-128"/>
+                <a:ea typeface="IBM Plex Sans JP" panose="020B0503050203000203" pitchFamily="50" charset="-128"/>
+              </a:rPr>
+              <a:t>のモデル構成です。</a:t>
+            </a:r>
+            <a:endParaRPr lang="en-US" altLang="ja-JP" sz="1000" dirty="0">
+              <a:latin typeface="IBM Plex Sans JP" panose="020B0503050203000203" pitchFamily="50" charset="-128"/>
+              <a:ea typeface="IBM Plex Sans JP" panose="020B0503050203000203" pitchFamily="50" charset="-128"/>
+            </a:endParaRPr>
           </a:p>
         </p:txBody>
       </p:sp>
@@ -7150,7 +7947,7 @@
         </p:nvSpPr>
         <p:spPr>
           <a:xfrm>
-            <a:off x="778114" y="7268269"/>
+            <a:off x="778114" y="7852755"/>
             <a:ext cx="1923925" cy="338554"/>
           </a:xfrm>
           <a:prstGeom prst="rect">
@@ -7192,7 +7989,7 @@
         </p:nvSpPr>
         <p:spPr>
           <a:xfrm>
-            <a:off x="638323" y="7599215"/>
+            <a:off x="638323" y="8183701"/>
             <a:ext cx="5649491" cy="507831"/>
           </a:xfrm>
           <a:prstGeom prst="rect">
@@ -7253,7 +8050,7 @@
         </p:blipFill>
         <p:spPr>
           <a:xfrm>
-            <a:off x="633073" y="1909692"/>
+            <a:off x="651740" y="2635456"/>
             <a:ext cx="5588622" cy="913760"/>
           </a:xfrm>
           <a:prstGeom prst="rect">
@@ -7263,49 +8060,32 @@
       </p:pic>
       <p:pic>
         <p:nvPicPr>
-          <p:cNvPr id="37" name="図 36">
+          <p:cNvPr id="3" name="図 2">
             <a:extLst>
               <a:ext uri="{FF2B5EF4-FFF2-40B4-BE49-F238E27FC236}">
-                <a16:creationId xmlns:a16="http://schemas.microsoft.com/office/drawing/2014/main" id="{B45BD161-DA0D-5CE8-8162-DC38C4F2F313}"/>
+                <a16:creationId xmlns:a16="http://schemas.microsoft.com/office/drawing/2014/main" id="{90B206C3-D203-72F8-F7D7-2E6905097490}"/>
               </a:ext>
             </a:extLst>
           </p:cNvPr>
           <p:cNvPicPr>
-            <a:picLocks noChangeAspect="1" noChangeArrowheads="1"/>
+            <a:picLocks noChangeAspect="1"/>
           </p:cNvPicPr>
           <p:nvPr/>
         </p:nvPicPr>
         <p:blipFill>
-          <a:blip r:embed="rId3">
-            <a:extLst>
-              <a:ext uri="{28A0092B-C50C-407E-A947-70E740481C1C}">
-                <a14:useLocalDpi xmlns:a14="http://schemas.microsoft.com/office/drawing/2010/main" val="0"/>
-              </a:ext>
-            </a:extLst>
-          </a:blip>
-          <a:srcRect/>
+          <a:blip r:embed="rId3"/>
           <a:stretch>
             <a:fillRect/>
           </a:stretch>
         </p:blipFill>
-        <p:spPr bwMode="auto">
+        <p:spPr>
           <a:xfrm>
-            <a:off x="587545" y="3188861"/>
-            <a:ext cx="5679677" cy="4002590"/>
+            <a:off x="673091" y="3861186"/>
+            <a:ext cx="5521536" cy="3874587"/>
           </a:xfrm>
           <a:prstGeom prst="rect">
             <a:avLst/>
           </a:prstGeom>
-          <a:noFill/>
-          <a:extLst>
-            <a:ext uri="{909E8E84-426E-40DD-AFC4-6F175D3DCCD1}">
-              <a14:hiddenFill xmlns:a14="http://schemas.microsoft.com/office/drawing/2010/main">
-                <a:solidFill>
-                  <a:srgbClr val="FFFFFF"/>
-                </a:solidFill>
-              </a14:hiddenFill>
-            </a:ext>
-          </a:extLst>
         </p:spPr>
       </p:pic>
     </p:spTree>
@@ -7329,7 +8109,7 @@
         <p:cNvPr id="1" name="">
           <a:extLst>
             <a:ext uri="{FF2B5EF4-FFF2-40B4-BE49-F238E27FC236}">
-              <a16:creationId xmlns:a16="http://schemas.microsoft.com/office/drawing/2014/main" id="{CD5DA673-1F6D-3E89-385D-51C4D771A791}"/>
+              <a16:creationId xmlns:a16="http://schemas.microsoft.com/office/drawing/2014/main" id="{90487F66-0A0B-6622-A328-4A7360C8DA39}"/>
             </a:ext>
           </a:extLst>
         </p:cNvPr>
@@ -7346,10 +8126,10 @@
       </p:grpSpPr>
       <p:sp>
         <p:nvSpPr>
-          <p:cNvPr id="3" name="正方形/長方形 2">
+          <p:cNvPr id="32" name="正方形/長方形 31">
             <a:extLst>
               <a:ext uri="{FF2B5EF4-FFF2-40B4-BE49-F238E27FC236}">
-                <a16:creationId xmlns:a16="http://schemas.microsoft.com/office/drawing/2014/main" id="{1DEFF187-2596-B65B-91B7-01BEB260E707}"/>
+                <a16:creationId xmlns:a16="http://schemas.microsoft.com/office/drawing/2014/main" id="{4FE2919F-4F03-BDC6-637C-54F859753550}"/>
               </a:ext>
             </a:extLst>
           </p:cNvPr>
@@ -7358,8 +8138,8 @@
         </p:nvSpPr>
         <p:spPr>
           <a:xfrm>
-            <a:off x="33951" y="45268"/>
-            <a:ext cx="6790099" cy="9053465"/>
+            <a:off x="0" y="0"/>
+            <a:ext cx="6858000" cy="9144000"/>
           </a:xfrm>
           <a:prstGeom prst="rect">
             <a:avLst/>
@@ -7409,10 +8189,10 @@
       </p:sp>
       <p:sp>
         <p:nvSpPr>
-          <p:cNvPr id="37" name="フリーフォーム: 図形 36">
+          <p:cNvPr id="38" name="フリーフォーム: 図形 37">
             <a:extLst>
               <a:ext uri="{FF2B5EF4-FFF2-40B4-BE49-F238E27FC236}">
-                <a16:creationId xmlns:a16="http://schemas.microsoft.com/office/drawing/2014/main" id="{79E6D1D4-A113-BFE0-3263-F0A91EBC473E}"/>
+                <a16:creationId xmlns:a16="http://schemas.microsoft.com/office/drawing/2014/main" id="{D504B6B1-8153-95A1-10E9-DE35F2B8C185}"/>
               </a:ext>
             </a:extLst>
           </p:cNvPr>
@@ -7421,91 +8201,91 @@
         </p:nvSpPr>
         <p:spPr>
           <a:xfrm>
-            <a:off x="-1" y="9938"/>
-            <a:ext cx="6858000" cy="9144000"/>
+            <a:off x="0" y="0"/>
+            <a:ext cx="6865269" cy="9144000"/>
           </a:xfrm>
           <a:custGeom>
             <a:avLst/>
             <a:gdLst>
-              <a:gd name="connsiteX0" fmla="*/ 3734844 w 6858000"/>
+              <a:gd name="connsiteX0" fmla="*/ 3734844 w 6865269"/>
               <a:gd name="connsiteY0" fmla="*/ 8661917 h 9144000"/>
-              <a:gd name="connsiteX1" fmla="*/ 3734844 w 6858000"/>
+              <a:gd name="connsiteX1" fmla="*/ 3734844 w 6865269"/>
               <a:gd name="connsiteY1" fmla="*/ 8715917 h 9144000"/>
-              <a:gd name="connsiteX2" fmla="*/ 6326844 w 6858000"/>
+              <a:gd name="connsiteX2" fmla="*/ 6326844 w 6865269"/>
               <a:gd name="connsiteY2" fmla="*/ 8715917 h 9144000"/>
-              <a:gd name="connsiteX3" fmla="*/ 6326844 w 6858000"/>
+              <a:gd name="connsiteX3" fmla="*/ 6326844 w 6865269"/>
               <a:gd name="connsiteY3" fmla="*/ 8661917 h 9144000"/>
-              <a:gd name="connsiteX4" fmla="*/ 554538 w 6858000"/>
+              <a:gd name="connsiteX4" fmla="*/ 554538 w 6865269"/>
               <a:gd name="connsiteY4" fmla="*/ 8661917 h 9144000"/>
-              <a:gd name="connsiteX5" fmla="*/ 554538 w 6858000"/>
+              <a:gd name="connsiteX5" fmla="*/ 554538 w 6865269"/>
               <a:gd name="connsiteY5" fmla="*/ 8715917 h 9144000"/>
-              <a:gd name="connsiteX6" fmla="*/ 3146538 w 6858000"/>
+              <a:gd name="connsiteX6" fmla="*/ 3146538 w 6865269"/>
               <a:gd name="connsiteY6" fmla="*/ 8715917 h 9144000"/>
-              <a:gd name="connsiteX7" fmla="*/ 3146538 w 6858000"/>
+              <a:gd name="connsiteX7" fmla="*/ 3146538 w 6865269"/>
               <a:gd name="connsiteY7" fmla="*/ 8661917 h 9144000"/>
-              <a:gd name="connsiteX8" fmla="*/ 668510 w 6858000"/>
-              <a:gd name="connsiteY8" fmla="*/ 4562351 h 9144000"/>
-              <a:gd name="connsiteX9" fmla="*/ 566175 w 6858000"/>
-              <a:gd name="connsiteY9" fmla="*/ 4664686 h 9144000"/>
-              <a:gd name="connsiteX10" fmla="*/ 668510 w 6858000"/>
-              <a:gd name="connsiteY10" fmla="*/ 4767021 h 9144000"/>
-              <a:gd name="connsiteX11" fmla="*/ 770845 w 6858000"/>
-              <a:gd name="connsiteY11" fmla="*/ 4664686 h 9144000"/>
-              <a:gd name="connsiteX12" fmla="*/ 668510 w 6858000"/>
-              <a:gd name="connsiteY12" fmla="*/ 4562351 h 9144000"/>
-              <a:gd name="connsiteX13" fmla="*/ 668510 w 6858000"/>
-              <a:gd name="connsiteY13" fmla="*/ 3069491 h 9144000"/>
-              <a:gd name="connsiteX14" fmla="*/ 566175 w 6858000"/>
-              <a:gd name="connsiteY14" fmla="*/ 3171826 h 9144000"/>
-              <a:gd name="connsiteX15" fmla="*/ 668510 w 6858000"/>
-              <a:gd name="connsiteY15" fmla="*/ 3274161 h 9144000"/>
-              <a:gd name="connsiteX16" fmla="*/ 770845 w 6858000"/>
-              <a:gd name="connsiteY16" fmla="*/ 3171826 h 9144000"/>
-              <a:gd name="connsiteX17" fmla="*/ 668510 w 6858000"/>
-              <a:gd name="connsiteY17" fmla="*/ 3069491 h 9144000"/>
-              <a:gd name="connsiteX18" fmla="*/ 1042027 w 6858000"/>
-              <a:gd name="connsiteY18" fmla="*/ 2161529 h 9144000"/>
-              <a:gd name="connsiteX19" fmla="*/ 1042026 w 6858000"/>
-              <a:gd name="connsiteY19" fmla="*/ 2308230 h 9144000"/>
-              <a:gd name="connsiteX20" fmla="*/ 1188728 w 6858000"/>
-              <a:gd name="connsiteY20" fmla="*/ 2454932 h 9144000"/>
-              <a:gd name="connsiteX21" fmla="*/ 5676539 w 6858000"/>
-              <a:gd name="connsiteY21" fmla="*/ 2454932 h 9144000"/>
-              <a:gd name="connsiteX22" fmla="*/ 5823241 w 6858000"/>
-              <a:gd name="connsiteY22" fmla="*/ 2308230 h 9144000"/>
-              <a:gd name="connsiteX23" fmla="*/ 5823241 w 6858000"/>
-              <a:gd name="connsiteY23" fmla="*/ 2163830 h 9144000"/>
-              <a:gd name="connsiteX24" fmla="*/ 5760740 w 6858000"/>
-              <a:gd name="connsiteY24" fmla="*/ 2226331 h 9144000"/>
-              <a:gd name="connsiteX25" fmla="*/ 1104528 w 6858000"/>
-              <a:gd name="connsiteY25" fmla="*/ 2226331 h 9144000"/>
-              <a:gd name="connsiteX26" fmla="*/ 1042027 w 6858000"/>
-              <a:gd name="connsiteY26" fmla="*/ 2163830 h 9144000"/>
-              <a:gd name="connsiteX27" fmla="*/ 1188728 w 6858000"/>
-              <a:gd name="connsiteY27" fmla="*/ 437295 h 9144000"/>
-              <a:gd name="connsiteX28" fmla="*/ 1042026 w 6858000"/>
-              <a:gd name="connsiteY28" fmla="*/ 583997 h 9144000"/>
-              <a:gd name="connsiteX29" fmla="*/ 1042026 w 6858000"/>
-              <a:gd name="connsiteY29" fmla="*/ 728397 h 9144000"/>
-              <a:gd name="connsiteX30" fmla="*/ 1104527 w 6858000"/>
-              <a:gd name="connsiteY30" fmla="*/ 665896 h 9144000"/>
-              <a:gd name="connsiteX31" fmla="*/ 5760739 w 6858000"/>
-              <a:gd name="connsiteY31" fmla="*/ 665896 h 9144000"/>
-              <a:gd name="connsiteX32" fmla="*/ 5823240 w 6858000"/>
-              <a:gd name="connsiteY32" fmla="*/ 728397 h 9144000"/>
-              <a:gd name="connsiteX33" fmla="*/ 5823240 w 6858000"/>
-              <a:gd name="connsiteY33" fmla="*/ 730698 h 9144000"/>
-              <a:gd name="connsiteX34" fmla="*/ 5823241 w 6858000"/>
-              <a:gd name="connsiteY34" fmla="*/ 583997 h 9144000"/>
-              <a:gd name="connsiteX35" fmla="*/ 5676539 w 6858000"/>
-              <a:gd name="connsiteY35" fmla="*/ 437295 h 9144000"/>
-              <a:gd name="connsiteX36" fmla="*/ 0 w 6858000"/>
+              <a:gd name="connsiteX8" fmla="*/ 668510 w 6865269"/>
+              <a:gd name="connsiteY8" fmla="*/ 4203603 h 9144000"/>
+              <a:gd name="connsiteX9" fmla="*/ 566175 w 6865269"/>
+              <a:gd name="connsiteY9" fmla="*/ 4305938 h 9144000"/>
+              <a:gd name="connsiteX10" fmla="*/ 668510 w 6865269"/>
+              <a:gd name="connsiteY10" fmla="*/ 4408273 h 9144000"/>
+              <a:gd name="connsiteX11" fmla="*/ 770845 w 6865269"/>
+              <a:gd name="connsiteY11" fmla="*/ 4305938 h 9144000"/>
+              <a:gd name="connsiteX12" fmla="*/ 668510 w 6865269"/>
+              <a:gd name="connsiteY12" fmla="*/ 4203603 h 9144000"/>
+              <a:gd name="connsiteX13" fmla="*/ 668510 w 6865269"/>
+              <a:gd name="connsiteY13" fmla="*/ 2883225 h 9144000"/>
+              <a:gd name="connsiteX14" fmla="*/ 566175 w 6865269"/>
+              <a:gd name="connsiteY14" fmla="*/ 2985560 h 9144000"/>
+              <a:gd name="connsiteX15" fmla="*/ 668510 w 6865269"/>
+              <a:gd name="connsiteY15" fmla="*/ 3087895 h 9144000"/>
+              <a:gd name="connsiteX16" fmla="*/ 770845 w 6865269"/>
+              <a:gd name="connsiteY16" fmla="*/ 2985560 h 9144000"/>
+              <a:gd name="connsiteX17" fmla="*/ 668510 w 6865269"/>
+              <a:gd name="connsiteY17" fmla="*/ 2883225 h 9144000"/>
+              <a:gd name="connsiteX18" fmla="*/ 5823240 w 6865269"/>
+              <a:gd name="connsiteY18" fmla="*/ 2279977 h 9144000"/>
+              <a:gd name="connsiteX19" fmla="*/ 5767935 w 6865269"/>
+              <a:gd name="connsiteY19" fmla="*/ 2335282 h 9144000"/>
+              <a:gd name="connsiteX20" fmla="*/ 1097330 w 6865269"/>
+              <a:gd name="connsiteY20" fmla="*/ 2335282 h 9144000"/>
+              <a:gd name="connsiteX21" fmla="*/ 1058223 w 6865269"/>
+              <a:gd name="connsiteY21" fmla="*/ 2319083 h 9144000"/>
+              <a:gd name="connsiteX22" fmla="*/ 1042026 w 6865269"/>
+              <a:gd name="connsiteY22" fmla="*/ 2279979 h 9144000"/>
+              <a:gd name="connsiteX23" fmla="*/ 1042026 w 6865269"/>
+              <a:gd name="connsiteY23" fmla="*/ 2413569 h 9144000"/>
+              <a:gd name="connsiteX24" fmla="*/ 1230922 w 6865269"/>
+              <a:gd name="connsiteY24" fmla="*/ 2602465 h 9144000"/>
+              <a:gd name="connsiteX25" fmla="*/ 5634344 w 6865269"/>
+              <a:gd name="connsiteY25" fmla="*/ 2602465 h 9144000"/>
+              <a:gd name="connsiteX26" fmla="*/ 5823240 w 6865269"/>
+              <a:gd name="connsiteY26" fmla="*/ 2413569 h 9144000"/>
+              <a:gd name="connsiteX27" fmla="*/ 1230922 w 6865269"/>
+              <a:gd name="connsiteY27" fmla="*/ 441445 h 9144000"/>
+              <a:gd name="connsiteX28" fmla="*/ 1042026 w 6865269"/>
+              <a:gd name="connsiteY28" fmla="*/ 630341 h 9144000"/>
+              <a:gd name="connsiteX29" fmla="*/ 1042026 w 6865269"/>
+              <a:gd name="connsiteY29" fmla="*/ 763933 h 9144000"/>
+              <a:gd name="connsiteX30" fmla="*/ 1097331 w 6865269"/>
+              <a:gd name="connsiteY30" fmla="*/ 708628 h 9144000"/>
+              <a:gd name="connsiteX31" fmla="*/ 5767936 w 6865269"/>
+              <a:gd name="connsiteY31" fmla="*/ 708628 h 9144000"/>
+              <a:gd name="connsiteX32" fmla="*/ 5807043 w 6865269"/>
+              <a:gd name="connsiteY32" fmla="*/ 724827 h 9144000"/>
+              <a:gd name="connsiteX33" fmla="*/ 5823240 w 6865269"/>
+              <a:gd name="connsiteY33" fmla="*/ 763931 h 9144000"/>
+              <a:gd name="connsiteX34" fmla="*/ 5823240 w 6865269"/>
+              <a:gd name="connsiteY34" fmla="*/ 630341 h 9144000"/>
+              <a:gd name="connsiteX35" fmla="*/ 5634344 w 6865269"/>
+              <a:gd name="connsiteY35" fmla="*/ 441445 h 9144000"/>
+              <a:gd name="connsiteX36" fmla="*/ 0 w 6865269"/>
               <a:gd name="connsiteY36" fmla="*/ 0 h 9144000"/>
-              <a:gd name="connsiteX37" fmla="*/ 6858000 w 6858000"/>
+              <a:gd name="connsiteX37" fmla="*/ 6865269 w 6865269"/>
               <a:gd name="connsiteY37" fmla="*/ 0 h 9144000"/>
-              <a:gd name="connsiteX38" fmla="*/ 6858000 w 6858000"/>
+              <a:gd name="connsiteX38" fmla="*/ 6865269 w 6865269"/>
               <a:gd name="connsiteY38" fmla="*/ 9144000 h 9144000"/>
-              <a:gd name="connsiteX39" fmla="*/ 0 w 6858000"/>
+              <a:gd name="connsiteX39" fmla="*/ 0 w 6865269"/>
               <a:gd name="connsiteY39" fmla="*/ 9144000 h 9144000"/>
             </a:gdLst>
             <a:ahLst/>
@@ -7633,7 +8413,7 @@
             </a:cxnLst>
             <a:rect l="l" t="t" r="r" b="b"/>
             <a:pathLst>
-              <a:path w="6858000" h="9144000">
+              <a:path w="6865269" h="9144000">
                 <a:moveTo>
                   <a:pt x="3734844" y="8661917"/>
                 </a:moveTo>
@@ -7661,137 +8441,133 @@
                 </a:lnTo>
                 <a:close/>
                 <a:moveTo>
-                  <a:pt x="668510" y="4562351"/>
+                  <a:pt x="668510" y="4203603"/>
                 </a:moveTo>
                 <a:cubicBezTo>
-                  <a:pt x="611992" y="4562351"/>
-                  <a:pt x="566175" y="4608168"/>
-                  <a:pt x="566175" y="4664686"/>
+                  <a:pt x="611992" y="4203603"/>
+                  <a:pt x="566175" y="4249420"/>
+                  <a:pt x="566175" y="4305938"/>
                 </a:cubicBezTo>
                 <a:cubicBezTo>
-                  <a:pt x="566175" y="4721204"/>
-                  <a:pt x="611992" y="4767021"/>
-                  <a:pt x="668510" y="4767021"/>
+                  <a:pt x="566175" y="4362456"/>
+                  <a:pt x="611992" y="4408273"/>
+                  <a:pt x="668510" y="4408273"/>
                 </a:cubicBezTo>
                 <a:cubicBezTo>
-                  <a:pt x="725028" y="4767021"/>
-                  <a:pt x="770845" y="4721204"/>
-                  <a:pt x="770845" y="4664686"/>
+                  <a:pt x="725028" y="4408273"/>
+                  <a:pt x="770845" y="4362456"/>
+                  <a:pt x="770845" y="4305938"/>
                 </a:cubicBezTo>
                 <a:cubicBezTo>
-                  <a:pt x="770845" y="4608168"/>
-                  <a:pt x="725028" y="4562351"/>
-                  <a:pt x="668510" y="4562351"/>
+                  <a:pt x="770845" y="4249420"/>
+                  <a:pt x="725028" y="4203603"/>
+                  <a:pt x="668510" y="4203603"/>
                 </a:cubicBezTo>
                 <a:close/>
                 <a:moveTo>
-                  <a:pt x="668510" y="3069491"/>
+                  <a:pt x="668510" y="2883225"/>
                 </a:moveTo>
                 <a:cubicBezTo>
-                  <a:pt x="611992" y="3069491"/>
-                  <a:pt x="566175" y="3115308"/>
-                  <a:pt x="566175" y="3171826"/>
+                  <a:pt x="611992" y="2883225"/>
+                  <a:pt x="566175" y="2929042"/>
+                  <a:pt x="566175" y="2985560"/>
                 </a:cubicBezTo>
                 <a:cubicBezTo>
-                  <a:pt x="566175" y="3228344"/>
-                  <a:pt x="611992" y="3274161"/>
-                  <a:pt x="668510" y="3274161"/>
+                  <a:pt x="566175" y="3042078"/>
+                  <a:pt x="611992" y="3087895"/>
+                  <a:pt x="668510" y="3087895"/>
                 </a:cubicBezTo>
                 <a:cubicBezTo>
-                  <a:pt x="725028" y="3274161"/>
-                  <a:pt x="770845" y="3228344"/>
-                  <a:pt x="770845" y="3171826"/>
+                  <a:pt x="725028" y="3087895"/>
+                  <a:pt x="770845" y="3042078"/>
+                  <a:pt x="770845" y="2985560"/>
                 </a:cubicBezTo>
                 <a:cubicBezTo>
-                  <a:pt x="770845" y="3115308"/>
-                  <a:pt x="725028" y="3069491"/>
-                  <a:pt x="668510" y="3069491"/>
+                  <a:pt x="770845" y="2929042"/>
+                  <a:pt x="725028" y="2883225"/>
+                  <a:pt x="668510" y="2883225"/>
                 </a:cubicBezTo>
                 <a:close/>
                 <a:moveTo>
-                  <a:pt x="1042027" y="2161529"/>
+                  <a:pt x="5823240" y="2279977"/>
                 </a:moveTo>
                 <a:cubicBezTo>
-                  <a:pt x="1042027" y="2210429"/>
-                  <a:pt x="1042026" y="2259330"/>
-                  <a:pt x="1042026" y="2308230"/>
-                </a:cubicBezTo>
-                <a:cubicBezTo>
-                  <a:pt x="1042026" y="2389251"/>
-                  <a:pt x="1107707" y="2454932"/>
-                  <a:pt x="1188728" y="2454932"/>
+                  <a:pt x="5823240" y="2310521"/>
+                  <a:pt x="5798479" y="2335282"/>
+                  <a:pt x="5767935" y="2335282"/>
                 </a:cubicBezTo>
                 <a:lnTo>
-                  <a:pt x="5676539" y="2454932"/>
+                  <a:pt x="1097330" y="2335282"/>
                 </a:lnTo>
                 <a:cubicBezTo>
-                  <a:pt x="5757560" y="2454932"/>
-                  <a:pt x="5823241" y="2389251"/>
-                  <a:pt x="5823241" y="2308230"/>
+                  <a:pt x="1082058" y="2335282"/>
+                  <a:pt x="1068232" y="2329092"/>
+                  <a:pt x="1058223" y="2319083"/>
                 </a:cubicBezTo>
                 <a:lnTo>
-                  <a:pt x="5823241" y="2163830"/>
+                  <a:pt x="1042026" y="2279979"/>
+                </a:lnTo>
+                <a:lnTo>
+                  <a:pt x="1042026" y="2413569"/>
                 </a:lnTo>
                 <a:cubicBezTo>
-                  <a:pt x="5823241" y="2198348"/>
-                  <a:pt x="5795258" y="2226331"/>
-                  <a:pt x="5760740" y="2226331"/>
+                  <a:pt x="1042026" y="2517893"/>
+                  <a:pt x="1126598" y="2602465"/>
+                  <a:pt x="1230922" y="2602465"/>
                 </a:cubicBezTo>
                 <a:lnTo>
-                  <a:pt x="1104528" y="2226331"/>
+                  <a:pt x="5634344" y="2602465"/>
                 </a:lnTo>
                 <a:cubicBezTo>
-                  <a:pt x="1070010" y="2226331"/>
-                  <a:pt x="1042027" y="2198348"/>
-                  <a:pt x="1042027" y="2163830"/>
+                  <a:pt x="5738668" y="2602465"/>
+                  <a:pt x="5823240" y="2517893"/>
+                  <a:pt x="5823240" y="2413569"/>
                 </a:cubicBezTo>
                 <a:close/>
                 <a:moveTo>
-                  <a:pt x="1188728" y="437295"/>
+                  <a:pt x="1230922" y="441445"/>
                 </a:moveTo>
                 <a:cubicBezTo>
-                  <a:pt x="1107707" y="437295"/>
-                  <a:pt x="1042026" y="502976"/>
-                  <a:pt x="1042026" y="583997"/>
+                  <a:pt x="1126598" y="441445"/>
+                  <a:pt x="1042026" y="526017"/>
+                  <a:pt x="1042026" y="630341"/>
                 </a:cubicBezTo>
                 <a:lnTo>
-                  <a:pt x="1042026" y="728397"/>
+                  <a:pt x="1042026" y="763933"/>
                 </a:lnTo>
                 <a:cubicBezTo>
-                  <a:pt x="1042026" y="693879"/>
-                  <a:pt x="1070009" y="665896"/>
-                  <a:pt x="1104527" y="665896"/>
+                  <a:pt x="1042026" y="733389"/>
+                  <a:pt x="1066787" y="708628"/>
+                  <a:pt x="1097331" y="708628"/>
                 </a:cubicBezTo>
                 <a:lnTo>
-                  <a:pt x="5760739" y="665896"/>
+                  <a:pt x="5767936" y="708628"/>
                 </a:lnTo>
                 <a:cubicBezTo>
-                  <a:pt x="5795257" y="665896"/>
-                  <a:pt x="5823240" y="693879"/>
-                  <a:pt x="5823240" y="728397"/>
+                  <a:pt x="5783208" y="708628"/>
+                  <a:pt x="5797034" y="714818"/>
+                  <a:pt x="5807043" y="724827"/>
                 </a:cubicBezTo>
                 <a:lnTo>
-                  <a:pt x="5823240" y="730698"/>
+                  <a:pt x="5823240" y="763931"/>
+                </a:lnTo>
+                <a:lnTo>
+                  <a:pt x="5823240" y="630341"/>
                 </a:lnTo>
                 <a:cubicBezTo>
-                  <a:pt x="5823240" y="681798"/>
-                  <a:pt x="5823241" y="632897"/>
-                  <a:pt x="5823241" y="583997"/>
-                </a:cubicBezTo>
-                <a:cubicBezTo>
-                  <a:pt x="5823241" y="502976"/>
-                  <a:pt x="5757560" y="437295"/>
-                  <a:pt x="5676539" y="437295"/>
+                  <a:pt x="5823240" y="526017"/>
+                  <a:pt x="5738668" y="441445"/>
+                  <a:pt x="5634344" y="441445"/>
                 </a:cubicBezTo>
                 <a:close/>
                 <a:moveTo>
                   <a:pt x="0" y="0"/>
                 </a:moveTo>
                 <a:lnTo>
-                  <a:pt x="6858000" y="0"/>
+                  <a:pt x="6865269" y="0"/>
                 </a:lnTo>
                 <a:lnTo>
-                  <a:pt x="6858000" y="9144000"/>
+                  <a:pt x="6865269" y="9144000"/>
                 </a:lnTo>
                 <a:lnTo>
                   <a:pt x="0" y="9144000"/>
@@ -7839,7 +8615,7 @@
           <p:cNvPr id="17" name="テキスト ボックス 16">
             <a:extLst>
               <a:ext uri="{FF2B5EF4-FFF2-40B4-BE49-F238E27FC236}">
-                <a16:creationId xmlns:a16="http://schemas.microsoft.com/office/drawing/2014/main" id="{F7724E97-9138-2231-87A0-68E3693C9BDD}"/>
+                <a16:creationId xmlns:a16="http://schemas.microsoft.com/office/drawing/2014/main" id="{23F7FDBC-2462-02EF-781D-CFB88D37BD65}"/>
               </a:ext>
             </a:extLst>
           </p:cNvPr>
@@ -7876,7 +8652,7 @@
           <p:cNvPr id="2" name="テキスト ボックス 1">
             <a:extLst>
               <a:ext uri="{FF2B5EF4-FFF2-40B4-BE49-F238E27FC236}">
-                <a16:creationId xmlns:a16="http://schemas.microsoft.com/office/drawing/2014/main" id="{037648C1-2F45-40CF-3D7A-6FB960705994}"/>
+                <a16:creationId xmlns:a16="http://schemas.microsoft.com/office/drawing/2014/main" id="{1C010116-E0FC-A1C3-A27C-4DE97F719290}"/>
               </a:ext>
             </a:extLst>
           </p:cNvPr>
@@ -7885,8 +8661,8 @@
         </p:nvSpPr>
         <p:spPr>
           <a:xfrm>
-            <a:off x="968673" y="840586"/>
-            <a:ext cx="4966039" cy="584775"/>
+            <a:off x="1002539" y="840586"/>
+            <a:ext cx="4908331" cy="584775"/>
           </a:xfrm>
           <a:prstGeom prst="rect">
             <a:avLst/>
@@ -7912,7 +8688,14 @@
                 <a:latin typeface="IBM Plex Sans JP" panose="020B0503050203000203" pitchFamily="50" charset="-128"/>
                 <a:ea typeface="IBM Plex Sans JP" panose="020B0503050203000203" pitchFamily="50" charset="-128"/>
               </a:rPr>
-              <a:t> Tour Guide</a:t>
+              <a:t> </a:t>
+            </a:r>
+            <a:r>
+              <a:rPr lang="ja-JP" altLang="en-US" sz="2800" b="1" dirty="0">
+                <a:latin typeface="IBM Plex Sans JP" panose="020B0503050203000203" pitchFamily="50" charset="-128"/>
+                <a:ea typeface="IBM Plex Sans JP" panose="020B0503050203000203" pitchFamily="50" charset="-128"/>
+              </a:rPr>
+              <a:t>ツアーガイド</a:t>
             </a:r>
             <a:endParaRPr kumimoji="1" lang="ja-JP" altLang="en-US" sz="3200" b="1" dirty="0">
               <a:latin typeface="IBM Plex Sans JP" panose="020B0503050203000203" pitchFamily="50" charset="-128"/>
@@ -7923,10 +8706,10 @@
       </p:sp>
       <p:sp>
         <p:nvSpPr>
-          <p:cNvPr id="11" name="テキスト ボックス 10">
+          <p:cNvPr id="18" name="テキスト ボックス 17">
             <a:extLst>
               <a:ext uri="{FF2B5EF4-FFF2-40B4-BE49-F238E27FC236}">
-                <a16:creationId xmlns:a16="http://schemas.microsoft.com/office/drawing/2014/main" id="{B588B2EE-0B49-3321-079A-EAA300945E47}"/>
+                <a16:creationId xmlns:a16="http://schemas.microsoft.com/office/drawing/2014/main" id="{1EAE5B37-A0A8-8DB3-058E-FE219EFB5C21}"/>
               </a:ext>
             </a:extLst>
           </p:cNvPr>
@@ -7935,8 +8718,8 @@
         </p:nvSpPr>
         <p:spPr>
           <a:xfrm>
-            <a:off x="1515655" y="1444411"/>
-            <a:ext cx="3826689" cy="338554"/>
+            <a:off x="770844" y="2815340"/>
+            <a:ext cx="1516762" cy="400110"/>
           </a:xfrm>
           <a:prstGeom prst="rect">
             <a:avLst/>
@@ -7950,25 +8733,32 @@
           <a:lstStyle/>
           <a:p>
             <a:r>
-              <a:rPr lang="en-US" altLang="ja-JP" sz="1600" dirty="0">
-                <a:latin typeface="IBM Plex Sans JP" panose="020B0503050203000203" pitchFamily="50" charset="-128"/>
-                <a:ea typeface="IBM Plex Sans JP" panose="020B0503050203000203" pitchFamily="50" charset="-128"/>
-              </a:rPr>
-              <a:t>- Let's Explore FlexChroma's Models -</a:t>
-            </a:r>
-            <a:endParaRPr kumimoji="1" lang="ja-JP" altLang="en-US" sz="1600" dirty="0">
-              <a:latin typeface="IBM Plex Sans JP" panose="020B0503050203000203" pitchFamily="50" charset="-128"/>
-              <a:ea typeface="IBM Plex Sans JP" panose="020B0503050203000203" pitchFamily="50" charset="-128"/>
+              <a:rPr lang="en-US" altLang="ja-JP" sz="2000" dirty="0">
+                <a:latin typeface="IBM Plex Sans JP SemiBold" panose="020B0703050203000203" pitchFamily="50" charset="-128"/>
+                <a:ea typeface="IBM Plex Sans JP SemiBold" panose="020B0703050203000203" pitchFamily="50" charset="-128"/>
+              </a:rPr>
+              <a:t>1. </a:t>
+            </a:r>
+            <a:r>
+              <a:rPr lang="ja-JP" altLang="en-US" sz="2000" dirty="0">
+                <a:latin typeface="IBM Plex Sans JP SemiBold" panose="020B0703050203000203" pitchFamily="50" charset="-128"/>
+                <a:ea typeface="IBM Plex Sans JP SemiBold" panose="020B0703050203000203" pitchFamily="50" charset="-128"/>
+              </a:rPr>
+              <a:t>はじめに</a:t>
+            </a:r>
+            <a:endParaRPr kumimoji="1" lang="ja-JP" altLang="en-US" sz="2000" b="1" dirty="0">
+              <a:latin typeface="IBM Plex Sans JP SemiBold" panose="020B0703050203000203" pitchFamily="50" charset="-128"/>
+              <a:ea typeface="IBM Plex Sans JP SemiBold" panose="020B0703050203000203" pitchFamily="50" charset="-128"/>
             </a:endParaRPr>
           </a:p>
         </p:txBody>
       </p:sp>
       <p:sp>
         <p:nvSpPr>
-          <p:cNvPr id="12" name="テキスト ボックス 11">
+          <p:cNvPr id="19" name="テキスト ボックス 18">
             <a:extLst>
               <a:ext uri="{FF2B5EF4-FFF2-40B4-BE49-F238E27FC236}">
-                <a16:creationId xmlns:a16="http://schemas.microsoft.com/office/drawing/2014/main" id="{70F1A14B-8154-E747-C82B-183E692F092B}"/>
+                <a16:creationId xmlns:a16="http://schemas.microsoft.com/office/drawing/2014/main" id="{8B277155-F6B4-006F-3D15-7E80ED29E848}"/>
               </a:ext>
             </a:extLst>
           </p:cNvPr>
@@ -7977,8 +8767,8 @@
         </p:nvSpPr>
         <p:spPr>
           <a:xfrm>
-            <a:off x="2381276" y="1883364"/>
-            <a:ext cx="1952779" cy="307777"/>
+            <a:off x="668508" y="3238280"/>
+            <a:ext cx="5649491" cy="861774"/>
           </a:xfrm>
           <a:prstGeom prst="rect">
             <a:avLst/>
@@ -7986,19 +8776,38 @@
           <a:noFill/>
         </p:spPr>
         <p:txBody>
-          <a:bodyPr wrap="none" rtlCol="0">
+          <a:bodyPr wrap="square" rtlCol="0">
             <a:spAutoFit/>
           </a:bodyPr>
           <a:lstStyle/>
           <a:p>
             <a:r>
-              <a:rPr lang="en-US" altLang="ja-JP" sz="1400" dirty="0">
-                <a:latin typeface="IBM Plex Sans JP" panose="020B0503050203000203" pitchFamily="50" charset="-128"/>
-                <a:ea typeface="IBM Plex Sans JP" panose="020B0503050203000203" pitchFamily="50" charset="-128"/>
-              </a:rPr>
-              <a:t>Ver.1.10  2026.7.22</a:t>
-            </a:r>
-            <a:endParaRPr kumimoji="1" lang="ja-JP" altLang="en-US" sz="1400" dirty="0">
+              <a:rPr lang="en-US" altLang="ja-JP" sz="1000" dirty="0">
+                <a:latin typeface="Segoe UI Semibold" panose="020B0702040204020203" pitchFamily="34" charset="0"/>
+                <a:ea typeface="IBM Plex Sans JP" panose="020B0503050203000203" pitchFamily="50" charset="-128"/>
+                <a:cs typeface="Segoe UI Semibold" panose="020B0702040204020203" pitchFamily="34" charset="0"/>
+              </a:rPr>
+              <a:t>FlexChroma™</a:t>
+            </a:r>
+            <a:r>
+              <a:rPr lang="ja-JP" altLang="ja-JP" sz="1000" dirty="0">
+                <a:latin typeface="IBM Plex Sans JP" panose="020B0503050203000203" pitchFamily="50" charset="-128"/>
+                <a:ea typeface="IBM Plex Sans JP" panose="020B0503050203000203" pitchFamily="50" charset="-128"/>
+              </a:rPr>
+              <a:t>は、市販のフィラメントを組み合わせて「フィラメントそのもの」を生み出すためのモデルです。</a:t>
+            </a:r>
+          </a:p>
+          <a:p>
+            <a:r>
+              <a:rPr lang="ja-JP" altLang="ja-JP" sz="1000" dirty="0">
+                <a:latin typeface="IBM Plex Sans JP" panose="020B0503050203000203" pitchFamily="50" charset="-128"/>
+                <a:ea typeface="IBM Plex Sans JP" panose="020B0503050203000203" pitchFamily="50" charset="-128"/>
+              </a:rPr>
+              <a:t>様々な目的のシリーズから構成されており、各シリーズにはサイズなどの違いによってモデル、プロファイル、プレートごとに異なるフィラメントモデルを提供します。</a:t>
+            </a:r>
+          </a:p>
+          <a:p>
+            <a:endParaRPr kumimoji="1" lang="ja-JP" altLang="en-US" sz="1000" b="1" dirty="0">
               <a:latin typeface="IBM Plex Sans JP" panose="020B0503050203000203" pitchFamily="50" charset="-128"/>
               <a:ea typeface="IBM Plex Sans JP" panose="020B0503050203000203" pitchFamily="50" charset="-128"/>
             </a:endParaRPr>
@@ -8007,10 +8816,10 @@
       </p:sp>
       <p:sp>
         <p:nvSpPr>
-          <p:cNvPr id="18" name="テキスト ボックス 17">
+          <p:cNvPr id="21" name="テキスト ボックス 20">
             <a:extLst>
               <a:ext uri="{FF2B5EF4-FFF2-40B4-BE49-F238E27FC236}">
-                <a16:creationId xmlns:a16="http://schemas.microsoft.com/office/drawing/2014/main" id="{B58B679E-EED2-37D5-F878-0982B577C9F1}"/>
+                <a16:creationId xmlns:a16="http://schemas.microsoft.com/office/drawing/2014/main" id="{54DA55D2-2B5C-9AD6-980D-12AA6565179D}"/>
               </a:ext>
             </a:extLst>
           </p:cNvPr>
@@ -8019,8 +8828,8 @@
         </p:nvSpPr>
         <p:spPr>
           <a:xfrm>
-            <a:off x="770844" y="3001606"/>
-            <a:ext cx="2055371" cy="400110"/>
+            <a:off x="770844" y="4135718"/>
+            <a:ext cx="2286203" cy="400110"/>
           </a:xfrm>
           <a:prstGeom prst="rect">
             <a:avLst/>
@@ -8038,9 +8847,16 @@
                 <a:latin typeface="IBM Plex Sans JP SemiBold" panose="020B0703050203000203" pitchFamily="50" charset="-128"/>
                 <a:ea typeface="IBM Plex Sans JP SemiBold" panose="020B0703050203000203" pitchFamily="50" charset="-128"/>
               </a:rPr>
-              <a:t>1. Introduction</a:t>
-            </a:r>
-            <a:endParaRPr kumimoji="1" lang="ja-JP" altLang="en-US" sz="2000" b="1" dirty="0">
+              <a:t>2. </a:t>
+            </a:r>
+            <a:r>
+              <a:rPr lang="ja-JP" altLang="en-US" sz="2000" dirty="0">
+                <a:latin typeface="IBM Plex Sans JP SemiBold" panose="020B0703050203000203" pitchFamily="50" charset="-128"/>
+                <a:ea typeface="IBM Plex Sans JP SemiBold" panose="020B0703050203000203" pitchFamily="50" charset="-128"/>
+              </a:rPr>
+              <a:t>モデル選定方法</a:t>
+            </a:r>
+            <a:endParaRPr kumimoji="1" lang="ja-JP" altLang="en-US" sz="2400" b="1" dirty="0">
               <a:latin typeface="IBM Plex Sans JP SemiBold" panose="020B0703050203000203" pitchFamily="50" charset="-128"/>
               <a:ea typeface="IBM Plex Sans JP SemiBold" panose="020B0703050203000203" pitchFamily="50" charset="-128"/>
             </a:endParaRPr>
@@ -8049,10 +8865,10 @@
       </p:sp>
       <p:sp>
         <p:nvSpPr>
-          <p:cNvPr id="19" name="テキスト ボックス 18">
+          <p:cNvPr id="22" name="テキスト ボックス 21">
             <a:extLst>
               <a:ext uri="{FF2B5EF4-FFF2-40B4-BE49-F238E27FC236}">
-                <a16:creationId xmlns:a16="http://schemas.microsoft.com/office/drawing/2014/main" id="{C6DEFA1D-CF68-E4F9-BA2D-64447AA15B5D}"/>
+                <a16:creationId xmlns:a16="http://schemas.microsoft.com/office/drawing/2014/main" id="{9892ABBA-C6BB-6533-C8B6-AF950E500E64}"/>
               </a:ext>
             </a:extLst>
           </p:cNvPr>
@@ -8061,8 +8877,8 @@
         </p:nvSpPr>
         <p:spPr>
           <a:xfrm>
-            <a:off x="668508" y="3424546"/>
-            <a:ext cx="5649491" cy="738664"/>
+            <a:off x="661239" y="4511386"/>
+            <a:ext cx="5649492" cy="553998"/>
           </a:xfrm>
           <a:prstGeom prst="rect">
             <a:avLst/>
@@ -8076,21 +8892,43 @@
           <a:lstStyle/>
           <a:p>
             <a:r>
-              <a:rPr lang="en-US" altLang="ja-JP" sz="1050" dirty="0">
-                <a:latin typeface="Segoe UI Semibold" panose="020B0702040204020203" pitchFamily="34" charset="0"/>
-                <a:ea typeface="IBM Plex Sans JP" panose="020B0503050203000203" pitchFamily="50" charset="-128"/>
-                <a:cs typeface="Segoe UI Semibold" panose="020B0702040204020203" pitchFamily="34" charset="0"/>
-              </a:rPr>
-              <a:t>FlexChroma™</a:t>
-            </a:r>
-            <a:r>
-              <a:rPr lang="en-US" altLang="ja-JP" sz="1050" dirty="0">
-                <a:latin typeface="IBM Plex Sans JP" panose="020B0503050203000203" pitchFamily="50" charset="-128"/>
-                <a:ea typeface="IBM Plex Sans JP" panose="020B0503050203000203" pitchFamily="50" charset="-128"/>
-              </a:rPr>
-              <a:t> is a set of models designed to create filament itself by combining commercially available filaments. It consists of multiple Series, each designed for a different purpose. Within each Series, multiple Models are provided, along with different Profiles and Plates depending on size and usage.</a:t>
-            </a:r>
-            <a:endParaRPr kumimoji="1" lang="ja-JP" altLang="en-US" sz="1050" b="1" dirty="0">
+              <a:rPr lang="ja-JP" altLang="ja-JP" sz="1000" dirty="0">
+                <a:latin typeface="IBM Plex Sans JP" panose="020B0503050203000203" pitchFamily="50" charset="-128"/>
+                <a:ea typeface="IBM Plex Sans JP" panose="020B0503050203000203" pitchFamily="50" charset="-128"/>
+              </a:rPr>
+              <a:t>簡易的なモデル選定手順をお見せします。まずは</a:t>
+            </a:r>
+            <a:r>
+              <a:rPr lang="en-US" altLang="ja-JP" sz="1000" dirty="0">
+                <a:latin typeface="IBM Plex Sans JP" panose="020B0503050203000203" pitchFamily="50" charset="-128"/>
+                <a:ea typeface="IBM Plex Sans JP" panose="020B0503050203000203" pitchFamily="50" charset="-128"/>
+              </a:rPr>
+              <a:t>Makerworld</a:t>
+            </a:r>
+            <a:r>
+              <a:rPr lang="ja-JP" altLang="ja-JP" sz="1000" dirty="0">
+                <a:latin typeface="IBM Plex Sans JP" panose="020B0503050203000203" pitchFamily="50" charset="-128"/>
+                <a:ea typeface="IBM Plex Sans JP" panose="020B0503050203000203" pitchFamily="50" charset="-128"/>
+              </a:rPr>
+              <a:t>で</a:t>
+            </a:r>
+            <a:r>
+              <a:rPr lang="en-US" altLang="ja-JP" sz="1000" b="1" dirty="0">
+                <a:latin typeface="IBM Plex Sans JP" panose="020B0503050203000203" pitchFamily="50" charset="-128"/>
+                <a:ea typeface="IBM Plex Sans JP" panose="020B0503050203000203" pitchFamily="50" charset="-128"/>
+              </a:rPr>
+              <a:t>FlexChroma HUB</a:t>
+            </a:r>
+            <a:r>
+              <a:rPr lang="ja-JP" altLang="ja-JP" sz="1000" dirty="0">
+                <a:latin typeface="IBM Plex Sans JP" panose="020B0503050203000203" pitchFamily="50" charset="-128"/>
+                <a:ea typeface="IBM Plex Sans JP" panose="020B0503050203000203" pitchFamily="50" charset="-128"/>
+              </a:rPr>
+              <a:t>を開いてください。その後に下記フローに従って適切なデータをダウンロードし、印刷してください。</a:t>
+            </a:r>
+          </a:p>
+          <a:p>
+            <a:endParaRPr kumimoji="1" lang="ja-JP" altLang="en-US" sz="1000" b="1" dirty="0">
               <a:latin typeface="IBM Plex Sans JP" panose="020B0503050203000203" pitchFamily="50" charset="-128"/>
               <a:ea typeface="IBM Plex Sans JP" panose="020B0503050203000203" pitchFamily="50" charset="-128"/>
             </a:endParaRPr>
@@ -8099,10 +8937,10 @@
       </p:sp>
       <p:sp>
         <p:nvSpPr>
-          <p:cNvPr id="21" name="テキスト ボックス 20">
+          <p:cNvPr id="25" name="テキスト ボックス 24">
             <a:extLst>
               <a:ext uri="{FF2B5EF4-FFF2-40B4-BE49-F238E27FC236}">
-                <a16:creationId xmlns:a16="http://schemas.microsoft.com/office/drawing/2014/main" id="{904DB38D-B7D0-BAB7-C051-CE44D494214D}"/>
+                <a16:creationId xmlns:a16="http://schemas.microsoft.com/office/drawing/2014/main" id="{2BD9B259-385D-72AB-BC12-A39347742A8E}"/>
               </a:ext>
             </a:extLst>
           </p:cNvPr>
@@ -8111,8 +8949,8 @@
         </p:nvSpPr>
         <p:spPr>
           <a:xfrm>
-            <a:off x="770844" y="4494466"/>
-            <a:ext cx="3389069" cy="400110"/>
+            <a:off x="661238" y="6206196"/>
+            <a:ext cx="5656761" cy="400110"/>
           </a:xfrm>
           <a:prstGeom prst="rect">
             <a:avLst/>
@@ -8120,31 +8958,55 @@
           <a:noFill/>
         </p:spPr>
         <p:txBody>
-          <a:bodyPr wrap="none" rtlCol="0">
+          <a:bodyPr wrap="square" rtlCol="0">
             <a:spAutoFit/>
           </a:bodyPr>
           <a:lstStyle/>
           <a:p>
             <a:r>
-              <a:rPr lang="en-US" altLang="ja-JP" sz="2000" dirty="0">
-                <a:latin typeface="IBM Plex Sans JP SemiBold" panose="020B0703050203000203" pitchFamily="50" charset="-128"/>
-                <a:ea typeface="IBM Plex Sans JP SemiBold" panose="020B0703050203000203" pitchFamily="50" charset="-128"/>
-              </a:rPr>
-              <a:t>2. How to Choose a Model</a:t>
-            </a:r>
-            <a:endParaRPr kumimoji="1" lang="ja-JP" altLang="en-US" sz="2400" b="1" dirty="0">
-              <a:latin typeface="IBM Plex Sans JP SemiBold" panose="020B0703050203000203" pitchFamily="50" charset="-128"/>
-              <a:ea typeface="IBM Plex Sans JP SemiBold" panose="020B0703050203000203" pitchFamily="50" charset="-128"/>
-            </a:endParaRPr>
-          </a:p>
-        </p:txBody>
-      </p:sp>
-      <p:sp>
-        <p:nvSpPr>
-          <p:cNvPr id="22" name="テキスト ボックス 21">
+              <a:rPr lang="ja-JP" altLang="ja-JP" sz="1000" dirty="0">
+                <a:latin typeface="IBM Plex Sans JP" panose="020B0503050203000203" pitchFamily="50" charset="-128"/>
+                <a:ea typeface="IBM Plex Sans JP" panose="020B0503050203000203" pitchFamily="50" charset="-128"/>
+              </a:rPr>
+              <a:t>モデル選定においてはどの様なフィラメントが欲しいか？を考えま</a:t>
+            </a:r>
+            <a:r>
+              <a:rPr lang="ja-JP" altLang="en-US" sz="1000" dirty="0">
+                <a:latin typeface="IBM Plex Sans JP" panose="020B0503050203000203" pitchFamily="50" charset="-128"/>
+                <a:ea typeface="IBM Plex Sans JP" panose="020B0503050203000203" pitchFamily="50" charset="-128"/>
+              </a:rPr>
+              <a:t>しょう</a:t>
+            </a:r>
+            <a:r>
+              <a:rPr lang="ja-JP" altLang="ja-JP" sz="1000" dirty="0">
+                <a:latin typeface="IBM Plex Sans JP" panose="020B0503050203000203" pitchFamily="50" charset="-128"/>
+                <a:ea typeface="IBM Plex Sans JP" panose="020B0503050203000203" pitchFamily="50" charset="-128"/>
+              </a:rPr>
+              <a:t>。下記１～５の手順によって最適なデータを探</a:t>
+            </a:r>
+            <a:r>
+              <a:rPr lang="ja-JP" altLang="en-US" sz="1000" dirty="0">
+                <a:latin typeface="IBM Plex Sans JP" panose="020B0503050203000203" pitchFamily="50" charset="-128"/>
+                <a:ea typeface="IBM Plex Sans JP" panose="020B0503050203000203" pitchFamily="50" charset="-128"/>
+              </a:rPr>
+              <a:t>すことができます</a:t>
+            </a:r>
+            <a:r>
+              <a:rPr lang="ja-JP" altLang="ja-JP" sz="1000" dirty="0">
+                <a:latin typeface="IBM Plex Sans JP" panose="020B0503050203000203" pitchFamily="50" charset="-128"/>
+                <a:ea typeface="IBM Plex Sans JP" panose="020B0503050203000203" pitchFamily="50" charset="-128"/>
+              </a:rPr>
+              <a:t>。</a:t>
+            </a:r>
+          </a:p>
+        </p:txBody>
+      </p:sp>
+      <p:sp>
+        <p:nvSpPr>
+          <p:cNvPr id="26" name="テキスト ボックス 25">
             <a:extLst>
               <a:ext uri="{FF2B5EF4-FFF2-40B4-BE49-F238E27FC236}">
-                <a16:creationId xmlns:a16="http://schemas.microsoft.com/office/drawing/2014/main" id="{0D6CFBE2-A4A0-54C6-80FE-E0E055BADBAB}"/>
+                <a16:creationId xmlns:a16="http://schemas.microsoft.com/office/drawing/2014/main" id="{0B7448FA-4B3E-BB8D-CDAF-DE6157C9F664}"/>
               </a:ext>
             </a:extLst>
           </p:cNvPr>
@@ -8153,8 +9015,8 @@
         </p:nvSpPr>
         <p:spPr>
           <a:xfrm>
-            <a:off x="661239" y="4917406"/>
-            <a:ext cx="5649492" cy="253916"/>
+            <a:off x="756306" y="6650049"/>
+            <a:ext cx="5554425" cy="1615827"/>
           </a:xfrm>
           <a:prstGeom prst="rect">
             <a:avLst/>
@@ -8167,26 +9029,425 @@
           </a:bodyPr>
           <a:lstStyle/>
           <a:p>
-            <a:r>
-              <a:rPr lang="en-US" altLang="ja-JP" sz="1050" dirty="0">
-                <a:latin typeface="IBM Plex Sans JP" panose="020B0503050203000203" pitchFamily="50" charset="-128"/>
-                <a:ea typeface="IBM Plex Sans JP" panose="020B0503050203000203" pitchFamily="50" charset="-128"/>
-              </a:rPr>
-              <a:t>First, follow this quick selection flow to download and print the correct data.</a:t>
-            </a:r>
-            <a:endParaRPr kumimoji="1" lang="ja-JP" altLang="en-US" sz="1050" b="1" dirty="0">
-              <a:latin typeface="IBM Plex Sans JP" panose="020B0503050203000203" pitchFamily="50" charset="-128"/>
-              <a:ea typeface="IBM Plex Sans JP" panose="020B0503050203000203" pitchFamily="50" charset="-128"/>
-            </a:endParaRPr>
+            <a:pPr marL="228600" lvl="0" indent="-228600">
+              <a:buFont typeface="+mj-lt"/>
+              <a:buAutoNum type="arabicPeriod"/>
+            </a:pPr>
+            <a:r>
+              <a:rPr lang="ja-JP" altLang="ja-JP" sz="900" dirty="0">
+                <a:latin typeface="IBM Plex Sans JP" panose="020B0503050203000203" pitchFamily="50" charset="-128"/>
+                <a:ea typeface="IBM Plex Sans JP" panose="020B0503050203000203" pitchFamily="50" charset="-128"/>
+              </a:rPr>
+              <a:t>最初に</a:t>
+            </a:r>
+            <a:r>
+              <a:rPr lang="en-US" altLang="ja-JP" sz="900" dirty="0">
+                <a:latin typeface="IBM Plex Sans JP" panose="020B0503050203000203" pitchFamily="50" charset="-128"/>
+                <a:ea typeface="IBM Plex Sans JP" panose="020B0503050203000203" pitchFamily="50" charset="-128"/>
+              </a:rPr>
+              <a:t>Series</a:t>
+            </a:r>
+            <a:r>
+              <a:rPr lang="ja-JP" altLang="ja-JP" sz="900" dirty="0">
+                <a:latin typeface="IBM Plex Sans JP" panose="020B0503050203000203" pitchFamily="50" charset="-128"/>
+                <a:ea typeface="IBM Plex Sans JP" panose="020B0503050203000203" pitchFamily="50" charset="-128"/>
+              </a:rPr>
+              <a:t>を選択します。中間色が欲しいのであれば</a:t>
+            </a:r>
+            <a:r>
+              <a:rPr lang="en-US" altLang="ja-JP" sz="900" dirty="0">
+                <a:latin typeface="IBM Plex Sans JP" panose="020B0503050203000203" pitchFamily="50" charset="-128"/>
+                <a:ea typeface="IBM Plex Sans JP" panose="020B0503050203000203" pitchFamily="50" charset="-128"/>
+              </a:rPr>
+              <a:t>Blend Filament</a:t>
+            </a:r>
+            <a:r>
+              <a:rPr lang="ja-JP" altLang="ja-JP" sz="900" dirty="0">
+                <a:latin typeface="IBM Plex Sans JP" panose="020B0503050203000203" pitchFamily="50" charset="-128"/>
+                <a:ea typeface="IBM Plex Sans JP" panose="020B0503050203000203" pitchFamily="50" charset="-128"/>
+              </a:rPr>
+              <a:t>、グラデーションフィラメントが欲しければ</a:t>
+            </a:r>
+            <a:r>
+              <a:rPr lang="en-US" altLang="ja-JP" sz="900" dirty="0">
+                <a:latin typeface="IBM Plex Sans JP" panose="020B0503050203000203" pitchFamily="50" charset="-128"/>
+                <a:ea typeface="IBM Plex Sans JP" panose="020B0503050203000203" pitchFamily="50" charset="-128"/>
+              </a:rPr>
+              <a:t>Gradient Filament</a:t>
+            </a:r>
+            <a:r>
+              <a:rPr lang="ja-JP" altLang="ja-JP" sz="900" dirty="0">
+                <a:latin typeface="IBM Plex Sans JP" panose="020B0503050203000203" pitchFamily="50" charset="-128"/>
+                <a:ea typeface="IBM Plex Sans JP" panose="020B0503050203000203" pitchFamily="50" charset="-128"/>
+              </a:rPr>
+              <a:t>と言った様に。</a:t>
+            </a:r>
+          </a:p>
+          <a:p>
+            <a:pPr marL="228600" lvl="0" indent="-228600">
+              <a:buFont typeface="+mj-lt"/>
+              <a:buAutoNum type="arabicPeriod"/>
+            </a:pPr>
+            <a:r>
+              <a:rPr lang="ja-JP" altLang="ja-JP" sz="900" dirty="0">
+                <a:latin typeface="IBM Plex Sans JP" panose="020B0503050203000203" pitchFamily="50" charset="-128"/>
+                <a:ea typeface="IBM Plex Sans JP" panose="020B0503050203000203" pitchFamily="50" charset="-128"/>
+              </a:rPr>
+              <a:t>次に</a:t>
+            </a:r>
+            <a:r>
+              <a:rPr lang="en-US" altLang="ja-JP" sz="900" dirty="0">
+                <a:latin typeface="IBM Plex Sans JP" panose="020B0503050203000203" pitchFamily="50" charset="-128"/>
+                <a:ea typeface="IBM Plex Sans JP" panose="020B0503050203000203" pitchFamily="50" charset="-128"/>
+              </a:rPr>
+              <a:t>Model</a:t>
+            </a:r>
+            <a:r>
+              <a:rPr lang="ja-JP" altLang="ja-JP" sz="900" dirty="0">
+                <a:latin typeface="IBM Plex Sans JP" panose="020B0503050203000203" pitchFamily="50" charset="-128"/>
+                <a:ea typeface="IBM Plex Sans JP" panose="020B0503050203000203" pitchFamily="50" charset="-128"/>
+              </a:rPr>
+              <a:t>を選択します。フィラメントの量がどれくらい必要かを考えて、それに合った</a:t>
+            </a:r>
+            <a:r>
+              <a:rPr lang="en-US" altLang="ja-JP" sz="900" dirty="0">
+                <a:latin typeface="IBM Plex Sans JP" panose="020B0503050203000203" pitchFamily="50" charset="-128"/>
+                <a:ea typeface="IBM Plex Sans JP" panose="020B0503050203000203" pitchFamily="50" charset="-128"/>
+              </a:rPr>
+              <a:t>Model</a:t>
+            </a:r>
+            <a:r>
+              <a:rPr lang="ja-JP" altLang="ja-JP" sz="900" dirty="0">
+                <a:latin typeface="IBM Plex Sans JP" panose="020B0503050203000203" pitchFamily="50" charset="-128"/>
+                <a:ea typeface="IBM Plex Sans JP" panose="020B0503050203000203" pitchFamily="50" charset="-128"/>
+              </a:rPr>
+              <a:t>を選択します。例えば</a:t>
+            </a:r>
+            <a:r>
+              <a:rPr lang="en-US" altLang="ja-JP" sz="900" dirty="0">
+                <a:latin typeface="IBM Plex Sans JP" panose="020B0503050203000203" pitchFamily="50" charset="-128"/>
+                <a:ea typeface="IBM Plex Sans JP" panose="020B0503050203000203" pitchFamily="50" charset="-128"/>
+              </a:rPr>
+              <a:t>3Dbenchy</a:t>
+            </a:r>
+            <a:r>
+              <a:rPr lang="ja-JP" altLang="ja-JP" sz="900" dirty="0">
+                <a:latin typeface="IBM Plex Sans JP" panose="020B0503050203000203" pitchFamily="50" charset="-128"/>
+                <a:ea typeface="IBM Plex Sans JP" panose="020B0503050203000203" pitchFamily="50" charset="-128"/>
+              </a:rPr>
+              <a:t>を作る程度であれば</a:t>
+            </a:r>
+            <a:r>
+              <a:rPr lang="en-US" altLang="ja-JP" sz="900" dirty="0">
+                <a:latin typeface="IBM Plex Sans JP" panose="020B0503050203000203" pitchFamily="50" charset="-128"/>
+                <a:ea typeface="IBM Plex Sans JP" panose="020B0503050203000203" pitchFamily="50" charset="-128"/>
+              </a:rPr>
+              <a:t>S4 Model</a:t>
+            </a:r>
+            <a:r>
+              <a:rPr lang="ja-JP" altLang="ja-JP" sz="900" dirty="0">
+                <a:latin typeface="IBM Plex Sans JP" panose="020B0503050203000203" pitchFamily="50" charset="-128"/>
+                <a:ea typeface="IBM Plex Sans JP" panose="020B0503050203000203" pitchFamily="50" charset="-128"/>
+              </a:rPr>
+              <a:t>、</a:t>
+            </a:r>
+            <a:r>
+              <a:rPr lang="en-US" altLang="ja-JP" sz="900" dirty="0">
+                <a:latin typeface="IBM Plex Sans JP" panose="020B0503050203000203" pitchFamily="50" charset="-128"/>
+                <a:ea typeface="IBM Plex Sans JP" panose="020B0503050203000203" pitchFamily="50" charset="-128"/>
+              </a:rPr>
+              <a:t>70g</a:t>
+            </a:r>
+            <a:r>
+              <a:rPr lang="ja-JP" altLang="ja-JP" sz="900" dirty="0">
+                <a:latin typeface="IBM Plex Sans JP" panose="020B0503050203000203" pitchFamily="50" charset="-128"/>
+                <a:ea typeface="IBM Plex Sans JP" panose="020B0503050203000203" pitchFamily="50" charset="-128"/>
+              </a:rPr>
+              <a:t>近い大きなモデルを作るのであれば</a:t>
+            </a:r>
+            <a:r>
+              <a:rPr lang="en-US" altLang="ja-JP" sz="900" dirty="0">
+                <a:latin typeface="IBM Plex Sans JP" panose="020B0503050203000203" pitchFamily="50" charset="-128"/>
+                <a:ea typeface="IBM Plex Sans JP" panose="020B0503050203000203" pitchFamily="50" charset="-128"/>
+              </a:rPr>
+              <a:t>M1 Model</a:t>
+            </a:r>
+            <a:r>
+              <a:rPr lang="ja-JP" altLang="ja-JP" sz="900" dirty="0">
+                <a:latin typeface="IBM Plex Sans JP" panose="020B0503050203000203" pitchFamily="50" charset="-128"/>
+                <a:ea typeface="IBM Plex Sans JP" panose="020B0503050203000203" pitchFamily="50" charset="-128"/>
+              </a:rPr>
+              <a:t>と言う具合です。</a:t>
+            </a:r>
+          </a:p>
+          <a:p>
+            <a:pPr marL="228600" lvl="0" indent="-228600">
+              <a:buFont typeface="+mj-lt"/>
+              <a:buAutoNum type="arabicPeriod"/>
+            </a:pPr>
+            <a:r>
+              <a:rPr lang="ja-JP" altLang="ja-JP" sz="900" dirty="0">
+                <a:latin typeface="IBM Plex Sans JP" panose="020B0503050203000203" pitchFamily="50" charset="-128"/>
+                <a:ea typeface="IBM Plex Sans JP" panose="020B0503050203000203" pitchFamily="50" charset="-128"/>
+              </a:rPr>
+              <a:t>次に</a:t>
+            </a:r>
+            <a:r>
+              <a:rPr lang="en-US" altLang="ja-JP" sz="900" dirty="0">
+                <a:latin typeface="IBM Plex Sans JP" panose="020B0503050203000203" pitchFamily="50" charset="-128"/>
+                <a:ea typeface="IBM Plex Sans JP" panose="020B0503050203000203" pitchFamily="50" charset="-128"/>
+              </a:rPr>
+              <a:t>Profile</a:t>
+            </a:r>
+            <a:r>
+              <a:rPr lang="ja-JP" altLang="ja-JP" sz="900" dirty="0">
+                <a:latin typeface="IBM Plex Sans JP" panose="020B0503050203000203" pitchFamily="50" charset="-128"/>
+                <a:ea typeface="IBM Plex Sans JP" panose="020B0503050203000203" pitchFamily="50" charset="-128"/>
+              </a:rPr>
+              <a:t>と</a:t>
+            </a:r>
+            <a:r>
+              <a:rPr lang="en-US" altLang="ja-JP" sz="900" dirty="0">
+                <a:latin typeface="IBM Plex Sans JP" panose="020B0503050203000203" pitchFamily="50" charset="-128"/>
+                <a:ea typeface="IBM Plex Sans JP" panose="020B0503050203000203" pitchFamily="50" charset="-128"/>
+              </a:rPr>
+              <a:t>Plate</a:t>
+            </a:r>
+            <a:r>
+              <a:rPr lang="ja-JP" altLang="ja-JP" sz="900" dirty="0">
+                <a:latin typeface="IBM Plex Sans JP" panose="020B0503050203000203" pitchFamily="50" charset="-128"/>
+                <a:ea typeface="IBM Plex Sans JP" panose="020B0503050203000203" pitchFamily="50" charset="-128"/>
+              </a:rPr>
+              <a:t>を選びます。</a:t>
+            </a:r>
+            <a:r>
+              <a:rPr lang="en-US" altLang="ja-JP" sz="900" dirty="0">
+                <a:latin typeface="IBM Plex Sans JP" panose="020B0503050203000203" pitchFamily="50" charset="-128"/>
+                <a:ea typeface="IBM Plex Sans JP" panose="020B0503050203000203" pitchFamily="50" charset="-128"/>
+              </a:rPr>
+              <a:t>Series</a:t>
+            </a:r>
+            <a:r>
+              <a:rPr lang="ja-JP" altLang="ja-JP" sz="900" dirty="0">
+                <a:latin typeface="IBM Plex Sans JP" panose="020B0503050203000203" pitchFamily="50" charset="-128"/>
+                <a:ea typeface="IBM Plex Sans JP" panose="020B0503050203000203" pitchFamily="50" charset="-128"/>
+              </a:rPr>
+              <a:t>によって異なる分け方で</a:t>
+            </a:r>
+            <a:r>
+              <a:rPr lang="en-US" altLang="ja-JP" sz="900" dirty="0">
+                <a:latin typeface="IBM Plex Sans JP" panose="020B0503050203000203" pitchFamily="50" charset="-128"/>
+                <a:ea typeface="IBM Plex Sans JP" panose="020B0503050203000203" pitchFamily="50" charset="-128"/>
+              </a:rPr>
+              <a:t>Profile</a:t>
+            </a:r>
+            <a:r>
+              <a:rPr lang="ja-JP" altLang="ja-JP" sz="900" dirty="0">
+                <a:latin typeface="IBM Plex Sans JP" panose="020B0503050203000203" pitchFamily="50" charset="-128"/>
+                <a:ea typeface="IBM Plex Sans JP" panose="020B0503050203000203" pitchFamily="50" charset="-128"/>
+              </a:rPr>
+              <a:t>と</a:t>
+            </a:r>
+            <a:r>
+              <a:rPr lang="en-US" altLang="ja-JP" sz="900" dirty="0">
+                <a:latin typeface="IBM Plex Sans JP" panose="020B0503050203000203" pitchFamily="50" charset="-128"/>
+                <a:ea typeface="IBM Plex Sans JP" panose="020B0503050203000203" pitchFamily="50" charset="-128"/>
+              </a:rPr>
+              <a:t>Plate</a:t>
+            </a:r>
+            <a:r>
+              <a:rPr lang="ja-JP" altLang="ja-JP" sz="900" dirty="0">
+                <a:latin typeface="IBM Plex Sans JP" panose="020B0503050203000203" pitchFamily="50" charset="-128"/>
+                <a:ea typeface="IBM Plex Sans JP" panose="020B0503050203000203" pitchFamily="50" charset="-128"/>
+              </a:rPr>
+              <a:t>ごとにフィラメントのデータがあります。例えば</a:t>
+            </a:r>
+            <a:r>
+              <a:rPr lang="en-US" altLang="ja-JP" sz="900" dirty="0">
+                <a:latin typeface="IBM Plex Sans JP" panose="020B0503050203000203" pitchFamily="50" charset="-128"/>
+                <a:ea typeface="IBM Plex Sans JP" panose="020B0503050203000203" pitchFamily="50" charset="-128"/>
+              </a:rPr>
+              <a:t>Blend Filament</a:t>
+            </a:r>
+            <a:r>
+              <a:rPr lang="ja-JP" altLang="ja-JP" sz="900" dirty="0">
+                <a:latin typeface="IBM Plex Sans JP" panose="020B0503050203000203" pitchFamily="50" charset="-128"/>
+                <a:ea typeface="IBM Plex Sans JP" panose="020B0503050203000203" pitchFamily="50" charset="-128"/>
+              </a:rPr>
+              <a:t>で９８％混色比のモデルであれば、</a:t>
+            </a:r>
+            <a:r>
+              <a:rPr lang="en-US" altLang="ja-JP" sz="900" dirty="0">
+                <a:latin typeface="IBM Plex Sans JP" panose="020B0503050203000203" pitchFamily="50" charset="-128"/>
+                <a:ea typeface="IBM Plex Sans JP" panose="020B0503050203000203" pitchFamily="50" charset="-128"/>
+              </a:rPr>
+              <a:t>Detail Profile</a:t>
+            </a:r>
+            <a:r>
+              <a:rPr lang="ja-JP" altLang="ja-JP" sz="900" dirty="0">
+                <a:latin typeface="IBM Plex Sans JP" panose="020B0503050203000203" pitchFamily="50" charset="-128"/>
+                <a:ea typeface="IBM Plex Sans JP" panose="020B0503050203000203" pitchFamily="50" charset="-128"/>
+              </a:rPr>
+              <a:t>の中の</a:t>
+            </a:r>
+            <a:r>
+              <a:rPr lang="en-US" altLang="ja-JP" sz="900" dirty="0">
+                <a:latin typeface="IBM Plex Sans JP" panose="020B0503050203000203" pitchFamily="50" charset="-128"/>
+                <a:ea typeface="IBM Plex Sans JP" panose="020B0503050203000203" pitchFamily="50" charset="-128"/>
+              </a:rPr>
+              <a:t>98pct</a:t>
+            </a:r>
+            <a:r>
+              <a:rPr lang="ja-JP" altLang="ja-JP" sz="900" dirty="0">
+                <a:latin typeface="IBM Plex Sans JP" panose="020B0503050203000203" pitchFamily="50" charset="-128"/>
+                <a:ea typeface="IBM Plex Sans JP" panose="020B0503050203000203" pitchFamily="50" charset="-128"/>
+              </a:rPr>
+              <a:t>プレートを選びます。</a:t>
+            </a:r>
+          </a:p>
+          <a:p>
+            <a:pPr marL="228600" lvl="0" indent="-228600">
+              <a:buFont typeface="+mj-lt"/>
+              <a:buAutoNum type="arabicPeriod"/>
+            </a:pPr>
+            <a:r>
+              <a:rPr lang="ja-JP" altLang="ja-JP" sz="900" dirty="0">
+                <a:latin typeface="IBM Plex Sans JP" panose="020B0503050203000203" pitchFamily="50" charset="-128"/>
+                <a:ea typeface="IBM Plex Sans JP" panose="020B0503050203000203" pitchFamily="50" charset="-128"/>
+              </a:rPr>
+              <a:t>使うフィラメントを選びます。素材が同じもしくは近い</a:t>
+            </a:r>
+            <a:r>
+              <a:rPr lang="en-US" altLang="ja-JP" sz="900" dirty="0">
+                <a:latin typeface="IBM Plex Sans JP" panose="020B0503050203000203" pitchFamily="50" charset="-128"/>
+                <a:ea typeface="IBM Plex Sans JP" panose="020B0503050203000203" pitchFamily="50" charset="-128"/>
+              </a:rPr>
+              <a:t>(PLA Basic</a:t>
+            </a:r>
+            <a:r>
+              <a:rPr lang="ja-JP" altLang="ja-JP" sz="900" dirty="0">
+                <a:latin typeface="IBM Plex Sans JP" panose="020B0503050203000203" pitchFamily="50" charset="-128"/>
+                <a:ea typeface="IBM Plex Sans JP" panose="020B0503050203000203" pitchFamily="50" charset="-128"/>
+              </a:rPr>
+              <a:t>と</a:t>
+            </a:r>
+            <a:r>
+              <a:rPr lang="en-US" altLang="ja-JP" sz="900" dirty="0">
+                <a:latin typeface="IBM Plex Sans JP" panose="020B0503050203000203" pitchFamily="50" charset="-128"/>
+                <a:ea typeface="IBM Plex Sans JP" panose="020B0503050203000203" pitchFamily="50" charset="-128"/>
+              </a:rPr>
+              <a:t>PLA Matte</a:t>
+            </a:r>
+            <a:r>
+              <a:rPr lang="ja-JP" altLang="ja-JP" sz="900" dirty="0">
+                <a:latin typeface="IBM Plex Sans JP" panose="020B0503050203000203" pitchFamily="50" charset="-128"/>
+                <a:ea typeface="IBM Plex Sans JP" panose="020B0503050203000203" pitchFamily="50" charset="-128"/>
+              </a:rPr>
+              <a:t>の様な</a:t>
+            </a:r>
+            <a:r>
+              <a:rPr lang="en-US" altLang="ja-JP" sz="900" dirty="0">
+                <a:latin typeface="IBM Plex Sans JP" panose="020B0503050203000203" pitchFamily="50" charset="-128"/>
+                <a:ea typeface="IBM Plex Sans JP" panose="020B0503050203000203" pitchFamily="50" charset="-128"/>
+              </a:rPr>
+              <a:t>)</a:t>
+            </a:r>
+            <a:r>
+              <a:rPr lang="ja-JP" altLang="ja-JP" sz="900" dirty="0">
+                <a:latin typeface="IBM Plex Sans JP" panose="020B0503050203000203" pitchFamily="50" charset="-128"/>
+                <a:ea typeface="IBM Plex Sans JP" panose="020B0503050203000203" pitchFamily="50" charset="-128"/>
+              </a:rPr>
+              <a:t>フィラメントを用意しましょう。選んだフィラメントを割り当てて、スライスしましょう。説明文に書かれている印刷時の注意点をよく読んでから印刷して下さい。</a:t>
+            </a:r>
+          </a:p>
+        </p:txBody>
+      </p:sp>
+      <p:sp>
+        <p:nvSpPr>
+          <p:cNvPr id="27" name="テキスト ボックス 26">
+            <a:extLst>
+              <a:ext uri="{FF2B5EF4-FFF2-40B4-BE49-F238E27FC236}">
+                <a16:creationId xmlns:a16="http://schemas.microsoft.com/office/drawing/2014/main" id="{C0F92284-90E6-0D1E-94B4-EE18257CE7CE}"/>
+              </a:ext>
+            </a:extLst>
+          </p:cNvPr>
+          <p:cNvSpPr txBox="1"/>
+          <p:nvPr/>
+        </p:nvSpPr>
+        <p:spPr>
+          <a:xfrm>
+            <a:off x="656136" y="8285815"/>
+            <a:ext cx="5680304" cy="223138"/>
+          </a:xfrm>
+          <a:prstGeom prst="rect">
+            <a:avLst/>
+          </a:prstGeom>
+          <a:noFill/>
+        </p:spPr>
+        <p:txBody>
+          <a:bodyPr wrap="square" rtlCol="0">
+            <a:spAutoFit/>
+          </a:bodyPr>
+          <a:lstStyle/>
+          <a:p>
+            <a:r>
+              <a:rPr lang="ja-JP" altLang="ja-JP" sz="800" dirty="0">
+                <a:latin typeface="IBM Plex Sans JP Light" panose="020B0403050203000203" pitchFamily="50" charset="-128"/>
+                <a:ea typeface="IBM Plex Sans JP Light" panose="020B0403050203000203" pitchFamily="50" charset="-128"/>
+              </a:rPr>
+              <a:t>※</a:t>
+            </a:r>
+            <a:r>
+              <a:rPr lang="en-US" altLang="ja-JP" sz="800" dirty="0">
+                <a:latin typeface="IBM Plex Sans JP Light" panose="020B0403050203000203" pitchFamily="50" charset="-128"/>
+                <a:ea typeface="IBM Plex Sans JP Light" panose="020B0403050203000203" pitchFamily="50" charset="-128"/>
+              </a:rPr>
+              <a:t>FlexChroma</a:t>
+            </a:r>
+            <a:r>
+              <a:rPr lang="ja-JP" altLang="ja-JP" sz="800" dirty="0">
+                <a:latin typeface="IBM Plex Sans JP Light" panose="020B0403050203000203" pitchFamily="50" charset="-128"/>
+                <a:ea typeface="IBM Plex Sans JP Light" panose="020B0403050203000203" pitchFamily="50" charset="-128"/>
+              </a:rPr>
+              <a:t>における</a:t>
+            </a:r>
+            <a:r>
+              <a:rPr lang="en-US" altLang="ja-JP" sz="800" dirty="0">
+                <a:latin typeface="IBM Plex Sans JP Light" panose="020B0403050203000203" pitchFamily="50" charset="-128"/>
+                <a:ea typeface="IBM Plex Sans JP Light" panose="020B0403050203000203" pitchFamily="50" charset="-128"/>
+              </a:rPr>
+              <a:t>Profile</a:t>
+            </a:r>
+            <a:r>
+              <a:rPr lang="ja-JP" altLang="ja-JP" sz="800" dirty="0">
+                <a:latin typeface="IBM Plex Sans JP Light" panose="020B0403050203000203" pitchFamily="50" charset="-128"/>
+                <a:ea typeface="IBM Plex Sans JP Light" panose="020B0403050203000203" pitchFamily="50" charset="-128"/>
+              </a:rPr>
+              <a:t>は印刷設定の違いではありません。各</a:t>
+            </a:r>
+            <a:r>
+              <a:rPr lang="en-US" altLang="ja-JP" sz="800" dirty="0">
+                <a:latin typeface="IBM Plex Sans JP Light" panose="020B0403050203000203" pitchFamily="50" charset="-128"/>
+                <a:ea typeface="IBM Plex Sans JP Light" panose="020B0403050203000203" pitchFamily="50" charset="-128"/>
+              </a:rPr>
+              <a:t>Series</a:t>
+            </a:r>
+            <a:r>
+              <a:rPr lang="ja-JP" altLang="ja-JP" sz="800" dirty="0">
+                <a:latin typeface="IBM Plex Sans JP Light" panose="020B0403050203000203" pitchFamily="50" charset="-128"/>
+                <a:ea typeface="IBM Plex Sans JP Light" panose="020B0403050203000203" pitchFamily="50" charset="-128"/>
+              </a:rPr>
+              <a:t>内で「目的別の分類」を表しています。</a:t>
+            </a:r>
           </a:p>
         </p:txBody>
       </p:sp>
       <p:pic>
         <p:nvPicPr>
-          <p:cNvPr id="24" name="図 23">
+          <p:cNvPr id="33" name="図 32">
             <a:extLst>
               <a:ext uri="{FF2B5EF4-FFF2-40B4-BE49-F238E27FC236}">
-                <a16:creationId xmlns:a16="http://schemas.microsoft.com/office/drawing/2014/main" id="{5F2979AD-644B-ADCD-5CC2-84EB3A43695A}"/>
+                <a16:creationId xmlns:a16="http://schemas.microsoft.com/office/drawing/2014/main" id="{0B4C43A0-825E-F30B-9D0C-F2B06C53569B}"/>
               </a:ext>
             </a:extLst>
           </p:cNvPr>
@@ -8203,7 +9464,7 @@
         </p:blipFill>
         <p:spPr>
           <a:xfrm>
-            <a:off x="551490" y="5293717"/>
+            <a:off x="551490" y="4987005"/>
             <a:ext cx="5759241" cy="1144558"/>
           </a:xfrm>
           <a:prstGeom prst="rect">
@@ -8213,10 +9474,10 @@
       </p:pic>
       <p:sp>
         <p:nvSpPr>
-          <p:cNvPr id="25" name="テキスト ボックス 24">
+          <p:cNvPr id="31" name="テキスト ボックス 30">
             <a:extLst>
               <a:ext uri="{FF2B5EF4-FFF2-40B4-BE49-F238E27FC236}">
-                <a16:creationId xmlns:a16="http://schemas.microsoft.com/office/drawing/2014/main" id="{08407871-7712-1714-53D0-42420BDF6422}"/>
+                <a16:creationId xmlns:a16="http://schemas.microsoft.com/office/drawing/2014/main" id="{89DAADC0-90E8-9DD8-E69D-EF0535095897}"/>
               </a:ext>
             </a:extLst>
           </p:cNvPr>
@@ -8225,8 +9486,8 @@
         </p:nvSpPr>
         <p:spPr>
           <a:xfrm>
-            <a:off x="661238" y="6573178"/>
-            <a:ext cx="5656761" cy="258083"/>
+            <a:off x="1515655" y="1444411"/>
+            <a:ext cx="3879588" cy="338554"/>
           </a:xfrm>
           <a:prstGeom prst="rect">
             <a:avLst/>
@@ -8234,27 +9495,53 @@
           <a:noFill/>
         </p:spPr>
         <p:txBody>
-          <a:bodyPr wrap="square" rtlCol="0">
+          <a:bodyPr wrap="none" rtlCol="0">
             <a:spAutoFit/>
           </a:bodyPr>
           <a:lstStyle/>
           <a:p>
             <a:r>
-              <a:rPr lang="en-US" altLang="ja-JP" sz="1050" dirty="0">
-                <a:latin typeface="IBM Plex Sans JP" panose="020B0503050203000203" pitchFamily="50" charset="-128"/>
-                <a:ea typeface="IBM Plex Sans JP" panose="020B0503050203000203" pitchFamily="50" charset="-128"/>
-              </a:rPr>
-              <a:t>When choosing a model, start by deciding what kind of filament you want to create.</a:t>
-            </a:r>
-          </a:p>
-        </p:txBody>
-      </p:sp>
-      <p:sp>
-        <p:nvSpPr>
-          <p:cNvPr id="26" name="テキスト ボックス 25">
+              <a:rPr lang="en-US" altLang="ja-JP" sz="1600" dirty="0">
+                <a:latin typeface="IBM Plex Sans JP" panose="020B0503050203000203" pitchFamily="50" charset="-128"/>
+                <a:ea typeface="IBM Plex Sans JP" panose="020B0503050203000203" pitchFamily="50" charset="-128"/>
+              </a:rPr>
+              <a:t>- </a:t>
+            </a:r>
+            <a:r>
+              <a:rPr lang="en-US" altLang="ja-JP" sz="1600" dirty="0">
+                <a:latin typeface="Segoe UI Semibold" panose="020B0702040204020203" pitchFamily="34" charset="0"/>
+                <a:ea typeface="IBM Plex Sans JP" panose="020B0503050203000203" pitchFamily="50" charset="-128"/>
+                <a:cs typeface="Segoe UI Semibold" panose="020B0702040204020203" pitchFamily="34" charset="0"/>
+              </a:rPr>
+              <a:t>FlexChroma</a:t>
+            </a:r>
+            <a:r>
+              <a:rPr lang="ja-JP" altLang="en-US" sz="1600" dirty="0">
+                <a:latin typeface="IBM Plex Sans JP" panose="020B0503050203000203" pitchFamily="50" charset="-128"/>
+                <a:ea typeface="IBM Plex Sans JP" panose="020B0503050203000203" pitchFamily="50" charset="-128"/>
+              </a:rPr>
+              <a:t>のモデルを探してみよう</a:t>
+            </a:r>
+            <a:r>
+              <a:rPr lang="en-US" altLang="ja-JP" sz="1600" dirty="0">
+                <a:latin typeface="IBM Plex Sans JP" panose="020B0503050203000203" pitchFamily="50" charset="-128"/>
+                <a:ea typeface="IBM Plex Sans JP" panose="020B0503050203000203" pitchFamily="50" charset="-128"/>
+              </a:rPr>
+              <a:t> -</a:t>
+            </a:r>
+            <a:endParaRPr kumimoji="1" lang="ja-JP" altLang="en-US" sz="1600" dirty="0">
+              <a:latin typeface="IBM Plex Sans JP" panose="020B0503050203000203" pitchFamily="50" charset="-128"/>
+              <a:ea typeface="IBM Plex Sans JP" panose="020B0503050203000203" pitchFamily="50" charset="-128"/>
+            </a:endParaRPr>
+          </a:p>
+        </p:txBody>
+      </p:sp>
+      <p:sp>
+        <p:nvSpPr>
+          <p:cNvPr id="34" name="テキスト ボックス 33">
             <a:extLst>
               <a:ext uri="{FF2B5EF4-FFF2-40B4-BE49-F238E27FC236}">
-                <a16:creationId xmlns:a16="http://schemas.microsoft.com/office/drawing/2014/main" id="{54428E43-7065-CB5F-8C19-67DF85808B38}"/>
+                <a16:creationId xmlns:a16="http://schemas.microsoft.com/office/drawing/2014/main" id="{902B05C9-73E0-B790-6785-7C63D903FB4D}"/>
               </a:ext>
             </a:extLst>
           </p:cNvPr>
@@ -8263,8 +9550,8 @@
         </p:nvSpPr>
         <p:spPr>
           <a:xfrm>
-            <a:off x="770843" y="6836315"/>
-            <a:ext cx="5554425" cy="1169551"/>
+            <a:off x="2381276" y="1883364"/>
+            <a:ext cx="1952779" cy="307777"/>
           </a:xfrm>
           <a:prstGeom prst="rect">
             <a:avLst/>
@@ -8272,132 +9559,21 @@
           <a:noFill/>
         </p:spPr>
         <p:txBody>
-          <a:bodyPr wrap="square" rtlCol="0">
+          <a:bodyPr wrap="none" rtlCol="0">
             <a:spAutoFit/>
           </a:bodyPr>
           <a:lstStyle/>
           <a:p>
             <a:r>
-              <a:rPr lang="en-US" altLang="ja-JP" sz="1000" dirty="0">
-                <a:latin typeface="IBM Plex Sans JP" panose="020B0503050203000203" pitchFamily="50" charset="-128"/>
-                <a:ea typeface="IBM Plex Sans JP" panose="020B0503050203000203" pitchFamily="50" charset="-128"/>
-              </a:rPr>
-              <a:t>1. Select a Series: Blend Filament for mixed colors, Gradient Filament for color changes.</a:t>
-            </a:r>
-          </a:p>
-          <a:p>
-            <a:r>
-              <a:rPr lang="en-US" altLang="ja-JP" sz="1000" dirty="0">
-                <a:latin typeface="IBM Plex Sans JP" panose="020B0503050203000203" pitchFamily="50" charset="-128"/>
-                <a:ea typeface="IBM Plex Sans JP" panose="020B0503050203000203" pitchFamily="50" charset="-128"/>
-              </a:rPr>
-              <a:t>2. Select a Model size: Use an S4 Model for small objects, or an M1 Model for larger prints </a:t>
-            </a:r>
-          </a:p>
-          <a:p>
-            <a:r>
-              <a:rPr lang="en-US" altLang="ja-JP" sz="1000" dirty="0">
-                <a:latin typeface="IBM Plex Sans JP" panose="020B0503050203000203" pitchFamily="50" charset="-128"/>
-                <a:ea typeface="IBM Plex Sans JP" panose="020B0503050203000203" pitchFamily="50" charset="-128"/>
-              </a:rPr>
-              <a:t>     requiring around 70g of filament.</a:t>
-            </a:r>
-          </a:p>
-          <a:p>
-            <a:r>
-              <a:rPr lang="en-US" altLang="ja-JP" sz="1000" dirty="0">
-                <a:latin typeface="IBM Plex Sans JP" panose="020B0503050203000203" pitchFamily="50" charset="-128"/>
-                <a:ea typeface="IBM Plex Sans JP" panose="020B0503050203000203" pitchFamily="50" charset="-128"/>
-              </a:rPr>
-              <a:t>3. Select a Profile and Plate: Choose the Plate that matches your desired mixing ratio or </a:t>
-            </a:r>
-          </a:p>
-          <a:p>
-            <a:r>
-              <a:rPr lang="en-US" altLang="ja-JP" sz="1000" dirty="0">
-                <a:latin typeface="IBM Plex Sans JP" panose="020B0503050203000203" pitchFamily="50" charset="-128"/>
-                <a:ea typeface="IBM Plex Sans JP" panose="020B0503050203000203" pitchFamily="50" charset="-128"/>
-              </a:rPr>
-              <a:t>     pattern.</a:t>
-            </a:r>
-          </a:p>
-          <a:p>
-            <a:r>
-              <a:rPr lang="en-US" altLang="ja-JP" sz="1000" dirty="0">
-                <a:latin typeface="IBM Plex Sans JP" panose="020B0503050203000203" pitchFamily="50" charset="-128"/>
-                <a:ea typeface="IBM Plex Sans JP" panose="020B0503050203000203" pitchFamily="50" charset="-128"/>
-              </a:rPr>
-              <a:t>4. Assign filaments and slice: Use filaments with the same or similar material, assign </a:t>
-            </a:r>
-          </a:p>
-          <a:p>
-            <a:r>
-              <a:rPr lang="en-US" altLang="ja-JP" sz="1000" dirty="0">
-                <a:latin typeface="IBM Plex Sans JP" panose="020B0503050203000203" pitchFamily="50" charset="-128"/>
-                <a:ea typeface="IBM Plex Sans JP" panose="020B0503050203000203" pitchFamily="50" charset="-128"/>
-              </a:rPr>
-              <a:t>     them, slice the model, and read the print notes before printing.</a:t>
-            </a:r>
-            <a:endParaRPr kumimoji="1" lang="ja-JP" altLang="en-US" sz="900" b="1" dirty="0">
-              <a:latin typeface="IBM Plex Sans JP Light" panose="020B0403050203000203" pitchFamily="50" charset="-128"/>
-              <a:ea typeface="IBM Plex Sans JP Light" panose="020B0403050203000203" pitchFamily="50" charset="-128"/>
-            </a:endParaRPr>
-          </a:p>
-        </p:txBody>
-      </p:sp>
-      <p:sp>
-        <p:nvSpPr>
-          <p:cNvPr id="27" name="テキスト ボックス 26">
-            <a:extLst>
-              <a:ext uri="{FF2B5EF4-FFF2-40B4-BE49-F238E27FC236}">
-                <a16:creationId xmlns:a16="http://schemas.microsoft.com/office/drawing/2014/main" id="{DE739D59-FAEF-B68A-41EA-3512C3BC39FD}"/>
-              </a:ext>
-            </a:extLst>
-          </p:cNvPr>
-          <p:cNvSpPr txBox="1"/>
-          <p:nvPr/>
-        </p:nvSpPr>
-        <p:spPr>
-          <a:xfrm>
-            <a:off x="770842" y="8115753"/>
-            <a:ext cx="5464000" cy="230832"/>
-          </a:xfrm>
-          <a:prstGeom prst="rect">
-            <a:avLst/>
-          </a:prstGeom>
-          <a:noFill/>
-        </p:spPr>
-        <p:txBody>
-          <a:bodyPr wrap="square" rtlCol="0">
-            <a:spAutoFit/>
-          </a:bodyPr>
-          <a:lstStyle/>
-          <a:p>
-            <a:r>
-              <a:rPr lang="en-US" altLang="ja-JP" sz="900" dirty="0">
-                <a:latin typeface="IBM Plex Sans JP Light" panose="020B0403050203000203" pitchFamily="50" charset="-128"/>
-                <a:ea typeface="IBM Plex Sans JP Light" panose="020B0403050203000203" pitchFamily="50" charset="-128"/>
-              </a:rPr>
-              <a:t>*Note: In </a:t>
-            </a:r>
-            <a:r>
-              <a:rPr lang="en-US" altLang="ja-JP" sz="900" dirty="0">
-                <a:latin typeface="Segoe UI" panose="020B0502040204020203" pitchFamily="34" charset="0"/>
-                <a:ea typeface="IBM Plex Sans JP Light" panose="020B0403050203000203" pitchFamily="50" charset="-128"/>
-                <a:cs typeface="Segoe UI" panose="020B0502040204020203" pitchFamily="34" charset="0"/>
-              </a:rPr>
-              <a:t>FlexChroma</a:t>
-            </a:r>
-            <a:r>
-              <a:rPr lang="en-US" altLang="ja-JP" sz="900" dirty="0">
-                <a:latin typeface="IBM Plex Sans JP Light" panose="020B0403050203000203" pitchFamily="50" charset="-128"/>
-                <a:ea typeface="IBM Plex Sans JP Light" panose="020B0403050203000203" pitchFamily="50" charset="-128"/>
-              </a:rPr>
-              <a:t>, “Profile” means a purpose-based classification, not different print settings.</a:t>
-            </a:r>
-            <a:endParaRPr kumimoji="1" lang="ja-JP" altLang="en-US" sz="900" b="1" dirty="0">
-              <a:latin typeface="IBM Plex Sans JP Light" panose="020B0403050203000203" pitchFamily="50" charset="-128"/>
-              <a:ea typeface="IBM Plex Sans JP Light" panose="020B0403050203000203" pitchFamily="50" charset="-128"/>
+              <a:rPr lang="en-US" altLang="ja-JP" sz="1400" dirty="0">
+                <a:latin typeface="IBM Plex Sans JP" panose="020B0503050203000203" pitchFamily="50" charset="-128"/>
+                <a:ea typeface="IBM Plex Sans JP" panose="020B0503050203000203" pitchFamily="50" charset="-128"/>
+              </a:rPr>
+              <a:t>Ver.1.10  2026.7.22</a:t>
+            </a:r>
+            <a:endParaRPr kumimoji="1" lang="ja-JP" altLang="en-US" sz="1400" dirty="0">
+              <a:latin typeface="IBM Plex Sans JP" panose="020B0503050203000203" pitchFamily="50" charset="-128"/>
+              <a:ea typeface="IBM Plex Sans JP" panose="020B0503050203000203" pitchFamily="50" charset="-128"/>
             </a:endParaRPr>
           </a:p>
         </p:txBody>
@@ -8405,7 +9581,7 @@
     </p:spTree>
     <p:extLst>
       <p:ext uri="{BB962C8B-B14F-4D97-AF65-F5344CB8AC3E}">
-        <p14:creationId xmlns:p14="http://schemas.microsoft.com/office/powerpoint/2010/main" val="17367200"/>
+        <p14:creationId xmlns:p14="http://schemas.microsoft.com/office/powerpoint/2010/main" val="3929067069"/>
       </p:ext>
     </p:extLst>
   </p:cSld>
@@ -8423,7 +9599,7 @@
         <p:cNvPr id="1" name="">
           <a:extLst>
             <a:ext uri="{FF2B5EF4-FFF2-40B4-BE49-F238E27FC236}">
-              <a16:creationId xmlns:a16="http://schemas.microsoft.com/office/drawing/2014/main" id="{FDED8CF6-698C-0611-6FE9-D8447E17F739}"/>
+              <a16:creationId xmlns:a16="http://schemas.microsoft.com/office/drawing/2014/main" id="{F80E29D0-A67B-D81A-ACFD-83FD8814E3FD}"/>
             </a:ext>
           </a:extLst>
         </p:cNvPr>
@@ -8440,10 +9616,10 @@
       </p:grpSpPr>
       <p:sp>
         <p:nvSpPr>
-          <p:cNvPr id="6" name="正方形/長方形 5">
+          <p:cNvPr id="2" name="正方形/長方形 1">
             <a:extLst>
               <a:ext uri="{FF2B5EF4-FFF2-40B4-BE49-F238E27FC236}">
-                <a16:creationId xmlns:a16="http://schemas.microsoft.com/office/drawing/2014/main" id="{5776EC83-5487-B904-9A4C-0C56AF1763D8}"/>
+                <a16:creationId xmlns:a16="http://schemas.microsoft.com/office/drawing/2014/main" id="{F078B9E5-980E-E0A0-2BA9-30CDBB5E1BBA}"/>
               </a:ext>
             </a:extLst>
           </p:cNvPr>
@@ -8452,8 +9628,8 @@
         </p:nvSpPr>
         <p:spPr>
           <a:xfrm>
-            <a:off x="33951" y="45268"/>
-            <a:ext cx="6790099" cy="9053465"/>
+            <a:off x="0" y="0"/>
+            <a:ext cx="6858000" cy="9144000"/>
           </a:xfrm>
           <a:prstGeom prst="rect">
             <a:avLst/>
@@ -8503,10 +9679,10 @@
       </p:sp>
       <p:sp>
         <p:nvSpPr>
-          <p:cNvPr id="35" name="フリーフォーム: 図形 34">
+          <p:cNvPr id="22" name="フリーフォーム: 図形 21">
             <a:extLst>
               <a:ext uri="{FF2B5EF4-FFF2-40B4-BE49-F238E27FC236}">
-                <a16:creationId xmlns:a16="http://schemas.microsoft.com/office/drawing/2014/main" id="{3AFC7783-D5E1-ECCC-D344-D4ECFBFDECDF}"/>
+                <a16:creationId xmlns:a16="http://schemas.microsoft.com/office/drawing/2014/main" id="{9E7A94BB-4332-D47F-48DC-BDAF90C3F44A}"/>
               </a:ext>
             </a:extLst>
           </p:cNvPr>
@@ -8515,63 +9691,63 @@
         </p:nvSpPr>
         <p:spPr>
           <a:xfrm>
-            <a:off x="-2195" y="0"/>
-            <a:ext cx="6862389" cy="9144000"/>
+            <a:off x="0" y="0"/>
+            <a:ext cx="6865269" cy="9144000"/>
           </a:xfrm>
           <a:custGeom>
             <a:avLst/>
             <a:gdLst>
-              <a:gd name="connsiteX0" fmla="*/ 3739233 w 6862389"/>
+              <a:gd name="connsiteX0" fmla="*/ 3727575 w 6858000"/>
               <a:gd name="connsiteY0" fmla="*/ 8661917 h 9144000"/>
-              <a:gd name="connsiteX1" fmla="*/ 3739233 w 6862389"/>
+              <a:gd name="connsiteX1" fmla="*/ 3727575 w 6858000"/>
               <a:gd name="connsiteY1" fmla="*/ 8715917 h 9144000"/>
-              <a:gd name="connsiteX2" fmla="*/ 6331233 w 6862389"/>
+              <a:gd name="connsiteX2" fmla="*/ 6319575 w 6858000"/>
               <a:gd name="connsiteY2" fmla="*/ 8715917 h 9144000"/>
-              <a:gd name="connsiteX3" fmla="*/ 6331233 w 6862389"/>
+              <a:gd name="connsiteX3" fmla="*/ 6319575 w 6858000"/>
               <a:gd name="connsiteY3" fmla="*/ 8661917 h 9144000"/>
-              <a:gd name="connsiteX4" fmla="*/ 558927 w 6862389"/>
+              <a:gd name="connsiteX4" fmla="*/ 547269 w 6858000"/>
               <a:gd name="connsiteY4" fmla="*/ 8661917 h 9144000"/>
-              <a:gd name="connsiteX5" fmla="*/ 558927 w 6862389"/>
+              <a:gd name="connsiteX5" fmla="*/ 547269 w 6858000"/>
               <a:gd name="connsiteY5" fmla="*/ 8715917 h 9144000"/>
-              <a:gd name="connsiteX6" fmla="*/ 3150927 w 6862389"/>
+              <a:gd name="connsiteX6" fmla="*/ 3139269 w 6858000"/>
               <a:gd name="connsiteY6" fmla="*/ 8715917 h 9144000"/>
-              <a:gd name="connsiteX7" fmla="*/ 3150927 w 6862389"/>
+              <a:gd name="connsiteX7" fmla="*/ 3139269 w 6858000"/>
               <a:gd name="connsiteY7" fmla="*/ 8661917 h 9144000"/>
-              <a:gd name="connsiteX8" fmla="*/ 672899 w 6862389"/>
-              <a:gd name="connsiteY8" fmla="*/ 2635259 h 9144000"/>
-              <a:gd name="connsiteX9" fmla="*/ 570564 w 6862389"/>
-              <a:gd name="connsiteY9" fmla="*/ 2737594 h 9144000"/>
-              <a:gd name="connsiteX10" fmla="*/ 672899 w 6862389"/>
-              <a:gd name="connsiteY10" fmla="*/ 2839929 h 9144000"/>
-              <a:gd name="connsiteX11" fmla="*/ 775234 w 6862389"/>
-              <a:gd name="connsiteY11" fmla="*/ 2737594 h 9144000"/>
-              <a:gd name="connsiteX12" fmla="*/ 672899 w 6862389"/>
-              <a:gd name="connsiteY12" fmla="*/ 2635259 h 9144000"/>
-              <a:gd name="connsiteX13" fmla="*/ 672899 w 6862389"/>
-              <a:gd name="connsiteY13" fmla="*/ 671552 h 9144000"/>
-              <a:gd name="connsiteX14" fmla="*/ 570564 w 6862389"/>
-              <a:gd name="connsiteY14" fmla="*/ 773887 h 9144000"/>
-              <a:gd name="connsiteX15" fmla="*/ 672899 w 6862389"/>
-              <a:gd name="connsiteY15" fmla="*/ 876222 h 9144000"/>
-              <a:gd name="connsiteX16" fmla="*/ 775234 w 6862389"/>
-              <a:gd name="connsiteY16" fmla="*/ 773887 h 9144000"/>
-              <a:gd name="connsiteX17" fmla="*/ 672899 w 6862389"/>
-              <a:gd name="connsiteY17" fmla="*/ 671552 h 9144000"/>
-              <a:gd name="connsiteX18" fmla="*/ 558926 w 6862389"/>
+              <a:gd name="connsiteX8" fmla="*/ 661241 w 6858000"/>
+              <a:gd name="connsiteY8" fmla="*/ 2510638 h 9144000"/>
+              <a:gd name="connsiteX9" fmla="*/ 558906 w 6858000"/>
+              <a:gd name="connsiteY9" fmla="*/ 2612973 h 9144000"/>
+              <a:gd name="connsiteX10" fmla="*/ 661241 w 6858000"/>
+              <a:gd name="connsiteY10" fmla="*/ 2715308 h 9144000"/>
+              <a:gd name="connsiteX11" fmla="*/ 763576 w 6858000"/>
+              <a:gd name="connsiteY11" fmla="*/ 2612973 h 9144000"/>
+              <a:gd name="connsiteX12" fmla="*/ 661241 w 6858000"/>
+              <a:gd name="connsiteY12" fmla="*/ 2510638 h 9144000"/>
+              <a:gd name="connsiteX13" fmla="*/ 661241 w 6858000"/>
+              <a:gd name="connsiteY13" fmla="*/ 677902 h 9144000"/>
+              <a:gd name="connsiteX14" fmla="*/ 558906 w 6858000"/>
+              <a:gd name="connsiteY14" fmla="*/ 780237 h 9144000"/>
+              <a:gd name="connsiteX15" fmla="*/ 661241 w 6858000"/>
+              <a:gd name="connsiteY15" fmla="*/ 882572 h 9144000"/>
+              <a:gd name="connsiteX16" fmla="*/ 763576 w 6858000"/>
+              <a:gd name="connsiteY16" fmla="*/ 780237 h 9144000"/>
+              <a:gd name="connsiteX17" fmla="*/ 661241 w 6858000"/>
+              <a:gd name="connsiteY17" fmla="*/ 677902 h 9144000"/>
+              <a:gd name="connsiteX18" fmla="*/ 547268 w 6858000"/>
               <a:gd name="connsiteY18" fmla="*/ 452468 h 9144000"/>
-              <a:gd name="connsiteX19" fmla="*/ 558926 w 6862389"/>
+              <a:gd name="connsiteX19" fmla="*/ 547268 w 6858000"/>
               <a:gd name="connsiteY19" fmla="*/ 506468 h 9144000"/>
-              <a:gd name="connsiteX20" fmla="*/ 6315119 w 6862389"/>
+              <a:gd name="connsiteX20" fmla="*/ 6303461 w 6858000"/>
               <a:gd name="connsiteY20" fmla="*/ 506468 h 9144000"/>
-              <a:gd name="connsiteX21" fmla="*/ 6315119 w 6862389"/>
+              <a:gd name="connsiteX21" fmla="*/ 6303461 w 6858000"/>
               <a:gd name="connsiteY21" fmla="*/ 452468 h 9144000"/>
-              <a:gd name="connsiteX22" fmla="*/ 0 w 6862389"/>
+              <a:gd name="connsiteX22" fmla="*/ 0 w 6858000"/>
               <a:gd name="connsiteY22" fmla="*/ 0 h 9144000"/>
-              <a:gd name="connsiteX23" fmla="*/ 6862389 w 6862389"/>
+              <a:gd name="connsiteX23" fmla="*/ 6858000 w 6858000"/>
               <a:gd name="connsiteY23" fmla="*/ 0 h 9144000"/>
-              <a:gd name="connsiteX24" fmla="*/ 6862389 w 6862389"/>
+              <a:gd name="connsiteX24" fmla="*/ 6858000 w 6858000"/>
               <a:gd name="connsiteY24" fmla="*/ 9144000 h 9144000"/>
-              <a:gd name="connsiteX25" fmla="*/ 0 w 6862389"/>
+              <a:gd name="connsiteX25" fmla="*/ 0 w 6858000"/>
               <a:gd name="connsiteY25" fmla="*/ 9144000 h 9144000"/>
             </a:gdLst>
             <a:ahLst/>
@@ -8657,102 +9833,102 @@
             </a:cxnLst>
             <a:rect l="l" t="t" r="r" b="b"/>
             <a:pathLst>
-              <a:path w="6862389" h="9144000">
+              <a:path w="6858000" h="9144000">
                 <a:moveTo>
-                  <a:pt x="3739233" y="8661917"/>
+                  <a:pt x="3727575" y="8661917"/>
                 </a:moveTo>
                 <a:lnTo>
-                  <a:pt x="3739233" y="8715917"/>
+                  <a:pt x="3727575" y="8715917"/>
                 </a:lnTo>
                 <a:lnTo>
-                  <a:pt x="6331233" y="8715917"/>
+                  <a:pt x="6319575" y="8715917"/>
                 </a:lnTo>
                 <a:lnTo>
-                  <a:pt x="6331233" y="8661917"/>
+                  <a:pt x="6319575" y="8661917"/>
                 </a:lnTo>
                 <a:close/>
                 <a:moveTo>
-                  <a:pt x="558927" y="8661917"/>
+                  <a:pt x="547269" y="8661917"/>
                 </a:moveTo>
                 <a:lnTo>
-                  <a:pt x="558927" y="8715917"/>
+                  <a:pt x="547269" y="8715917"/>
                 </a:lnTo>
                 <a:lnTo>
-                  <a:pt x="3150927" y="8715917"/>
+                  <a:pt x="3139269" y="8715917"/>
                 </a:lnTo>
                 <a:lnTo>
-                  <a:pt x="3150927" y="8661917"/>
+                  <a:pt x="3139269" y="8661917"/>
                 </a:lnTo>
                 <a:close/>
                 <a:moveTo>
-                  <a:pt x="672899" y="2635259"/>
+                  <a:pt x="661241" y="2510638"/>
                 </a:moveTo>
                 <a:cubicBezTo>
-                  <a:pt x="616381" y="2635259"/>
-                  <a:pt x="570564" y="2681076"/>
-                  <a:pt x="570564" y="2737594"/>
+                  <a:pt x="604723" y="2510638"/>
+                  <a:pt x="558906" y="2556455"/>
+                  <a:pt x="558906" y="2612973"/>
                 </a:cubicBezTo>
                 <a:cubicBezTo>
-                  <a:pt x="570564" y="2794112"/>
-                  <a:pt x="616381" y="2839929"/>
-                  <a:pt x="672899" y="2839929"/>
+                  <a:pt x="558906" y="2669491"/>
+                  <a:pt x="604723" y="2715308"/>
+                  <a:pt x="661241" y="2715308"/>
                 </a:cubicBezTo>
                 <a:cubicBezTo>
-                  <a:pt x="729417" y="2839929"/>
-                  <a:pt x="775234" y="2794112"/>
-                  <a:pt x="775234" y="2737594"/>
+                  <a:pt x="717759" y="2715308"/>
+                  <a:pt x="763576" y="2669491"/>
+                  <a:pt x="763576" y="2612973"/>
                 </a:cubicBezTo>
                 <a:cubicBezTo>
-                  <a:pt x="775234" y="2681076"/>
-                  <a:pt x="729417" y="2635259"/>
-                  <a:pt x="672899" y="2635259"/>
+                  <a:pt x="763576" y="2556455"/>
+                  <a:pt x="717759" y="2510638"/>
+                  <a:pt x="661241" y="2510638"/>
                 </a:cubicBezTo>
                 <a:close/>
                 <a:moveTo>
-                  <a:pt x="672899" y="671552"/>
+                  <a:pt x="661241" y="677902"/>
                 </a:moveTo>
                 <a:cubicBezTo>
-                  <a:pt x="616381" y="671552"/>
-                  <a:pt x="570564" y="717369"/>
-                  <a:pt x="570564" y="773887"/>
+                  <a:pt x="604723" y="677902"/>
+                  <a:pt x="558906" y="723719"/>
+                  <a:pt x="558906" y="780237"/>
                 </a:cubicBezTo>
                 <a:cubicBezTo>
-                  <a:pt x="570564" y="830405"/>
-                  <a:pt x="616381" y="876222"/>
-                  <a:pt x="672899" y="876222"/>
+                  <a:pt x="558906" y="836755"/>
+                  <a:pt x="604723" y="882572"/>
+                  <a:pt x="661241" y="882572"/>
                 </a:cubicBezTo>
                 <a:cubicBezTo>
-                  <a:pt x="729417" y="876222"/>
-                  <a:pt x="775234" y="830405"/>
-                  <a:pt x="775234" y="773887"/>
+                  <a:pt x="717759" y="882572"/>
+                  <a:pt x="763576" y="836755"/>
+                  <a:pt x="763576" y="780237"/>
                 </a:cubicBezTo>
                 <a:cubicBezTo>
-                  <a:pt x="775234" y="717369"/>
-                  <a:pt x="729417" y="671552"/>
-                  <a:pt x="672899" y="671552"/>
+                  <a:pt x="763576" y="723719"/>
+                  <a:pt x="717759" y="677902"/>
+                  <a:pt x="661241" y="677902"/>
                 </a:cubicBezTo>
                 <a:close/>
                 <a:moveTo>
-                  <a:pt x="558926" y="452468"/>
+                  <a:pt x="547268" y="452468"/>
                 </a:moveTo>
                 <a:lnTo>
-                  <a:pt x="558926" y="506468"/>
+                  <a:pt x="547268" y="506468"/>
                 </a:lnTo>
                 <a:lnTo>
-                  <a:pt x="6315119" y="506468"/>
+                  <a:pt x="6303461" y="506468"/>
                 </a:lnTo>
                 <a:lnTo>
-                  <a:pt x="6315119" y="452468"/>
+                  <a:pt x="6303461" y="452468"/>
                 </a:lnTo>
                 <a:close/>
                 <a:moveTo>
                   <a:pt x="0" y="0"/>
                 </a:moveTo>
                 <a:lnTo>
-                  <a:pt x="6862389" y="0"/>
+                  <a:pt x="6858000" y="0"/>
                 </a:lnTo>
                 <a:lnTo>
-                  <a:pt x="6862389" y="9144000"/>
+                  <a:pt x="6858000" y="9144000"/>
                 </a:lnTo>
                 <a:lnTo>
                   <a:pt x="0" y="9144000"/>
@@ -8800,7 +9976,7 @@
           <p:cNvPr id="17" name="テキスト ボックス 16">
             <a:extLst>
               <a:ext uri="{FF2B5EF4-FFF2-40B4-BE49-F238E27FC236}">
-                <a16:creationId xmlns:a16="http://schemas.microsoft.com/office/drawing/2014/main" id="{981E22E0-F0C3-8FD5-9B53-0AE823C53A48}"/>
+                <a16:creationId xmlns:a16="http://schemas.microsoft.com/office/drawing/2014/main" id="{166FC322-1D62-A69F-56DF-8F820EB033E3}"/>
               </a:ext>
             </a:extLst>
           </p:cNvPr>
@@ -8809,7 +9985,7 @@
         </p:nvSpPr>
         <p:spPr>
           <a:xfrm>
-            <a:off x="3150021" y="8521283"/>
+            <a:off x="3163826" y="8511531"/>
             <a:ext cx="575734" cy="369332"/>
           </a:xfrm>
           <a:prstGeom prst="rect">
@@ -8834,10 +10010,10 @@
       </p:sp>
       <p:sp>
         <p:nvSpPr>
-          <p:cNvPr id="2" name="テキスト ボックス 1">
+          <p:cNvPr id="3" name="テキスト ボックス 2">
             <a:extLst>
               <a:ext uri="{FF2B5EF4-FFF2-40B4-BE49-F238E27FC236}">
-                <a16:creationId xmlns:a16="http://schemas.microsoft.com/office/drawing/2014/main" id="{E9D719DD-DE7E-DED6-A18B-B084A027B2DE}"/>
+                <a16:creationId xmlns:a16="http://schemas.microsoft.com/office/drawing/2014/main" id="{18C85979-FA04-F6B4-1A25-5254037C1655}"/>
               </a:ext>
             </a:extLst>
           </p:cNvPr>
@@ -8876,10 +10052,10 @@
       </p:sp>
       <p:sp>
         <p:nvSpPr>
-          <p:cNvPr id="3" name="テキスト ボックス 2">
+          <p:cNvPr id="11" name="テキスト ボックス 10">
             <a:extLst>
               <a:ext uri="{FF2B5EF4-FFF2-40B4-BE49-F238E27FC236}">
-                <a16:creationId xmlns:a16="http://schemas.microsoft.com/office/drawing/2014/main" id="{9F86F671-02C9-9E9B-5F0D-DC2FAC11DD2F}"/>
+                <a16:creationId xmlns:a16="http://schemas.microsoft.com/office/drawing/2014/main" id="{A798E74C-E29E-7137-31D2-45EEB48C6114}"/>
               </a:ext>
             </a:extLst>
           </p:cNvPr>
@@ -8889,7 +10065,7 @@
         <p:spPr>
           <a:xfrm>
             <a:off x="668508" y="950188"/>
-            <a:ext cx="5649491" cy="400110"/>
+            <a:ext cx="5649491" cy="553998"/>
           </a:xfrm>
           <a:prstGeom prst="rect">
             <a:avLst/>
@@ -8904,39 +10080,60 @@
           <a:p>
             <a:r>
               <a:rPr lang="en-US" altLang="ja-JP" sz="1000" dirty="0">
-                <a:latin typeface="IBM Plex Sans JP" panose="020B0503050203000203" pitchFamily="50" charset="-128"/>
-                <a:ea typeface="IBM Plex Sans JP" panose="020B0503050203000203" pitchFamily="50" charset="-128"/>
-              </a:rPr>
-              <a:t>The </a:t>
+                <a:latin typeface="Segoe UI Semibold" panose="020B0702040204020203" pitchFamily="34" charset="0"/>
+                <a:ea typeface="IBM Plex Sans JP" panose="020B0503050203000203" pitchFamily="50" charset="-128"/>
+                <a:cs typeface="Segoe UI Semibold" panose="020B0702040204020203" pitchFamily="34" charset="0"/>
+              </a:rPr>
+              <a:t>FlexChroma HUB </a:t>
+            </a:r>
+            <a:r>
+              <a:rPr lang="ja-JP" altLang="en-US" sz="1000" dirty="0">
+                <a:latin typeface="IBM Plex Sans JP" panose="020B0503050203000203" pitchFamily="50" charset="-128"/>
+                <a:ea typeface="IBM Plex Sans JP" panose="020B0503050203000203" pitchFamily="50" charset="-128"/>
+                <a:cs typeface="Segoe UI Semibold" panose="020B0702040204020203" pitchFamily="34" charset="0"/>
+              </a:rPr>
+              <a:t>は</a:t>
             </a:r>
             <a:r>
               <a:rPr lang="en-US" altLang="ja-JP" sz="1000" dirty="0">
-                <a:latin typeface="Segoe UI Semibold" panose="020B0702040204020203" pitchFamily="34" charset="0"/>
-                <a:ea typeface="IBM Plex Sans JP" panose="020B0503050203000203" pitchFamily="50" charset="-128"/>
-                <a:cs typeface="Segoe UI Semibold" panose="020B0702040204020203" pitchFamily="34" charset="0"/>
-              </a:rPr>
-              <a:t>FlexChroma HUB </a:t>
-            </a:r>
-            <a:r>
-              <a:rPr lang="en-US" altLang="ja-JP" sz="1000" dirty="0">
-                <a:latin typeface="IBM Plex Sans JP" panose="020B0503050203000203" pitchFamily="50" charset="-128"/>
-                <a:ea typeface="IBM Plex Sans JP" panose="020B0503050203000203" pitchFamily="50" charset="-128"/>
-              </a:rPr>
-              <a:t>is the main entry point on MakerWorld, providing access to all Series and external portals. If you are unsure where to start, open this model first.</a:t>
-            </a:r>
-            <a:endParaRPr kumimoji="1" lang="ja-JP" altLang="en-US" sz="500" b="1" dirty="0">
+                <a:latin typeface="IBM Plex Sans JP" panose="020B0503050203000203" pitchFamily="50" charset="-128"/>
+                <a:ea typeface="IBM Plex Sans JP" panose="020B0503050203000203" pitchFamily="50" charset="-128"/>
+              </a:rPr>
+              <a:t>Makerworld</a:t>
+            </a:r>
+            <a:r>
+              <a:rPr lang="ja-JP" altLang="ja-JP" sz="1000" dirty="0">
+                <a:latin typeface="IBM Plex Sans JP" panose="020B0503050203000203" pitchFamily="50" charset="-128"/>
+                <a:ea typeface="IBM Plex Sans JP" panose="020B0503050203000203" pitchFamily="50" charset="-128"/>
+              </a:rPr>
+              <a:t>における全てのシリーズや外部ポータルへの入口です。</a:t>
+            </a:r>
+            <a:r>
+              <a:rPr lang="ja-JP" altLang="ja-JP" sz="1000" b="1" dirty="0">
+                <a:latin typeface="IBM Plex Sans JP" panose="020B0503050203000203" pitchFamily="50" charset="-128"/>
+                <a:ea typeface="IBM Plex Sans JP" panose="020B0503050203000203" pitchFamily="50" charset="-128"/>
+              </a:rPr>
+              <a:t>迷ったらまずここを開いてください。</a:t>
+            </a:r>
+            <a:endParaRPr lang="ja-JP" altLang="ja-JP" sz="1000" dirty="0">
               <a:latin typeface="IBM Plex Sans JP" panose="020B0503050203000203" pitchFamily="50" charset="-128"/>
               <a:ea typeface="IBM Plex Sans JP" panose="020B0503050203000203" pitchFamily="50" charset="-128"/>
             </a:endParaRPr>
           </a:p>
-        </p:txBody>
-      </p:sp>
-      <p:sp>
-        <p:nvSpPr>
-          <p:cNvPr id="11" name="テキスト ボックス 10">
+          <a:p>
+            <a:endParaRPr kumimoji="1" lang="ja-JP" altLang="en-US" sz="1000" b="1" dirty="0">
+              <a:latin typeface="IBM Plex Sans JP" panose="020B0503050203000203" pitchFamily="50" charset="-128"/>
+              <a:ea typeface="IBM Plex Sans JP" panose="020B0503050203000203" pitchFamily="50" charset="-128"/>
+            </a:endParaRPr>
+          </a:p>
+        </p:txBody>
+      </p:sp>
+      <p:sp>
+        <p:nvSpPr>
+          <p:cNvPr id="12" name="テキスト ボックス 11">
             <a:extLst>
               <a:ext uri="{FF2B5EF4-FFF2-40B4-BE49-F238E27FC236}">
-                <a16:creationId xmlns:a16="http://schemas.microsoft.com/office/drawing/2014/main" id="{9331D375-CC72-3463-7EBE-AD9BD8A9AFDD}"/>
+                <a16:creationId xmlns:a16="http://schemas.microsoft.com/office/drawing/2014/main" id="{CD8BCD38-83D5-BF0D-E9F6-96FD8A35BD19}"/>
               </a:ext>
             </a:extLst>
           </p:cNvPr>
@@ -8945,7 +10142,7 @@
         </p:nvSpPr>
         <p:spPr>
           <a:xfrm>
-            <a:off x="770844" y="2574192"/>
+            <a:off x="770844" y="2440080"/>
             <a:ext cx="2379177" cy="400110"/>
           </a:xfrm>
           <a:prstGeom prst="rect">
@@ -8975,10 +10172,10 @@
       </p:sp>
       <p:sp>
         <p:nvSpPr>
-          <p:cNvPr id="12" name="テキスト ボックス 11">
+          <p:cNvPr id="23" name="テキスト ボックス 22">
             <a:extLst>
               <a:ext uri="{FF2B5EF4-FFF2-40B4-BE49-F238E27FC236}">
-                <a16:creationId xmlns:a16="http://schemas.microsoft.com/office/drawing/2014/main" id="{53F77DD3-6423-8DE1-AC87-0DD7AF777795}"/>
+                <a16:creationId xmlns:a16="http://schemas.microsoft.com/office/drawing/2014/main" id="{50BCCB88-45BA-28DD-EAD4-7C869FD19E5D}"/>
               </a:ext>
             </a:extLst>
           </p:cNvPr>
@@ -8987,8 +10184,8 @@
         </p:nvSpPr>
         <p:spPr>
           <a:xfrm>
-            <a:off x="668509" y="2953843"/>
-            <a:ext cx="5642222" cy="1107996"/>
+            <a:off x="668509" y="2819731"/>
+            <a:ext cx="5642222" cy="1323439"/>
           </a:xfrm>
           <a:prstGeom prst="rect">
             <a:avLst/>
@@ -9006,27 +10203,115 @@
                 <a:latin typeface="IBM Plex Sans JP" panose="020B0503050203000203" pitchFamily="50" charset="-128"/>
                 <a:ea typeface="IBM Plex Sans JP" panose="020B0503050203000203" pitchFamily="50" charset="-128"/>
               </a:rPr>
-              <a:t>The Blend Filament Series is the most basic FlexChroma lineup. It allows you to mix two filaments at various ratios to create your own custom color.</a:t>
-            </a:r>
-          </a:p>
-          <a:p>
+              <a:t>Blend Filament</a:t>
+            </a:r>
+            <a:r>
+              <a:rPr lang="ja-JP" altLang="ja-JP" sz="1000" dirty="0">
+                <a:latin typeface="IBM Plex Sans JP" panose="020B0503050203000203" pitchFamily="50" charset="-128"/>
+                <a:ea typeface="IBM Plex Sans JP" panose="020B0503050203000203" pitchFamily="50" charset="-128"/>
+              </a:rPr>
+              <a:t>シリーズは</a:t>
+            </a:r>
             <a:r>
               <a:rPr lang="en-US" altLang="ja-JP" sz="1000" dirty="0">
-                <a:latin typeface="IBM Plex Sans JP" panose="020B0503050203000203" pitchFamily="50" charset="-128"/>
-                <a:ea typeface="IBM Plex Sans JP" panose="020B0503050203000203" pitchFamily="50" charset="-128"/>
-              </a:rPr>
-              <a:t>Each model supports blend ratios from 50% to 99.5</a:t>
+                <a:latin typeface="Segoe UI Semibold" panose="020B0702040204020203" pitchFamily="34" charset="0"/>
+                <a:ea typeface="IBM Plex Sans JP" panose="020B0503050203000203" pitchFamily="50" charset="-128"/>
+                <a:cs typeface="Segoe UI Semibold" panose="020B0702040204020203" pitchFamily="34" charset="0"/>
+              </a:rPr>
+              <a:t>FlexChroma</a:t>
+            </a:r>
+            <a:r>
+              <a:rPr lang="ja-JP" altLang="ja-JP" sz="1000" dirty="0">
+                <a:latin typeface="IBM Plex Sans JP" panose="020B0503050203000203" pitchFamily="50" charset="-128"/>
+                <a:ea typeface="IBM Plex Sans JP" panose="020B0503050203000203" pitchFamily="50" charset="-128"/>
+              </a:rPr>
+              <a:t>の最も基礎的なシリーズです。</a:t>
+            </a:r>
+            <a:r>
+              <a:rPr lang="en-US" altLang="ja-JP" sz="1000" dirty="0">
+                <a:latin typeface="IBM Plex Sans JP" panose="020B0503050203000203" pitchFamily="50" charset="-128"/>
+                <a:ea typeface="IBM Plex Sans JP" panose="020B0503050203000203" pitchFamily="50" charset="-128"/>
+              </a:rPr>
+              <a:t>2</a:t>
+            </a:r>
+            <a:r>
+              <a:rPr lang="ja-JP" altLang="ja-JP" sz="1000" dirty="0">
+                <a:latin typeface="IBM Plex Sans JP" panose="020B0503050203000203" pitchFamily="50" charset="-128"/>
+                <a:ea typeface="IBM Plex Sans JP" panose="020B0503050203000203" pitchFamily="50" charset="-128"/>
+              </a:rPr>
+              <a:t>つのフィラメントを様々な混合比で混ぜ合わせ、あなただけの新しい色を作ることが出来ます。各モデルは</a:t>
+            </a:r>
+            <a:r>
+              <a:rPr lang="en-US" altLang="ja-JP" sz="1000" dirty="0">
+                <a:latin typeface="IBM Plex Sans JP" panose="020B0503050203000203" pitchFamily="50" charset="-128"/>
+                <a:ea typeface="IBM Plex Sans JP" panose="020B0503050203000203" pitchFamily="50" charset="-128"/>
+              </a:rPr>
+              <a:t>50</a:t>
+            </a:r>
+            <a:r>
+              <a:rPr lang="ja-JP" altLang="ja-JP" sz="1000" dirty="0">
+                <a:latin typeface="IBM Plex Sans JP" panose="020B0503050203000203" pitchFamily="50" charset="-128"/>
+                <a:ea typeface="IBM Plex Sans JP" panose="020B0503050203000203" pitchFamily="50" charset="-128"/>
+              </a:rPr>
+              <a:t>％～</a:t>
+            </a:r>
+            <a:r>
+              <a:rPr lang="en-US" altLang="ja-JP" sz="1000" dirty="0">
+                <a:latin typeface="IBM Plex Sans JP" panose="020B0503050203000203" pitchFamily="50" charset="-128"/>
+                <a:ea typeface="IBM Plex Sans JP" panose="020B0503050203000203" pitchFamily="50" charset="-128"/>
+              </a:rPr>
+              <a:t>99.5%</a:t>
+            </a:r>
+            <a:r>
+              <a:rPr lang="ja-JP" altLang="ja-JP" sz="1000" dirty="0">
+                <a:latin typeface="IBM Plex Sans JP" panose="020B0503050203000203" pitchFamily="50" charset="-128"/>
+                <a:ea typeface="IBM Plex Sans JP" panose="020B0503050203000203" pitchFamily="50" charset="-128"/>
+              </a:rPr>
+              <a:t>までの混色比</a:t>
+            </a:r>
+            <a:r>
+              <a:rPr lang="en-US" altLang="ja-JP" sz="1000" dirty="0">
+                <a:latin typeface="IBM Plex Sans JP" panose="020B0503050203000203" pitchFamily="50" charset="-128"/>
+                <a:ea typeface="IBM Plex Sans JP" panose="020B0503050203000203" pitchFamily="50" charset="-128"/>
+              </a:rPr>
+              <a:t>Profile</a:t>
+            </a:r>
+            <a:r>
+              <a:rPr lang="ja-JP" altLang="ja-JP" sz="1000" dirty="0">
+                <a:latin typeface="IBM Plex Sans JP" panose="020B0503050203000203" pitchFamily="50" charset="-128"/>
+                <a:ea typeface="IBM Plex Sans JP" panose="020B0503050203000203" pitchFamily="50" charset="-128"/>
+              </a:rPr>
+              <a:t>をもっていますが、</a:t>
             </a:r>
             <a:r>
               <a:rPr lang="en-US" altLang="ja-JP" sz="1000" b="1" dirty="0">
                 <a:latin typeface="IBM Plex Sans JP" panose="020B0503050203000203" pitchFamily="50" charset="-128"/>
                 <a:ea typeface="IBM Plex Sans JP" panose="020B0503050203000203" pitchFamily="50" charset="-128"/>
               </a:rPr>
-              <a:t>%. For ratios below 50%, simply swap Filament A and Filament B.</a:t>
-            </a:r>
-          </a:p>
-          <a:p>
-            <a:endParaRPr lang="en-US" altLang="ja-JP" sz="600" dirty="0">
+              <a:t>50</a:t>
+            </a:r>
+            <a:r>
+              <a:rPr lang="ja-JP" altLang="ja-JP" sz="1000" b="1" dirty="0">
+                <a:latin typeface="IBM Plex Sans JP" panose="020B0503050203000203" pitchFamily="50" charset="-128"/>
+                <a:ea typeface="IBM Plex Sans JP" panose="020B0503050203000203" pitchFamily="50" charset="-128"/>
+              </a:rPr>
+              <a:t>％未満の混色比についてはフィラメント</a:t>
+            </a:r>
+            <a:r>
+              <a:rPr lang="en-US" altLang="ja-JP" sz="1000" b="1" dirty="0">
+                <a:latin typeface="IBM Plex Sans JP" panose="020B0503050203000203" pitchFamily="50" charset="-128"/>
+                <a:ea typeface="IBM Plex Sans JP" panose="020B0503050203000203" pitchFamily="50" charset="-128"/>
+              </a:rPr>
+              <a:t>A/B</a:t>
+            </a:r>
+            <a:r>
+              <a:rPr lang="ja-JP" altLang="ja-JP" sz="1000" b="1" dirty="0">
+                <a:latin typeface="IBM Plex Sans JP" panose="020B0503050203000203" pitchFamily="50" charset="-128"/>
+                <a:ea typeface="IBM Plex Sans JP" panose="020B0503050203000203" pitchFamily="50" charset="-128"/>
+              </a:rPr>
+              <a:t>を入れ替えることで得ることが出来ます。</a:t>
+            </a:r>
+            <a:endParaRPr lang="ja-JP" altLang="ja-JP" sz="1000" dirty="0">
               <a:latin typeface="IBM Plex Sans JP" panose="020B0503050203000203" pitchFamily="50" charset="-128"/>
               <a:ea typeface="IBM Plex Sans JP" panose="020B0503050203000203" pitchFamily="50" charset="-128"/>
             </a:endParaRPr>
@@ -9037,21 +10322,102 @@
                 <a:latin typeface="IBM Plex Sans JP" panose="020B0503050203000203" pitchFamily="50" charset="-128"/>
                 <a:ea typeface="IBM Plex Sans JP" panose="020B0503050203000203" pitchFamily="50" charset="-128"/>
               </a:rPr>
-              <a:t>Example: To create a filament with 25% cyan mixed into yellow, read the Plate value as the ratio of Filament A, interpret it as 75% yellow, and slice the model accordingly.</a:t>
-            </a:r>
-            <a:endParaRPr kumimoji="1" lang="ja-JP" altLang="en-US" sz="1000" b="1" dirty="0">
+              <a:t> </a:t>
+            </a:r>
+            <a:endParaRPr lang="ja-JP" altLang="ja-JP" sz="1000" dirty="0">
               <a:latin typeface="IBM Plex Sans JP" panose="020B0503050203000203" pitchFamily="50" charset="-128"/>
               <a:ea typeface="IBM Plex Sans JP" panose="020B0503050203000203" pitchFamily="50" charset="-128"/>
             </a:endParaRPr>
           </a:p>
-        </p:txBody>
-      </p:sp>
-      <p:sp>
-        <p:nvSpPr>
-          <p:cNvPr id="23" name="テキスト ボックス 22">
+          <a:p>
+            <a:r>
+              <a:rPr lang="ja-JP" altLang="ja-JP" sz="1000" dirty="0">
+                <a:latin typeface="IBM Plex Sans JP" panose="020B0503050203000203" pitchFamily="50" charset="-128"/>
+                <a:ea typeface="IBM Plex Sans JP" panose="020B0503050203000203" pitchFamily="50" charset="-128"/>
+              </a:rPr>
+              <a:t>以下はイエローにシアンを</a:t>
+            </a:r>
+            <a:r>
+              <a:rPr lang="en-US" altLang="ja-JP" sz="1000" dirty="0">
+                <a:latin typeface="IBM Plex Sans JP" panose="020B0503050203000203" pitchFamily="50" charset="-128"/>
+                <a:ea typeface="IBM Plex Sans JP" panose="020B0503050203000203" pitchFamily="50" charset="-128"/>
+              </a:rPr>
+              <a:t>25%</a:t>
+            </a:r>
+            <a:r>
+              <a:rPr lang="ja-JP" altLang="ja-JP" sz="1000" dirty="0">
+                <a:latin typeface="IBM Plex Sans JP" panose="020B0503050203000203" pitchFamily="50" charset="-128"/>
+                <a:ea typeface="IBM Plex Sans JP" panose="020B0503050203000203" pitchFamily="50" charset="-128"/>
+              </a:rPr>
+              <a:t>混ぜた</a:t>
+            </a:r>
+            <a:r>
+              <a:rPr lang="en-US" altLang="ja-JP" sz="1000" dirty="0">
+                <a:latin typeface="IBM Plex Sans JP" panose="020B0503050203000203" pitchFamily="50" charset="-128"/>
+                <a:ea typeface="IBM Plex Sans JP" panose="020B0503050203000203" pitchFamily="50" charset="-128"/>
+              </a:rPr>
+              <a:t>Blend Filament</a:t>
+            </a:r>
+            <a:r>
+              <a:rPr lang="ja-JP" altLang="ja-JP" sz="1000" dirty="0">
+                <a:latin typeface="IBM Plex Sans JP" panose="020B0503050203000203" pitchFamily="50" charset="-128"/>
+                <a:ea typeface="IBM Plex Sans JP" panose="020B0503050203000203" pitchFamily="50" charset="-128"/>
+              </a:rPr>
+              <a:t>を作る場合の例です。</a:t>
+            </a:r>
+          </a:p>
+          <a:p>
+            <a:r>
+              <a:rPr lang="en-US" altLang="ja-JP" sz="1000" dirty="0">
+                <a:latin typeface="IBM Plex Sans JP" panose="020B0503050203000203" pitchFamily="50" charset="-128"/>
+                <a:ea typeface="IBM Plex Sans JP" panose="020B0503050203000203" pitchFamily="50" charset="-128"/>
+              </a:rPr>
+              <a:t>Plate</a:t>
+            </a:r>
+            <a:r>
+              <a:rPr lang="ja-JP" altLang="ja-JP" sz="1000" dirty="0">
+                <a:latin typeface="IBM Plex Sans JP" panose="020B0503050203000203" pitchFamily="50" charset="-128"/>
+                <a:ea typeface="IBM Plex Sans JP" panose="020B0503050203000203" pitchFamily="50" charset="-128"/>
+              </a:rPr>
+              <a:t>に記載されている数値はフィラメント</a:t>
+            </a:r>
+            <a:r>
+              <a:rPr lang="en-US" altLang="ja-JP" sz="1000" dirty="0">
+                <a:latin typeface="IBM Plex Sans JP" panose="020B0503050203000203" pitchFamily="50" charset="-128"/>
+                <a:ea typeface="IBM Plex Sans JP" panose="020B0503050203000203" pitchFamily="50" charset="-128"/>
+              </a:rPr>
+              <a:t>A</a:t>
+            </a:r>
+            <a:r>
+              <a:rPr lang="ja-JP" altLang="ja-JP" sz="1000" dirty="0">
+                <a:latin typeface="IBM Plex Sans JP" panose="020B0503050203000203" pitchFamily="50" charset="-128"/>
+                <a:ea typeface="IBM Plex Sans JP" panose="020B0503050203000203" pitchFamily="50" charset="-128"/>
+              </a:rPr>
+              <a:t>の割合です。そのためこの例ではイエローを</a:t>
+            </a:r>
+            <a:r>
+              <a:rPr lang="en-US" altLang="ja-JP" sz="1000" dirty="0">
+                <a:latin typeface="IBM Plex Sans JP" panose="020B0503050203000203" pitchFamily="50" charset="-128"/>
+                <a:ea typeface="IBM Plex Sans JP" panose="020B0503050203000203" pitchFamily="50" charset="-128"/>
+              </a:rPr>
+              <a:t>75%</a:t>
+            </a:r>
+            <a:r>
+              <a:rPr lang="ja-JP" altLang="ja-JP" sz="1000" dirty="0">
+                <a:latin typeface="IBM Plex Sans JP" panose="020B0503050203000203" pitchFamily="50" charset="-128"/>
+                <a:ea typeface="IBM Plex Sans JP" panose="020B0503050203000203" pitchFamily="50" charset="-128"/>
+              </a:rPr>
+              <a:t>にすると読み替えて、スライスまでのの設定を選びます。</a:t>
+            </a:r>
+          </a:p>
+        </p:txBody>
+      </p:sp>
+      <p:sp>
+        <p:nvSpPr>
+          <p:cNvPr id="24" name="テキスト ボックス 23">
             <a:extLst>
               <a:ext uri="{FF2B5EF4-FFF2-40B4-BE49-F238E27FC236}">
-                <a16:creationId xmlns:a16="http://schemas.microsoft.com/office/drawing/2014/main" id="{4115F0A8-4267-0FEB-9B1F-41BC20F962C4}"/>
+                <a16:creationId xmlns:a16="http://schemas.microsoft.com/office/drawing/2014/main" id="{33E7CC69-3B3F-F3A6-3DCF-D170E51F244D}"/>
               </a:ext>
             </a:extLst>
           </p:cNvPr>
@@ -9060,7 +10426,7 @@
         </p:nvSpPr>
         <p:spPr>
           <a:xfrm>
-            <a:off x="668508" y="5046262"/>
+            <a:off x="668508" y="5070646"/>
             <a:ext cx="5642222" cy="246221"/>
           </a:xfrm>
           <a:prstGeom prst="rect">
@@ -9075,11 +10441,25 @@
           <a:lstStyle/>
           <a:p>
             <a:r>
+              <a:rPr lang="ja-JP" altLang="ja-JP" sz="1000" dirty="0">
+                <a:latin typeface="IBM Plex Sans JP" panose="020B0503050203000203" pitchFamily="50" charset="-128"/>
+                <a:ea typeface="IBM Plex Sans JP" panose="020B0503050203000203" pitchFamily="50" charset="-128"/>
+              </a:rPr>
+              <a:t>以下は</a:t>
+            </a:r>
+            <a:r>
               <a:rPr lang="en-US" altLang="ja-JP" sz="1000" dirty="0">
                 <a:latin typeface="IBM Plex Sans JP" panose="020B0503050203000203" pitchFamily="50" charset="-128"/>
                 <a:ea typeface="IBM Plex Sans JP" panose="020B0503050203000203" pitchFamily="50" charset="-128"/>
               </a:rPr>
-              <a:t>The following is the model configuration for Blend Filament.</a:t>
+              <a:t>Blend Filament</a:t>
+            </a:r>
+            <a:r>
+              <a:rPr lang="ja-JP" altLang="ja-JP" sz="1000" dirty="0">
+                <a:latin typeface="IBM Plex Sans JP" panose="020B0503050203000203" pitchFamily="50" charset="-128"/>
+                <a:ea typeface="IBM Plex Sans JP" panose="020B0503050203000203" pitchFamily="50" charset="-128"/>
+              </a:rPr>
+              <a:t>のモデル構成です。</a:t>
             </a:r>
           </a:p>
         </p:txBody>
@@ -9089,7 +10469,7 @@
           <p:cNvPr id="26" name="図 25">
             <a:extLst>
               <a:ext uri="{FF2B5EF4-FFF2-40B4-BE49-F238E27FC236}">
-                <a16:creationId xmlns:a16="http://schemas.microsoft.com/office/drawing/2014/main" id="{D599B3A6-5BF1-475A-455C-4CE16066520F}"/>
+                <a16:creationId xmlns:a16="http://schemas.microsoft.com/office/drawing/2014/main" id="{C0977733-1EC6-18D0-367E-FB8E73078387}"/>
               </a:ext>
             </a:extLst>
           </p:cNvPr>
@@ -9113,7 +10493,7 @@
         </p:blipFill>
         <p:spPr bwMode="auto">
           <a:xfrm>
-            <a:off x="770844" y="5325050"/>
+            <a:off x="770844" y="5337242"/>
             <a:ext cx="5264196" cy="3270393"/>
           </a:xfrm>
           <a:prstGeom prst="rect">
@@ -9133,10 +10513,40 @@
       </p:pic>
       <p:pic>
         <p:nvPicPr>
-          <p:cNvPr id="38" name="図 37">
+          <p:cNvPr id="27" name="図 26">
             <a:extLst>
               <a:ext uri="{FF2B5EF4-FFF2-40B4-BE49-F238E27FC236}">
-                <a16:creationId xmlns:a16="http://schemas.microsoft.com/office/drawing/2014/main" id="{24EE4D19-C95F-DECA-987F-D6FD0CAF2F69}"/>
+                <a16:creationId xmlns:a16="http://schemas.microsoft.com/office/drawing/2014/main" id="{2C8B8E17-B4AE-E354-9224-6D8A5A7B49F2}"/>
+              </a:ext>
+            </a:extLst>
+          </p:cNvPr>
+          <p:cNvPicPr>
+            <a:picLocks noChangeAspect="1"/>
+          </p:cNvPicPr>
+          <p:nvPr/>
+        </p:nvPicPr>
+        <p:blipFill>
+          <a:blip r:embed="rId3"/>
+          <a:stretch>
+            <a:fillRect/>
+          </a:stretch>
+        </p:blipFill>
+        <p:spPr>
+          <a:xfrm>
+            <a:off x="709884" y="4161494"/>
+            <a:ext cx="5325156" cy="831813"/>
+          </a:xfrm>
+          <a:prstGeom prst="rect">
+            <a:avLst/>
+          </a:prstGeom>
+        </p:spPr>
+      </p:pic>
+      <p:pic>
+        <p:nvPicPr>
+          <p:cNvPr id="28" name="図 27">
+            <a:extLst>
+              <a:ext uri="{FF2B5EF4-FFF2-40B4-BE49-F238E27FC236}">
+                <a16:creationId xmlns:a16="http://schemas.microsoft.com/office/drawing/2014/main" id="{9B3FC674-F120-51BF-92D1-0CCE403D465B}"/>
               </a:ext>
             </a:extLst>
           </p:cNvPr>
@@ -9146,7 +10556,7 @@
           <p:nvPr/>
         </p:nvPicPr>
         <p:blipFill rotWithShape="1">
-          <a:blip r:embed="rId3">
+          <a:blip r:embed="rId4">
             <a:extLst>
               <a:ext uri="{28A0092B-C50C-407E-A947-70E740481C1C}">
                 <a14:useLocalDpi xmlns:a14="http://schemas.microsoft.com/office/drawing/2010/main" val="0"/>
@@ -9160,55 +10570,8 @@
         </p:blipFill>
         <p:spPr bwMode="auto">
           <a:xfrm>
-            <a:off x="1091915" y="1374795"/>
+            <a:off x="1091915" y="1338219"/>
             <a:ext cx="4561094" cy="1014727"/>
-          </a:xfrm>
-          <a:prstGeom prst="rect">
-            <a:avLst/>
-          </a:prstGeom>
-          <a:noFill/>
-          <a:extLst>
-            <a:ext uri="{909E8E84-426E-40DD-AFC4-6F175D3DCCD1}">
-              <a14:hiddenFill xmlns:a14="http://schemas.microsoft.com/office/drawing/2010/main">
-                <a:solidFill>
-                  <a:srgbClr val="FFFFFF"/>
-                </a:solidFill>
-              </a14:hiddenFill>
-            </a:ext>
-          </a:extLst>
-        </p:spPr>
-      </p:pic>
-      <p:pic>
-        <p:nvPicPr>
-          <p:cNvPr id="4" name="図 3">
-            <a:extLst>
-              <a:ext uri="{FF2B5EF4-FFF2-40B4-BE49-F238E27FC236}">
-                <a16:creationId xmlns:a16="http://schemas.microsoft.com/office/drawing/2014/main" id="{31322046-DA05-E453-193E-B1947F2711C9}"/>
-              </a:ext>
-            </a:extLst>
-          </p:cNvPr>
-          <p:cNvPicPr>
-            <a:picLocks noChangeAspect="1" noChangeArrowheads="1"/>
-          </p:cNvPicPr>
-          <p:nvPr/>
-        </p:nvPicPr>
-        <p:blipFill>
-          <a:blip r:embed="rId4">
-            <a:extLst>
-              <a:ext uri="{28A0092B-C50C-407E-A947-70E740481C1C}">
-                <a14:useLocalDpi xmlns:a14="http://schemas.microsoft.com/office/drawing/2010/main" val="0"/>
-              </a:ext>
-            </a:extLst>
-          </a:blip>
-          <a:srcRect/>
-          <a:stretch>
-            <a:fillRect/>
-          </a:stretch>
-        </p:blipFill>
-        <p:spPr bwMode="auto">
-          <a:xfrm>
-            <a:off x="659626" y="4065069"/>
-            <a:ext cx="5529865" cy="863845"/>
           </a:xfrm>
           <a:prstGeom prst="rect">
             <a:avLst/>
@@ -9228,7 +10591,7 @@
     </p:spTree>
     <p:extLst>
       <p:ext uri="{BB962C8B-B14F-4D97-AF65-F5344CB8AC3E}">
-        <p14:creationId xmlns:p14="http://schemas.microsoft.com/office/powerpoint/2010/main" val="1711923920"/>
+        <p14:creationId xmlns:p14="http://schemas.microsoft.com/office/powerpoint/2010/main" val="3492068226"/>
       </p:ext>
     </p:extLst>
   </p:cSld>
@@ -9246,7 +10609,7 @@
         <p:cNvPr id="1" name="">
           <a:extLst>
             <a:ext uri="{FF2B5EF4-FFF2-40B4-BE49-F238E27FC236}">
-              <a16:creationId xmlns:a16="http://schemas.microsoft.com/office/drawing/2014/main" id="{3D99E812-8D39-99F5-1D23-0E1A450CC131}"/>
+              <a16:creationId xmlns:a16="http://schemas.microsoft.com/office/drawing/2014/main" id="{206E907F-33A2-C649-A0EB-5ACCE72727A5}"/>
             </a:ext>
           </a:extLst>
         </p:cNvPr>
@@ -9263,10 +10626,10 @@
       </p:grpSpPr>
       <p:sp>
         <p:nvSpPr>
-          <p:cNvPr id="3" name="正方形/長方形 2">
+          <p:cNvPr id="30" name="正方形/長方形 29">
             <a:extLst>
               <a:ext uri="{FF2B5EF4-FFF2-40B4-BE49-F238E27FC236}">
-                <a16:creationId xmlns:a16="http://schemas.microsoft.com/office/drawing/2014/main" id="{6D89B353-9D95-712D-2512-32F299577803}"/>
+                <a16:creationId xmlns:a16="http://schemas.microsoft.com/office/drawing/2014/main" id="{6F0F53F1-FFCD-EDD8-027D-BB71DCD5E93F}"/>
               </a:ext>
             </a:extLst>
           </p:cNvPr>
@@ -9275,7 +10638,7 @@
         </p:nvSpPr>
         <p:spPr>
           <a:xfrm>
-            <a:off x="33951" y="45268"/>
+            <a:off x="51086" y="45268"/>
             <a:ext cx="6790099" cy="9053465"/>
           </a:xfrm>
           <a:prstGeom prst="rect">
@@ -9326,10 +10689,10 @@
       </p:sp>
       <p:sp>
         <p:nvSpPr>
-          <p:cNvPr id="7" name="フリーフォーム: 図形 6">
+          <p:cNvPr id="19" name="フリーフォーム: 図形 18">
             <a:extLst>
               <a:ext uri="{FF2B5EF4-FFF2-40B4-BE49-F238E27FC236}">
-                <a16:creationId xmlns:a16="http://schemas.microsoft.com/office/drawing/2014/main" id="{EBB0D2A0-3A2E-56E5-5FE5-78980A9D36F4}"/>
+                <a16:creationId xmlns:a16="http://schemas.microsoft.com/office/drawing/2014/main" id="{E925E3B5-F543-14FD-B64D-E00E01624B23}"/>
               </a:ext>
             </a:extLst>
           </p:cNvPr>
@@ -9338,63 +10701,63 @@
         </p:nvSpPr>
         <p:spPr>
           <a:xfrm>
-            <a:off x="-3233" y="0"/>
-            <a:ext cx="6861231" cy="9144000"/>
+            <a:off x="17051" y="5531"/>
+            <a:ext cx="6858000" cy="9144000"/>
           </a:xfrm>
           <a:custGeom>
             <a:avLst/>
             <a:gdLst>
-              <a:gd name="connsiteX0" fmla="*/ 3739836 w 6861231"/>
-              <a:gd name="connsiteY0" fmla="*/ 8661917 h 9144000"/>
-              <a:gd name="connsiteX1" fmla="*/ 3739836 w 6861231"/>
-              <a:gd name="connsiteY1" fmla="*/ 8715917 h 9144000"/>
-              <a:gd name="connsiteX2" fmla="*/ 6333058 w 6861231"/>
-              <a:gd name="connsiteY2" fmla="*/ 8715917 h 9144000"/>
-              <a:gd name="connsiteX3" fmla="*/ 6333058 w 6861231"/>
-              <a:gd name="connsiteY3" fmla="*/ 8661917 h 9144000"/>
-              <a:gd name="connsiteX4" fmla="*/ 558032 w 6861231"/>
-              <a:gd name="connsiteY4" fmla="*/ 8661917 h 9144000"/>
-              <a:gd name="connsiteX5" fmla="*/ 558032 w 6861231"/>
-              <a:gd name="connsiteY5" fmla="*/ 8715917 h 9144000"/>
-              <a:gd name="connsiteX6" fmla="*/ 3151253 w 6861231"/>
-              <a:gd name="connsiteY6" fmla="*/ 8715917 h 9144000"/>
-              <a:gd name="connsiteX7" fmla="*/ 3151253 w 6861231"/>
-              <a:gd name="connsiteY7" fmla="*/ 8661917 h 9144000"/>
-              <a:gd name="connsiteX8" fmla="*/ 651915 w 6861231"/>
-              <a:gd name="connsiteY8" fmla="*/ 7301051 h 9144000"/>
-              <a:gd name="connsiteX9" fmla="*/ 549580 w 6861231"/>
-              <a:gd name="connsiteY9" fmla="*/ 7403386 h 9144000"/>
-              <a:gd name="connsiteX10" fmla="*/ 651915 w 6861231"/>
-              <a:gd name="connsiteY10" fmla="*/ 7505721 h 9144000"/>
-              <a:gd name="connsiteX11" fmla="*/ 754250 w 6861231"/>
-              <a:gd name="connsiteY11" fmla="*/ 7403386 h 9144000"/>
-              <a:gd name="connsiteX12" fmla="*/ 651915 w 6861231"/>
-              <a:gd name="connsiteY12" fmla="*/ 7301051 h 9144000"/>
-              <a:gd name="connsiteX13" fmla="*/ 672058 w 6861231"/>
-              <a:gd name="connsiteY13" fmla="*/ 677902 h 9144000"/>
-              <a:gd name="connsiteX14" fmla="*/ 569674 w 6861231"/>
-              <a:gd name="connsiteY14" fmla="*/ 780237 h 9144000"/>
-              <a:gd name="connsiteX15" fmla="*/ 672058 w 6861231"/>
-              <a:gd name="connsiteY15" fmla="*/ 882572 h 9144000"/>
-              <a:gd name="connsiteX16" fmla="*/ 774441 w 6861231"/>
-              <a:gd name="connsiteY16" fmla="*/ 780237 h 9144000"/>
-              <a:gd name="connsiteX17" fmla="*/ 672058 w 6861231"/>
-              <a:gd name="connsiteY17" fmla="*/ 677902 h 9144000"/>
-              <a:gd name="connsiteX18" fmla="*/ 558031 w 6861231"/>
-              <a:gd name="connsiteY18" fmla="*/ 452468 h 9144000"/>
-              <a:gd name="connsiteX19" fmla="*/ 558031 w 6861231"/>
-              <a:gd name="connsiteY19" fmla="*/ 506468 h 9144000"/>
-              <a:gd name="connsiteX20" fmla="*/ 6316936 w 6861231"/>
-              <a:gd name="connsiteY20" fmla="*/ 506468 h 9144000"/>
-              <a:gd name="connsiteX21" fmla="*/ 6316936 w 6861231"/>
-              <a:gd name="connsiteY21" fmla="*/ 452468 h 9144000"/>
-              <a:gd name="connsiteX22" fmla="*/ 0 w 6861231"/>
+              <a:gd name="connsiteX0" fmla="*/ 3717793 w 6858000"/>
+              <a:gd name="connsiteY0" fmla="*/ 8656386 h 9144000"/>
+              <a:gd name="connsiteX1" fmla="*/ 3717793 w 6858000"/>
+              <a:gd name="connsiteY1" fmla="*/ 8710386 h 9144000"/>
+              <a:gd name="connsiteX2" fmla="*/ 6309793 w 6858000"/>
+              <a:gd name="connsiteY2" fmla="*/ 8710386 h 9144000"/>
+              <a:gd name="connsiteX3" fmla="*/ 6309793 w 6858000"/>
+              <a:gd name="connsiteY3" fmla="*/ 8656386 h 9144000"/>
+              <a:gd name="connsiteX4" fmla="*/ 537487 w 6858000"/>
+              <a:gd name="connsiteY4" fmla="*/ 8656386 h 9144000"/>
+              <a:gd name="connsiteX5" fmla="*/ 537487 w 6858000"/>
+              <a:gd name="connsiteY5" fmla="*/ 8710386 h 9144000"/>
+              <a:gd name="connsiteX6" fmla="*/ 3129487 w 6858000"/>
+              <a:gd name="connsiteY6" fmla="*/ 8710386 h 9144000"/>
+              <a:gd name="connsiteX7" fmla="*/ 3129487 w 6858000"/>
+              <a:gd name="connsiteY7" fmla="*/ 8656386 h 9144000"/>
+              <a:gd name="connsiteX8" fmla="*/ 631632 w 6858000"/>
+              <a:gd name="connsiteY8" fmla="*/ 7880006 h 9144000"/>
+              <a:gd name="connsiteX9" fmla="*/ 529297 w 6858000"/>
+              <a:gd name="connsiteY9" fmla="*/ 7982341 h 9144000"/>
+              <a:gd name="connsiteX10" fmla="*/ 631632 w 6858000"/>
+              <a:gd name="connsiteY10" fmla="*/ 8084676 h 9144000"/>
+              <a:gd name="connsiteX11" fmla="*/ 733967 w 6858000"/>
+              <a:gd name="connsiteY11" fmla="*/ 7982341 h 9144000"/>
+              <a:gd name="connsiteX12" fmla="*/ 631632 w 6858000"/>
+              <a:gd name="connsiteY12" fmla="*/ 7880006 h 9144000"/>
+              <a:gd name="connsiteX13" fmla="*/ 651459 w 6858000"/>
+              <a:gd name="connsiteY13" fmla="*/ 672371 h 9144000"/>
+              <a:gd name="connsiteX14" fmla="*/ 549124 w 6858000"/>
+              <a:gd name="connsiteY14" fmla="*/ 774706 h 9144000"/>
+              <a:gd name="connsiteX15" fmla="*/ 651459 w 6858000"/>
+              <a:gd name="connsiteY15" fmla="*/ 877041 h 9144000"/>
+              <a:gd name="connsiteX16" fmla="*/ 753794 w 6858000"/>
+              <a:gd name="connsiteY16" fmla="*/ 774706 h 9144000"/>
+              <a:gd name="connsiteX17" fmla="*/ 651459 w 6858000"/>
+              <a:gd name="connsiteY17" fmla="*/ 672371 h 9144000"/>
+              <a:gd name="connsiteX18" fmla="*/ 537486 w 6858000"/>
+              <a:gd name="connsiteY18" fmla="*/ 446937 h 9144000"/>
+              <a:gd name="connsiteX19" fmla="*/ 537486 w 6858000"/>
+              <a:gd name="connsiteY19" fmla="*/ 500937 h 9144000"/>
+              <a:gd name="connsiteX20" fmla="*/ 6293679 w 6858000"/>
+              <a:gd name="connsiteY20" fmla="*/ 500937 h 9144000"/>
+              <a:gd name="connsiteX21" fmla="*/ 6293679 w 6858000"/>
+              <a:gd name="connsiteY21" fmla="*/ 446937 h 9144000"/>
+              <a:gd name="connsiteX22" fmla="*/ 0 w 6858000"/>
               <a:gd name="connsiteY22" fmla="*/ 0 h 9144000"/>
-              <a:gd name="connsiteX23" fmla="*/ 6861231 w 6861231"/>
+              <a:gd name="connsiteX23" fmla="*/ 6858000 w 6858000"/>
               <a:gd name="connsiteY23" fmla="*/ 0 h 9144000"/>
-              <a:gd name="connsiteX24" fmla="*/ 6861231 w 6861231"/>
+              <a:gd name="connsiteX24" fmla="*/ 6858000 w 6858000"/>
               <a:gd name="connsiteY24" fmla="*/ 9144000 h 9144000"/>
-              <a:gd name="connsiteX25" fmla="*/ 0 w 6861231"/>
+              <a:gd name="connsiteX25" fmla="*/ 0 w 6858000"/>
               <a:gd name="connsiteY25" fmla="*/ 9144000 h 9144000"/>
             </a:gdLst>
             <a:ahLst/>
@@ -9480,102 +10843,102 @@
             </a:cxnLst>
             <a:rect l="l" t="t" r="r" b="b"/>
             <a:pathLst>
-              <a:path w="6861231" h="9144000">
+              <a:path w="6858000" h="9144000">
                 <a:moveTo>
-                  <a:pt x="3739836" y="8661917"/>
+                  <a:pt x="3717793" y="8656386"/>
                 </a:moveTo>
                 <a:lnTo>
-                  <a:pt x="3739836" y="8715917"/>
+                  <a:pt x="3717793" y="8710386"/>
                 </a:lnTo>
                 <a:lnTo>
-                  <a:pt x="6333058" y="8715917"/>
+                  <a:pt x="6309793" y="8710386"/>
                 </a:lnTo>
                 <a:lnTo>
-                  <a:pt x="6333058" y="8661917"/>
+                  <a:pt x="6309793" y="8656386"/>
                 </a:lnTo>
                 <a:close/>
                 <a:moveTo>
-                  <a:pt x="558032" y="8661917"/>
+                  <a:pt x="537487" y="8656386"/>
                 </a:moveTo>
                 <a:lnTo>
-                  <a:pt x="558032" y="8715917"/>
+                  <a:pt x="537487" y="8710386"/>
                 </a:lnTo>
                 <a:lnTo>
-                  <a:pt x="3151253" y="8715917"/>
+                  <a:pt x="3129487" y="8710386"/>
                 </a:lnTo>
                 <a:lnTo>
-                  <a:pt x="3151253" y="8661917"/>
+                  <a:pt x="3129487" y="8656386"/>
                 </a:lnTo>
                 <a:close/>
                 <a:moveTo>
-                  <a:pt x="651915" y="7301051"/>
+                  <a:pt x="631632" y="7880006"/>
                 </a:moveTo>
                 <a:cubicBezTo>
-                  <a:pt x="595397" y="7301051"/>
-                  <a:pt x="549580" y="7346868"/>
-                  <a:pt x="549580" y="7403386"/>
+                  <a:pt x="575114" y="7880006"/>
+                  <a:pt x="529297" y="7925823"/>
+                  <a:pt x="529297" y="7982341"/>
                 </a:cubicBezTo>
                 <a:cubicBezTo>
-                  <a:pt x="549580" y="7459904"/>
-                  <a:pt x="595397" y="7505721"/>
-                  <a:pt x="651915" y="7505721"/>
+                  <a:pt x="529297" y="8038859"/>
+                  <a:pt x="575114" y="8084676"/>
+                  <a:pt x="631632" y="8084676"/>
                 </a:cubicBezTo>
                 <a:cubicBezTo>
-                  <a:pt x="708433" y="7505721"/>
-                  <a:pt x="754250" y="7459904"/>
-                  <a:pt x="754250" y="7403386"/>
+                  <a:pt x="688150" y="8084676"/>
+                  <a:pt x="733967" y="8038859"/>
+                  <a:pt x="733967" y="7982341"/>
                 </a:cubicBezTo>
                 <a:cubicBezTo>
-                  <a:pt x="754250" y="7346868"/>
-                  <a:pt x="708433" y="7301051"/>
-                  <a:pt x="651915" y="7301051"/>
+                  <a:pt x="733967" y="7925823"/>
+                  <a:pt x="688150" y="7880006"/>
+                  <a:pt x="631632" y="7880006"/>
                 </a:cubicBezTo>
                 <a:close/>
                 <a:moveTo>
-                  <a:pt x="672058" y="677902"/>
+                  <a:pt x="651459" y="672371"/>
                 </a:moveTo>
                 <a:cubicBezTo>
-                  <a:pt x="615513" y="677902"/>
-                  <a:pt x="569674" y="723719"/>
-                  <a:pt x="569674" y="780237"/>
+                  <a:pt x="594941" y="672371"/>
+                  <a:pt x="549124" y="718188"/>
+                  <a:pt x="549124" y="774706"/>
                 </a:cubicBezTo>
                 <a:cubicBezTo>
-                  <a:pt x="569674" y="836755"/>
-                  <a:pt x="615513" y="882572"/>
-                  <a:pt x="672058" y="882572"/>
+                  <a:pt x="549124" y="831224"/>
+                  <a:pt x="594941" y="877041"/>
+                  <a:pt x="651459" y="877041"/>
                 </a:cubicBezTo>
                 <a:cubicBezTo>
-                  <a:pt x="728602" y="882572"/>
-                  <a:pt x="774441" y="836755"/>
-                  <a:pt x="774441" y="780237"/>
+                  <a:pt x="707977" y="877041"/>
+                  <a:pt x="753794" y="831224"/>
+                  <a:pt x="753794" y="774706"/>
                 </a:cubicBezTo>
                 <a:cubicBezTo>
-                  <a:pt x="774441" y="723719"/>
-                  <a:pt x="728602" y="677902"/>
-                  <a:pt x="672058" y="677902"/>
+                  <a:pt x="753794" y="718188"/>
+                  <a:pt x="707977" y="672371"/>
+                  <a:pt x="651459" y="672371"/>
                 </a:cubicBezTo>
                 <a:close/>
                 <a:moveTo>
-                  <a:pt x="558031" y="452468"/>
+                  <a:pt x="537486" y="446937"/>
                 </a:moveTo>
                 <a:lnTo>
-                  <a:pt x="558031" y="506468"/>
+                  <a:pt x="537486" y="500937"/>
                 </a:lnTo>
                 <a:lnTo>
-                  <a:pt x="6316936" y="506468"/>
+                  <a:pt x="6293679" y="500937"/>
                 </a:lnTo>
                 <a:lnTo>
-                  <a:pt x="6316936" y="452468"/>
+                  <a:pt x="6293679" y="446937"/>
                 </a:lnTo>
                 <a:close/>
                 <a:moveTo>
                   <a:pt x="0" y="0"/>
                 </a:moveTo>
                 <a:lnTo>
-                  <a:pt x="6861231" y="0"/>
+                  <a:pt x="6858000" y="0"/>
                 </a:lnTo>
                 <a:lnTo>
-                  <a:pt x="6861231" y="9144000"/>
+                  <a:pt x="6858000" y="9144000"/>
                 </a:lnTo>
                 <a:lnTo>
                   <a:pt x="0" y="9144000"/>
@@ -9614,63 +10977,16 @@
           <a:lstStyle/>
           <a:p>
             <a:pPr algn="ctr"/>
-            <a:endParaRPr kumimoji="1" lang="ja-JP" altLang="en-US"/>
-          </a:p>
-        </p:txBody>
-      </p:sp>
-      <p:pic>
-        <p:nvPicPr>
-          <p:cNvPr id="4" name="図 3">
-            <a:extLst>
-              <a:ext uri="{FF2B5EF4-FFF2-40B4-BE49-F238E27FC236}">
-                <a16:creationId xmlns:a16="http://schemas.microsoft.com/office/drawing/2014/main" id="{65EBD496-4320-F95D-E4F6-46AE1204BBFD}"/>
-              </a:ext>
-            </a:extLst>
-          </p:cNvPr>
-          <p:cNvPicPr>
-            <a:picLocks noChangeAspect="1" noChangeArrowheads="1"/>
-          </p:cNvPicPr>
-          <p:nvPr/>
-        </p:nvPicPr>
-        <p:blipFill>
-          <a:blip r:embed="rId2">
-            <a:extLst>
-              <a:ext uri="{28A0092B-C50C-407E-A947-70E740481C1C}">
-                <a14:useLocalDpi xmlns:a14="http://schemas.microsoft.com/office/drawing/2010/main" val="0"/>
-              </a:ext>
-            </a:extLst>
-          </a:blip>
-          <a:srcRect/>
-          <a:stretch>
-            <a:fillRect/>
-          </a:stretch>
-        </p:blipFill>
-        <p:spPr bwMode="auto">
-          <a:xfrm>
-            <a:off x="633074" y="1909692"/>
-            <a:ext cx="5636600" cy="919080"/>
-          </a:xfrm>
-          <a:prstGeom prst="rect">
-            <a:avLst/>
-          </a:prstGeom>
-          <a:noFill/>
-          <a:extLst>
-            <a:ext uri="{909E8E84-426E-40DD-AFC4-6F175D3DCCD1}">
-              <a14:hiddenFill xmlns:a14="http://schemas.microsoft.com/office/drawing/2010/main">
-                <a:solidFill>
-                  <a:srgbClr val="FFFFFF"/>
-                </a:solidFill>
-              </a14:hiddenFill>
-            </a:ext>
-          </a:extLst>
-        </p:spPr>
-      </p:pic>
+            <a:endParaRPr kumimoji="1" lang="ja-JP" altLang="en-US" dirty="0"/>
+          </a:p>
+        </p:txBody>
+      </p:sp>
       <p:sp>
         <p:nvSpPr>
           <p:cNvPr id="17" name="テキスト ボックス 16">
             <a:extLst>
               <a:ext uri="{FF2B5EF4-FFF2-40B4-BE49-F238E27FC236}">
-                <a16:creationId xmlns:a16="http://schemas.microsoft.com/office/drawing/2014/main" id="{DDFACC84-E7FE-11C7-6620-F3DEFEB06920}"/>
+                <a16:creationId xmlns:a16="http://schemas.microsoft.com/office/drawing/2014/main" id="{179A80EA-C038-4703-1BDB-466354340DA6}"/>
               </a:ext>
             </a:extLst>
           </p:cNvPr>
@@ -9704,10 +11020,10 @@
       </p:sp>
       <p:sp>
         <p:nvSpPr>
-          <p:cNvPr id="18" name="テキスト ボックス 17">
+          <p:cNvPr id="31" name="テキスト ボックス 30">
             <a:extLst>
               <a:ext uri="{FF2B5EF4-FFF2-40B4-BE49-F238E27FC236}">
-                <a16:creationId xmlns:a16="http://schemas.microsoft.com/office/drawing/2014/main" id="{AEF844E9-5EE0-D507-0BE6-EA50C139ECC5}"/>
+                <a16:creationId xmlns:a16="http://schemas.microsoft.com/office/drawing/2014/main" id="{24A4ADEE-BA21-83FA-B3D3-284329685B4E}"/>
               </a:ext>
             </a:extLst>
           </p:cNvPr>
@@ -9746,10 +11062,10 @@
       </p:sp>
       <p:sp>
         <p:nvSpPr>
-          <p:cNvPr id="19" name="テキスト ボックス 18">
+          <p:cNvPr id="32" name="テキスト ボックス 31">
             <a:extLst>
               <a:ext uri="{FF2B5EF4-FFF2-40B4-BE49-F238E27FC236}">
-                <a16:creationId xmlns:a16="http://schemas.microsoft.com/office/drawing/2014/main" id="{79E1405D-DAD0-B18A-CDD6-7E8756624CA9}"/>
+                <a16:creationId xmlns:a16="http://schemas.microsoft.com/office/drawing/2014/main" id="{18D0FA83-5583-654E-ABDF-7AC285062148}"/>
               </a:ext>
             </a:extLst>
           </p:cNvPr>
@@ -9758,8 +11074,8 @@
         </p:nvSpPr>
         <p:spPr>
           <a:xfrm>
-            <a:off x="668508" y="1032957"/>
-            <a:ext cx="5649491" cy="861774"/>
+            <a:off x="668508" y="1010097"/>
+            <a:ext cx="5649491" cy="1661993"/>
           </a:xfrm>
           <a:prstGeom prst="rect">
             <a:avLst/>
@@ -9777,22 +11093,227 @@
                 <a:latin typeface="IBM Plex Sans JP" panose="020B0503050203000203" pitchFamily="50" charset="-128"/>
                 <a:ea typeface="IBM Plex Sans JP" panose="020B0503050203000203" pitchFamily="50" charset="-128"/>
               </a:rPr>
-              <a:t>The Gradient Filament Series provides multiple color-changing Profiles and Plates with different cycle counts. Details vary by model, so please refer to each model’s description.</a:t>
-            </a:r>
-          </a:p>
-          <a:p>
-            <a:endParaRPr lang="en-US" altLang="ja-JP" sz="1000" dirty="0">
+              <a:t>Gradient Filament</a:t>
+            </a:r>
+            <a:r>
+              <a:rPr lang="ja-JP" altLang="ja-JP" sz="1000" dirty="0">
+                <a:latin typeface="IBM Plex Sans JP" panose="020B0503050203000203" pitchFamily="50" charset="-128"/>
+                <a:ea typeface="IBM Plex Sans JP" panose="020B0503050203000203" pitchFamily="50" charset="-128"/>
+              </a:rPr>
+              <a:t>シリーズは色の組み合わせに合わせた複数のカーブ</a:t>
+            </a:r>
+            <a:r>
+              <a:rPr lang="en-US" altLang="ja-JP" sz="1000" dirty="0">
+                <a:latin typeface="IBM Plex Sans JP" panose="020B0503050203000203" pitchFamily="50" charset="-128"/>
+                <a:ea typeface="IBM Plex Sans JP" panose="020B0503050203000203" pitchFamily="50" charset="-128"/>
+              </a:rPr>
+              <a:t>Profile</a:t>
+            </a:r>
+            <a:r>
+              <a:rPr lang="ja-JP" altLang="ja-JP" sz="1000" dirty="0">
+                <a:latin typeface="IBM Plex Sans JP" panose="020B0503050203000203" pitchFamily="50" charset="-128"/>
+                <a:ea typeface="IBM Plex Sans JP" panose="020B0503050203000203" pitchFamily="50" charset="-128"/>
+              </a:rPr>
+              <a:t>とプレートごとにサイクル数が違うモデルを持っています。詳細は各モデルの説明文をご確認ください。</a:t>
+            </a:r>
+          </a:p>
+          <a:p>
+            <a:r>
+              <a:rPr lang="en-US" altLang="ja-JP" sz="600" dirty="0">
+                <a:latin typeface="IBM Plex Sans JP" panose="020B0503050203000203" pitchFamily="50" charset="-128"/>
+                <a:ea typeface="IBM Plex Sans JP" panose="020B0503050203000203" pitchFamily="50" charset="-128"/>
+              </a:rPr>
+              <a:t> </a:t>
+            </a:r>
+          </a:p>
+          <a:p>
+            <a:pPr marL="171450" indent="-171450">
+              <a:buFont typeface="Arial" panose="020B0604020202020204" pitchFamily="34" charset="0"/>
+              <a:buChar char="•"/>
+            </a:pPr>
+            <a:r>
+              <a:rPr lang="ja-JP" altLang="ja-JP" sz="1000" dirty="0">
+                <a:latin typeface="IBM Plex Sans JP" panose="020B0503050203000203" pitchFamily="50" charset="-128"/>
+                <a:ea typeface="IBM Plex Sans JP" panose="020B0503050203000203" pitchFamily="50" charset="-128"/>
+              </a:rPr>
+              <a:t>カラーカーブ：色の組み合わせに応じた設定。シアンとイエローならば</a:t>
+            </a:r>
+            <a:r>
+              <a:rPr lang="en-US" altLang="ja-JP" sz="1000" dirty="0">
+                <a:latin typeface="IBM Plex Sans JP" panose="020B0503050203000203" pitchFamily="50" charset="-128"/>
+                <a:ea typeface="IBM Plex Sans JP" panose="020B0503050203000203" pitchFamily="50" charset="-128"/>
+              </a:rPr>
+              <a:t>Vivid</a:t>
+            </a:r>
+            <a:r>
+              <a:rPr lang="ja-JP" altLang="ja-JP" sz="1000" dirty="0">
+                <a:latin typeface="IBM Plex Sans JP" panose="020B0503050203000203" pitchFamily="50" charset="-128"/>
+                <a:ea typeface="IBM Plex Sans JP" panose="020B0503050203000203" pitchFamily="50" charset="-128"/>
+              </a:rPr>
+              <a:t>、白とマゼンタならば</a:t>
+            </a:r>
+            <a:r>
+              <a:rPr lang="en-US" altLang="ja-JP" sz="1000" dirty="0">
+                <a:latin typeface="IBM Plex Sans JP" panose="020B0503050203000203" pitchFamily="50" charset="-128"/>
+                <a:ea typeface="IBM Plex Sans JP" panose="020B0503050203000203" pitchFamily="50" charset="-128"/>
+              </a:rPr>
+              <a:t>Contrast</a:t>
+            </a:r>
+            <a:r>
+              <a:rPr lang="ja-JP" altLang="ja-JP" sz="1000" dirty="0">
+                <a:latin typeface="IBM Plex Sans JP" panose="020B0503050203000203" pitchFamily="50" charset="-128"/>
+                <a:ea typeface="IBM Plex Sans JP" panose="020B0503050203000203" pitchFamily="50" charset="-128"/>
+              </a:rPr>
+              <a:t>と言う風に色に応じた最適なグラデーションを選ぶための項目。</a:t>
+            </a:r>
+          </a:p>
+          <a:p>
+            <a:pPr marL="171450" indent="-171450">
+              <a:buFont typeface="Arial" panose="020B0604020202020204" pitchFamily="34" charset="0"/>
+              <a:buChar char="•"/>
+            </a:pPr>
+            <a:r>
+              <a:rPr lang="ja-JP" altLang="ja-JP" sz="1000" dirty="0">
+                <a:latin typeface="IBM Plex Sans JP" panose="020B0503050203000203" pitchFamily="50" charset="-128"/>
+                <a:ea typeface="IBM Plex Sans JP" panose="020B0503050203000203" pitchFamily="50" charset="-128"/>
+              </a:rPr>
+              <a:t>サイクル数：グラデーションの頻度を変える数。サイクル数はフィラメントが</a:t>
+            </a:r>
+            <a:r>
+              <a:rPr lang="en-US" altLang="ja-JP" sz="1000" dirty="0">
+                <a:latin typeface="IBM Plex Sans JP" panose="020B0503050203000203" pitchFamily="50" charset="-128"/>
+                <a:ea typeface="IBM Plex Sans JP" panose="020B0503050203000203" pitchFamily="50" charset="-128"/>
+              </a:rPr>
+              <a:t>A</a:t>
+            </a:r>
+            <a:r>
+              <a:rPr lang="ja-JP" altLang="ja-JP" sz="1000" dirty="0">
+                <a:latin typeface="IBM Plex Sans JP" panose="020B0503050203000203" pitchFamily="50" charset="-128"/>
+                <a:ea typeface="IBM Plex Sans JP" panose="020B0503050203000203" pitchFamily="50" charset="-128"/>
+              </a:rPr>
+              <a:t>→</a:t>
+            </a:r>
+            <a:r>
+              <a:rPr lang="en-US" altLang="ja-JP" sz="1000" dirty="0">
+                <a:latin typeface="IBM Plex Sans JP" panose="020B0503050203000203" pitchFamily="50" charset="-128"/>
+                <a:ea typeface="IBM Plex Sans JP" panose="020B0503050203000203" pitchFamily="50" charset="-128"/>
+              </a:rPr>
+              <a:t>B</a:t>
+            </a:r>
+            <a:r>
+              <a:rPr lang="ja-JP" altLang="ja-JP" sz="1000" dirty="0">
+                <a:latin typeface="IBM Plex Sans JP" panose="020B0503050203000203" pitchFamily="50" charset="-128"/>
+                <a:ea typeface="IBM Plex Sans JP" panose="020B0503050203000203" pitchFamily="50" charset="-128"/>
+              </a:rPr>
+              <a:t>→</a:t>
+            </a:r>
+            <a:r>
+              <a:rPr lang="en-US" altLang="ja-JP" sz="1000" dirty="0">
+                <a:latin typeface="IBM Plex Sans JP" panose="020B0503050203000203" pitchFamily="50" charset="-128"/>
+                <a:ea typeface="IBM Plex Sans JP" panose="020B0503050203000203" pitchFamily="50" charset="-128"/>
+              </a:rPr>
+              <a:t>A</a:t>
+            </a:r>
+            <a:r>
+              <a:rPr lang="ja-JP" altLang="ja-JP" sz="1000" dirty="0">
+                <a:latin typeface="IBM Plex Sans JP" panose="020B0503050203000203" pitchFamily="50" charset="-128"/>
+                <a:ea typeface="IBM Plex Sans JP" panose="020B0503050203000203" pitchFamily="50" charset="-128"/>
+              </a:rPr>
+              <a:t>と変化して戻ることを</a:t>
+            </a:r>
+            <a:r>
+              <a:rPr lang="en-US" altLang="ja-JP" sz="1000" dirty="0">
+                <a:latin typeface="IBM Plex Sans JP" panose="020B0503050203000203" pitchFamily="50" charset="-128"/>
+                <a:ea typeface="IBM Plex Sans JP" panose="020B0503050203000203" pitchFamily="50" charset="-128"/>
+              </a:rPr>
+              <a:t>1</a:t>
+            </a:r>
+            <a:r>
+              <a:rPr lang="ja-JP" altLang="ja-JP" sz="1000" dirty="0">
+                <a:latin typeface="IBM Plex Sans JP" panose="020B0503050203000203" pitchFamily="50" charset="-128"/>
+                <a:ea typeface="IBM Plex Sans JP" panose="020B0503050203000203" pitchFamily="50" charset="-128"/>
+              </a:rPr>
+              <a:t>回と数える。</a:t>
+            </a:r>
+          </a:p>
+          <a:p>
+            <a:endParaRPr lang="ja-JP" altLang="ja-JP" sz="600" dirty="0">
               <a:latin typeface="IBM Plex Sans JP" panose="020B0503050203000203" pitchFamily="50" charset="-128"/>
               <a:ea typeface="IBM Plex Sans JP" panose="020B0503050203000203" pitchFamily="50" charset="-128"/>
             </a:endParaRPr>
           </a:p>
           <a:p>
             <a:r>
+              <a:rPr lang="ja-JP" altLang="ja-JP" sz="1000" dirty="0">
+                <a:latin typeface="IBM Plex Sans JP" panose="020B0503050203000203" pitchFamily="50" charset="-128"/>
+                <a:ea typeface="IBM Plex Sans JP" panose="020B0503050203000203" pitchFamily="50" charset="-128"/>
+              </a:rPr>
+              <a:t>以下はシアンとマゼンタの速い周期の</a:t>
+            </a:r>
+            <a:r>
               <a:rPr lang="en-US" altLang="ja-JP" sz="1000" dirty="0">
                 <a:latin typeface="IBM Plex Sans JP" panose="020B0503050203000203" pitchFamily="50" charset="-128"/>
                 <a:ea typeface="IBM Plex Sans JP" panose="020B0503050203000203" pitchFamily="50" charset="-128"/>
               </a:rPr>
-              <a:t>Example: To create a fast-cycle gradient filament using cyan and magenta, select an S4 Model, choose a 4-cycle Plate, and use the Vivid curve Profile due to the high color contrast.</a:t>
+              <a:t>Gradient Filament</a:t>
+            </a:r>
+            <a:r>
+              <a:rPr lang="ja-JP" altLang="ja-JP" sz="1000" dirty="0">
+                <a:latin typeface="IBM Plex Sans JP" panose="020B0503050203000203" pitchFamily="50" charset="-128"/>
+                <a:ea typeface="IBM Plex Sans JP" panose="020B0503050203000203" pitchFamily="50" charset="-128"/>
+              </a:rPr>
+              <a:t>を作る場合の例です。</a:t>
+            </a:r>
+          </a:p>
+          <a:p>
+            <a:r>
+              <a:rPr lang="ja-JP" altLang="ja-JP" sz="1000" dirty="0">
+                <a:latin typeface="IBM Plex Sans JP" panose="020B0503050203000203" pitchFamily="50" charset="-128"/>
+                <a:ea typeface="IBM Plex Sans JP" panose="020B0503050203000203" pitchFamily="50" charset="-128"/>
+              </a:rPr>
+              <a:t>周期はモデルサイズとサイクル数に影響されます。そのため、</a:t>
+            </a:r>
+            <a:r>
+              <a:rPr lang="en-US" altLang="ja-JP" sz="1000" dirty="0">
+                <a:latin typeface="IBM Plex Sans JP" panose="020B0503050203000203" pitchFamily="50" charset="-128"/>
+                <a:ea typeface="IBM Plex Sans JP" panose="020B0503050203000203" pitchFamily="50" charset="-128"/>
+              </a:rPr>
+              <a:t>S4</a:t>
+            </a:r>
+            <a:r>
+              <a:rPr lang="ja-JP" altLang="ja-JP" sz="1000" dirty="0">
+                <a:latin typeface="IBM Plex Sans JP" panose="020B0503050203000203" pitchFamily="50" charset="-128"/>
+                <a:ea typeface="IBM Plex Sans JP" panose="020B0503050203000203" pitchFamily="50" charset="-128"/>
+              </a:rPr>
+              <a:t>のモデルを選び、サイクル数は</a:t>
+            </a:r>
+            <a:r>
+              <a:rPr lang="en-US" altLang="ja-JP" sz="1000" dirty="0">
+                <a:latin typeface="IBM Plex Sans JP" panose="020B0503050203000203" pitchFamily="50" charset="-128"/>
+                <a:ea typeface="IBM Plex Sans JP" panose="020B0503050203000203" pitchFamily="50" charset="-128"/>
+              </a:rPr>
+              <a:t>4</a:t>
+            </a:r>
+            <a:r>
+              <a:rPr lang="ja-JP" altLang="ja-JP" sz="1000" dirty="0">
+                <a:latin typeface="IBM Plex Sans JP" panose="020B0503050203000203" pitchFamily="50" charset="-128"/>
+                <a:ea typeface="IBM Plex Sans JP" panose="020B0503050203000203" pitchFamily="50" charset="-128"/>
+              </a:rPr>
+              <a:t>サイクルを選ぶこととします。また、色相の離れた組合せなので</a:t>
+            </a:r>
+            <a:r>
+              <a:rPr lang="en-US" altLang="ja-JP" sz="1000" dirty="0">
+                <a:latin typeface="IBM Plex Sans JP" panose="020B0503050203000203" pitchFamily="50" charset="-128"/>
+                <a:ea typeface="IBM Plex Sans JP" panose="020B0503050203000203" pitchFamily="50" charset="-128"/>
+              </a:rPr>
+              <a:t>Vivid</a:t>
+            </a:r>
+            <a:r>
+              <a:rPr lang="ja-JP" altLang="ja-JP" sz="1000" dirty="0">
+                <a:latin typeface="IBM Plex Sans JP" panose="020B0503050203000203" pitchFamily="50" charset="-128"/>
+                <a:ea typeface="IBM Plex Sans JP" panose="020B0503050203000203" pitchFamily="50" charset="-128"/>
+              </a:rPr>
+              <a:t>カーブを選びます。</a:t>
             </a:r>
             <a:endParaRPr kumimoji="1" lang="ja-JP" altLang="en-US" sz="1000" b="1" dirty="0">
               <a:latin typeface="IBM Plex Sans JP" panose="020B0503050203000203" pitchFamily="50" charset="-128"/>
@@ -9803,10 +11324,10 @@
       </p:sp>
       <p:sp>
         <p:nvSpPr>
-          <p:cNvPr id="25" name="テキスト ボックス 24">
+          <p:cNvPr id="33" name="テキスト ボックス 32">
             <a:extLst>
               <a:ext uri="{FF2B5EF4-FFF2-40B4-BE49-F238E27FC236}">
-                <a16:creationId xmlns:a16="http://schemas.microsoft.com/office/drawing/2014/main" id="{7ED3E711-A061-E5B5-882E-75E8B78F5498}"/>
+                <a16:creationId xmlns:a16="http://schemas.microsoft.com/office/drawing/2014/main" id="{F2AEC5C2-C759-5468-B690-686B74E6A68E}"/>
               </a:ext>
             </a:extLst>
           </p:cNvPr>
@@ -9815,7 +11336,7 @@
         </p:nvSpPr>
         <p:spPr>
           <a:xfrm>
-            <a:off x="675778" y="2965281"/>
+            <a:off x="675778" y="3595963"/>
             <a:ext cx="5642222" cy="246221"/>
           </a:xfrm>
           <a:prstGeom prst="rect">
@@ -9830,21 +11351,39 @@
           <a:lstStyle/>
           <a:p>
             <a:r>
+              <a:rPr lang="ja-JP" altLang="ja-JP" sz="1000" dirty="0">
+                <a:latin typeface="IBM Plex Sans JP" panose="020B0503050203000203" pitchFamily="50" charset="-128"/>
+                <a:ea typeface="IBM Plex Sans JP" panose="020B0503050203000203" pitchFamily="50" charset="-128"/>
+              </a:rPr>
+              <a:t>以下は</a:t>
+            </a:r>
+            <a:r>
               <a:rPr lang="en-US" altLang="ja-JP" sz="1000" dirty="0">
                 <a:latin typeface="IBM Plex Sans JP" panose="020B0503050203000203" pitchFamily="50" charset="-128"/>
                 <a:ea typeface="IBM Plex Sans JP" panose="020B0503050203000203" pitchFamily="50" charset="-128"/>
               </a:rPr>
-              <a:t>The following is the model configuration for Gradient Filament.</a:t>
-            </a:r>
-          </a:p>
-        </p:txBody>
-      </p:sp>
-      <p:sp>
-        <p:nvSpPr>
-          <p:cNvPr id="5" name="テキスト ボックス 4">
+              <a:t>Gradient Filament</a:t>
+            </a:r>
+            <a:r>
+              <a:rPr lang="ja-JP" altLang="ja-JP" sz="1000" dirty="0">
+                <a:latin typeface="IBM Plex Sans JP" panose="020B0503050203000203" pitchFamily="50" charset="-128"/>
+                <a:ea typeface="IBM Plex Sans JP" panose="020B0503050203000203" pitchFamily="50" charset="-128"/>
+              </a:rPr>
+              <a:t>のモデル構成です。</a:t>
+            </a:r>
+            <a:endParaRPr lang="en-US" altLang="ja-JP" sz="1000" dirty="0">
+              <a:latin typeface="IBM Plex Sans JP" panose="020B0503050203000203" pitchFamily="50" charset="-128"/>
+              <a:ea typeface="IBM Plex Sans JP" panose="020B0503050203000203" pitchFamily="50" charset="-128"/>
+            </a:endParaRPr>
+          </a:p>
+        </p:txBody>
+      </p:sp>
+      <p:sp>
+        <p:nvSpPr>
+          <p:cNvPr id="34" name="テキスト ボックス 33">
             <a:extLst>
               <a:ext uri="{FF2B5EF4-FFF2-40B4-BE49-F238E27FC236}">
-                <a16:creationId xmlns:a16="http://schemas.microsoft.com/office/drawing/2014/main" id="{46940E87-7400-BF59-728F-D232492BBE36}"/>
+                <a16:creationId xmlns:a16="http://schemas.microsoft.com/office/drawing/2014/main" id="{5DD33A85-D920-6841-D122-FE5141E331ED}"/>
               </a:ext>
             </a:extLst>
           </p:cNvPr>
@@ -9853,7 +11392,7 @@
         </p:nvSpPr>
         <p:spPr>
           <a:xfrm>
-            <a:off x="778114" y="7268269"/>
+            <a:off x="778114" y="7829895"/>
             <a:ext cx="1923925" cy="338554"/>
           </a:xfrm>
           <a:prstGeom prst="rect">
@@ -9883,10 +11422,10 @@
       </p:sp>
       <p:sp>
         <p:nvSpPr>
-          <p:cNvPr id="6" name="テキスト ボックス 5">
+          <p:cNvPr id="35" name="テキスト ボックス 34">
             <a:extLst>
               <a:ext uri="{FF2B5EF4-FFF2-40B4-BE49-F238E27FC236}">
-                <a16:creationId xmlns:a16="http://schemas.microsoft.com/office/drawing/2014/main" id="{772E1925-419D-E6C3-9438-BD98D2BBDD58}"/>
+                <a16:creationId xmlns:a16="http://schemas.microsoft.com/office/drawing/2014/main" id="{21B2D047-2B66-EC11-16BD-6EF9E52897C1}"/>
               </a:ext>
             </a:extLst>
           </p:cNvPr>
@@ -9895,7 +11434,7 @@
         </p:nvSpPr>
         <p:spPr>
           <a:xfrm>
-            <a:off x="638323" y="7599215"/>
+            <a:off x="638323" y="8168461"/>
             <a:ext cx="5649491" cy="507831"/>
           </a:xfrm>
           <a:prstGeom prst="rect">
@@ -9936,10 +11475,40 @@
       </p:sp>
       <p:pic>
         <p:nvPicPr>
-          <p:cNvPr id="9" name="図 8">
+          <p:cNvPr id="36" name="図 35">
             <a:extLst>
               <a:ext uri="{FF2B5EF4-FFF2-40B4-BE49-F238E27FC236}">
-                <a16:creationId xmlns:a16="http://schemas.microsoft.com/office/drawing/2014/main" id="{0012A0F4-0BEF-52F9-839A-7754F15453D4}"/>
+                <a16:creationId xmlns:a16="http://schemas.microsoft.com/office/drawing/2014/main" id="{9B5CD66D-50B6-9A4B-62D7-0FE70CA37B9A}"/>
+              </a:ext>
+            </a:extLst>
+          </p:cNvPr>
+          <p:cNvPicPr>
+            <a:picLocks noChangeAspect="1"/>
+          </p:cNvPicPr>
+          <p:nvPr/>
+        </p:nvPicPr>
+        <p:blipFill>
+          <a:blip r:embed="rId2"/>
+          <a:stretch>
+            <a:fillRect/>
+          </a:stretch>
+        </p:blipFill>
+        <p:spPr>
+          <a:xfrm>
+            <a:off x="651740" y="2635456"/>
+            <a:ext cx="5588622" cy="913760"/>
+          </a:xfrm>
+          <a:prstGeom prst="rect">
+            <a:avLst/>
+          </a:prstGeom>
+        </p:spPr>
+      </p:pic>
+      <p:pic>
+        <p:nvPicPr>
+          <p:cNvPr id="3" name="図 2">
+            <a:extLst>
+              <a:ext uri="{FF2B5EF4-FFF2-40B4-BE49-F238E27FC236}">
+                <a16:creationId xmlns:a16="http://schemas.microsoft.com/office/drawing/2014/main" id="{C99C9AE4-68EC-C31D-2E72-FAFA9B860DFF}"/>
               </a:ext>
             </a:extLst>
           </p:cNvPr>
@@ -9956,7 +11525,7 @@
         </p:blipFill>
         <p:spPr>
           <a:xfrm>
-            <a:off x="666614" y="3276700"/>
+            <a:off x="673091" y="3861186"/>
             <a:ext cx="5521536" cy="3874587"/>
           </a:xfrm>
           <a:prstGeom prst="rect">
@@ -9967,7 +11536,7 @@
     </p:spTree>
     <p:extLst>
       <p:ext uri="{BB962C8B-B14F-4D97-AF65-F5344CB8AC3E}">
-        <p14:creationId xmlns:p14="http://schemas.microsoft.com/office/powerpoint/2010/main" val="3659034256"/>
+        <p14:creationId xmlns:p14="http://schemas.microsoft.com/office/powerpoint/2010/main" val="939485769"/>
       </p:ext>
     </p:extLst>
   </p:cSld>

</xml_diff>

<commit_message>
Tiour Guide jp updated
</commit_message>
<xml_diff>
--- a/Documents/Original/FlexChroma_Tour_Guide_JP.pptx
+++ b/Documents/Original/FlexChroma_Tour_Guide_JP.pptx
@@ -8877,7 +8877,7 @@
         </p:nvSpPr>
         <p:spPr>
           <a:xfrm>
-            <a:off x="661239" y="4511386"/>
+            <a:off x="661239" y="4538281"/>
             <a:ext cx="5649492" cy="553998"/>
           </a:xfrm>
           <a:prstGeom prst="rect">
@@ -9015,8 +9015,8 @@
         </p:nvSpPr>
         <p:spPr>
           <a:xfrm>
-            <a:off x="756306" y="6650049"/>
-            <a:ext cx="5554425" cy="1615827"/>
+            <a:off x="756306" y="6676943"/>
+            <a:ext cx="5554425" cy="1615829"/>
           </a:xfrm>
           <a:prstGeom prst="rect">
             <a:avLst/>
@@ -9376,8 +9376,8 @@
         </p:nvSpPr>
         <p:spPr>
           <a:xfrm>
-            <a:off x="656136" y="8285815"/>
-            <a:ext cx="5680304" cy="223138"/>
+            <a:off x="688410" y="8345835"/>
+            <a:ext cx="5680304" cy="167647"/>
           </a:xfrm>
           <a:prstGeom prst="rect">
             <a:avLst/>
@@ -9464,8 +9464,8 @@
         </p:blipFill>
         <p:spPr>
           <a:xfrm>
-            <a:off x="551490" y="4987005"/>
-            <a:ext cx="5759241" cy="1144558"/>
+            <a:off x="668508" y="4987005"/>
+            <a:ext cx="5478171" cy="1088700"/>
           </a:xfrm>
           <a:prstGeom prst="rect">
             <a:avLst/>
@@ -9973,43 +9973,6 @@
       </p:sp>
       <p:sp>
         <p:nvSpPr>
-          <p:cNvPr id="17" name="テキスト ボックス 16">
-            <a:extLst>
-              <a:ext uri="{FF2B5EF4-FFF2-40B4-BE49-F238E27FC236}">
-                <a16:creationId xmlns:a16="http://schemas.microsoft.com/office/drawing/2014/main" id="{166FC322-1D62-A69F-56DF-8F820EB033E3}"/>
-              </a:ext>
-            </a:extLst>
-          </p:cNvPr>
-          <p:cNvSpPr txBox="1"/>
-          <p:nvPr/>
-        </p:nvSpPr>
-        <p:spPr>
-          <a:xfrm>
-            <a:off x="3163826" y="8511531"/>
-            <a:ext cx="575734" cy="369332"/>
-          </a:xfrm>
-          <a:prstGeom prst="rect">
-            <a:avLst/>
-          </a:prstGeom>
-          <a:noFill/>
-        </p:spPr>
-        <p:txBody>
-          <a:bodyPr wrap="square" rtlCol="0" anchor="ctr">
-            <a:spAutoFit/>
-          </a:bodyPr>
-          <a:lstStyle/>
-          <a:p>
-            <a:pPr algn="ctr"/>
-            <a:r>
-              <a:rPr kumimoji="1" lang="en-US" altLang="ja-JP" dirty="0"/>
-              <a:t>2</a:t>
-            </a:r>
-            <a:endParaRPr kumimoji="1" lang="ja-JP" altLang="en-US" dirty="0"/>
-          </a:p>
-        </p:txBody>
-      </p:sp>
-      <p:sp>
-        <p:nvSpPr>
           <p:cNvPr id="3" name="テキスト ボックス 2">
             <a:extLst>
               <a:ext uri="{FF2B5EF4-FFF2-40B4-BE49-F238E27FC236}">
@@ -10064,7 +10027,7 @@
         </p:nvSpPr>
         <p:spPr>
           <a:xfrm>
-            <a:off x="668508" y="950188"/>
+            <a:off x="668508" y="966325"/>
             <a:ext cx="5649491" cy="553998"/>
           </a:xfrm>
           <a:prstGeom prst="rect">
@@ -10426,7 +10389,7 @@
         </p:nvSpPr>
         <p:spPr>
           <a:xfrm>
-            <a:off x="668508" y="5070646"/>
+            <a:off x="668508" y="5086783"/>
             <a:ext cx="5642222" cy="246221"/>
           </a:xfrm>
           <a:prstGeom prst="rect">
@@ -10493,7 +10456,7 @@
         </p:blipFill>
         <p:spPr bwMode="auto">
           <a:xfrm>
-            <a:off x="770844" y="5337242"/>
+            <a:off x="770844" y="5369516"/>
             <a:ext cx="5264196" cy="3270393"/>
           </a:xfrm>
           <a:prstGeom prst="rect">
@@ -10570,8 +10533,8 @@
         </p:blipFill>
         <p:spPr bwMode="auto">
           <a:xfrm>
-            <a:off x="1091915" y="1338219"/>
-            <a:ext cx="4561094" cy="1014727"/>
+            <a:off x="1254450" y="1387287"/>
+            <a:ext cx="4394485" cy="977661"/>
           </a:xfrm>
           <a:prstGeom prst="rect">
             <a:avLst/>
@@ -10588,6 +10551,43 @@
           </a:extLst>
         </p:spPr>
       </p:pic>
+      <p:sp>
+        <p:nvSpPr>
+          <p:cNvPr id="17" name="テキスト ボックス 16">
+            <a:extLst>
+              <a:ext uri="{FF2B5EF4-FFF2-40B4-BE49-F238E27FC236}">
+                <a16:creationId xmlns:a16="http://schemas.microsoft.com/office/drawing/2014/main" id="{166FC322-1D62-A69F-56DF-8F820EB033E3}"/>
+              </a:ext>
+            </a:extLst>
+          </p:cNvPr>
+          <p:cNvSpPr txBox="1"/>
+          <p:nvPr/>
+        </p:nvSpPr>
+        <p:spPr>
+          <a:xfrm>
+            <a:off x="3163826" y="8511531"/>
+            <a:ext cx="575734" cy="369332"/>
+          </a:xfrm>
+          <a:prstGeom prst="rect">
+            <a:avLst/>
+          </a:prstGeom>
+          <a:noFill/>
+        </p:spPr>
+        <p:txBody>
+          <a:bodyPr wrap="square" rtlCol="0" anchor="ctr">
+            <a:spAutoFit/>
+          </a:bodyPr>
+          <a:lstStyle/>
+          <a:p>
+            <a:pPr algn="ctr"/>
+            <a:r>
+              <a:rPr kumimoji="1" lang="en-US" altLang="ja-JP" dirty="0"/>
+              <a:t>2</a:t>
+            </a:r>
+            <a:endParaRPr kumimoji="1" lang="ja-JP" altLang="en-US" dirty="0"/>
+          </a:p>
+        </p:txBody>
+      </p:sp>
     </p:spTree>
     <p:extLst>
       <p:ext uri="{BB962C8B-B14F-4D97-AF65-F5344CB8AC3E}">
@@ -11032,7 +11032,7 @@
         </p:nvSpPr>
         <p:spPr>
           <a:xfrm>
-            <a:off x="770844" y="610017"/>
+            <a:off x="770844" y="599259"/>
             <a:ext cx="2739853" cy="400110"/>
           </a:xfrm>
           <a:prstGeom prst="rect">
@@ -11074,7 +11074,7 @@
         </p:nvSpPr>
         <p:spPr>
           <a:xfrm>
-            <a:off x="668508" y="1010097"/>
+            <a:off x="668508" y="977823"/>
             <a:ext cx="5649491" cy="1661993"/>
           </a:xfrm>
           <a:prstGeom prst="rect">
@@ -11336,7 +11336,7 @@
         </p:nvSpPr>
         <p:spPr>
           <a:xfrm>
-            <a:off x="675778" y="3595963"/>
+            <a:off x="675778" y="3681158"/>
             <a:ext cx="5642222" cy="246221"/>
           </a:xfrm>
           <a:prstGeom prst="rect">
@@ -11392,7 +11392,7 @@
         </p:nvSpPr>
         <p:spPr>
           <a:xfrm>
-            <a:off x="778114" y="7829895"/>
+            <a:off x="778114" y="7851411"/>
             <a:ext cx="1923925" cy="338554"/>
           </a:xfrm>
           <a:prstGeom prst="rect">
@@ -11434,7 +11434,7 @@
         </p:nvSpPr>
         <p:spPr>
           <a:xfrm>
-            <a:off x="638323" y="8168461"/>
+            <a:off x="638323" y="8189977"/>
             <a:ext cx="5649491" cy="507831"/>
           </a:xfrm>
           <a:prstGeom prst="rect">
@@ -11495,7 +11495,7 @@
         </p:blipFill>
         <p:spPr>
           <a:xfrm>
-            <a:off x="651740" y="2635456"/>
+            <a:off x="651740" y="2656972"/>
             <a:ext cx="5588622" cy="913760"/>
           </a:xfrm>
           <a:prstGeom prst="rect">
@@ -11525,7 +11525,7 @@
         </p:blipFill>
         <p:spPr>
           <a:xfrm>
-            <a:off x="673091" y="3861186"/>
+            <a:off x="673091" y="3947248"/>
             <a:ext cx="5521536" cy="3874587"/>
           </a:xfrm>
           <a:prstGeom prst="rect">

</xml_diff>

<commit_message>
fixed small mistake on tour guide
</commit_message>
<xml_diff>
--- a/Documents/Original/FlexChroma_Tour_Guide_JP.pptx
+++ b/Documents/Original/FlexChroma_Tour_Guide_JP.pptx
@@ -249,7 +249,7 @@
           <a:p>
             <a:fld id="{71132294-360C-4425-B294-91EF6E97A591}" type="datetimeFigureOut">
               <a:rPr kumimoji="1" lang="ja-JP" altLang="en-US" smtClean="0"/>
-              <a:t>2026/7/23</a:t>
+              <a:t>2026/7/24</a:t>
             </a:fld>
             <a:endParaRPr kumimoji="1" lang="ja-JP" altLang="en-US"/>
           </a:p>
@@ -451,7 +451,7 @@
           <a:p>
             <a:fld id="{71132294-360C-4425-B294-91EF6E97A591}" type="datetimeFigureOut">
               <a:rPr kumimoji="1" lang="ja-JP" altLang="en-US" smtClean="0"/>
-              <a:t>2026/7/23</a:t>
+              <a:t>2026/7/24</a:t>
             </a:fld>
             <a:endParaRPr kumimoji="1" lang="ja-JP" altLang="en-US"/>
           </a:p>
@@ -663,7 +663,7 @@
           <a:p>
             <a:fld id="{71132294-360C-4425-B294-91EF6E97A591}" type="datetimeFigureOut">
               <a:rPr kumimoji="1" lang="ja-JP" altLang="en-US" smtClean="0"/>
-              <a:t>2026/7/23</a:t>
+              <a:t>2026/7/24</a:t>
             </a:fld>
             <a:endParaRPr kumimoji="1" lang="ja-JP" altLang="en-US"/>
           </a:p>
@@ -865,7 +865,7 @@
           <a:p>
             <a:fld id="{71132294-360C-4425-B294-91EF6E97A591}" type="datetimeFigureOut">
               <a:rPr kumimoji="1" lang="ja-JP" altLang="en-US" smtClean="0"/>
-              <a:t>2026/7/23</a:t>
+              <a:t>2026/7/24</a:t>
             </a:fld>
             <a:endParaRPr kumimoji="1" lang="ja-JP" altLang="en-US"/>
           </a:p>
@@ -1111,7 +1111,7 @@
           <a:p>
             <a:fld id="{71132294-360C-4425-B294-91EF6E97A591}" type="datetimeFigureOut">
               <a:rPr kumimoji="1" lang="ja-JP" altLang="en-US" smtClean="0"/>
-              <a:t>2026/7/23</a:t>
+              <a:t>2026/7/24</a:t>
             </a:fld>
             <a:endParaRPr kumimoji="1" lang="ja-JP" altLang="en-US"/>
           </a:p>
@@ -1407,7 +1407,7 @@
           <a:p>
             <a:fld id="{71132294-360C-4425-B294-91EF6E97A591}" type="datetimeFigureOut">
               <a:rPr kumimoji="1" lang="ja-JP" altLang="en-US" smtClean="0"/>
-              <a:t>2026/7/23</a:t>
+              <a:t>2026/7/24</a:t>
             </a:fld>
             <a:endParaRPr kumimoji="1" lang="ja-JP" altLang="en-US"/>
           </a:p>
@@ -1838,7 +1838,7 @@
           <a:p>
             <a:fld id="{71132294-360C-4425-B294-91EF6E97A591}" type="datetimeFigureOut">
               <a:rPr kumimoji="1" lang="ja-JP" altLang="en-US" smtClean="0"/>
-              <a:t>2026/7/23</a:t>
+              <a:t>2026/7/24</a:t>
             </a:fld>
             <a:endParaRPr kumimoji="1" lang="ja-JP" altLang="en-US"/>
           </a:p>
@@ -1956,7 +1956,7 @@
           <a:p>
             <a:fld id="{71132294-360C-4425-B294-91EF6E97A591}" type="datetimeFigureOut">
               <a:rPr kumimoji="1" lang="ja-JP" altLang="en-US" smtClean="0"/>
-              <a:t>2026/7/23</a:t>
+              <a:t>2026/7/24</a:t>
             </a:fld>
             <a:endParaRPr kumimoji="1" lang="ja-JP" altLang="en-US"/>
           </a:p>
@@ -2051,7 +2051,7 @@
           <a:p>
             <a:fld id="{71132294-360C-4425-B294-91EF6E97A591}" type="datetimeFigureOut">
               <a:rPr kumimoji="1" lang="ja-JP" altLang="en-US" smtClean="0"/>
-              <a:t>2026/7/23</a:t>
+              <a:t>2026/7/24</a:t>
             </a:fld>
             <a:endParaRPr kumimoji="1" lang="ja-JP" altLang="en-US"/>
           </a:p>
@@ -2360,7 +2360,7 @@
           <a:p>
             <a:fld id="{71132294-360C-4425-B294-91EF6E97A591}" type="datetimeFigureOut">
               <a:rPr kumimoji="1" lang="ja-JP" altLang="en-US" smtClean="0"/>
-              <a:t>2026/7/23</a:t>
+              <a:t>2026/7/24</a:t>
             </a:fld>
             <a:endParaRPr kumimoji="1" lang="ja-JP" altLang="en-US"/>
           </a:p>
@@ -2617,7 +2617,7 @@
           <a:p>
             <a:fld id="{71132294-360C-4425-B294-91EF6E97A591}" type="datetimeFigureOut">
               <a:rPr kumimoji="1" lang="ja-JP" altLang="en-US" smtClean="0"/>
-              <a:t>2026/7/23</a:t>
+              <a:t>2026/7/24</a:t>
             </a:fld>
             <a:endParaRPr kumimoji="1" lang="ja-JP" altLang="en-US"/>
           </a:p>
@@ -2862,7 +2862,7 @@
           <a:p>
             <a:fld id="{71132294-360C-4425-B294-91EF6E97A591}" type="datetimeFigureOut">
               <a:rPr kumimoji="1" lang="ja-JP" altLang="en-US" smtClean="0"/>
-              <a:t>2026/7/23</a:t>
+              <a:t>2026/7/24</a:t>
             </a:fld>
             <a:endParaRPr kumimoji="1" lang="ja-JP" altLang="en-US"/>
           </a:p>
@@ -8138,8 +8138,8 @@
         </p:nvSpPr>
         <p:spPr>
           <a:xfrm>
-            <a:off x="0" y="0"/>
-            <a:ext cx="6858000" cy="9144000"/>
+            <a:off x="33951" y="45268"/>
+            <a:ext cx="6790099" cy="9053465"/>
           </a:xfrm>
           <a:prstGeom prst="rect">
             <a:avLst/>
@@ -9628,8 +9628,8 @@
         </p:nvSpPr>
         <p:spPr>
           <a:xfrm>
-            <a:off x="0" y="0"/>
-            <a:ext cx="6858000" cy="9144000"/>
+            <a:off x="33951" y="45268"/>
+            <a:ext cx="6790099" cy="9053465"/>
           </a:xfrm>
           <a:prstGeom prst="rect">
             <a:avLst/>

</xml_diff>